<commit_message>
Fix deck formatting: chip overflow, timeline alignment, card margins
- Slide 4: brand chips now sized to fit exactly within slide margins
- Slide 12: timeline date labels centred on their dots (removed edge clamping)
- Slide 10: logistics cards sized to fit within margins

Co-Authored-By: Claude Opus 4.8 <noreply@anthropic.com>
Claude-Session: https://claude.ai/code/session_01SPjFYHW1nTDVr5tUuToRXR
</commit_message>
<xml_diff>
--- a/doft_diwali_popup/Doft_Diwali_PopUp_ProMarcom_Pitch.pptx
+++ b/doft_diwali_popup/Doft_Diwali_PopUp_ProMarcom_Pitch.pptx
@@ -3213,7 +3213,7 @@
         <p:spPr>
           <a:xfrm>
             <a:off x="548640" y="2011680"/>
-            <a:ext cx="2514600" cy="2011680"/>
+            <a:ext cx="2430018" cy="2011680"/>
           </a:xfrm>
           <a:prstGeom prst="roundRect">
             <a:avLst>
@@ -3246,7 +3246,7 @@
         </p:nvSpPr>
         <p:spPr>
           <a:xfrm>
-            <a:off x="1531620" y="2286000"/>
+            <a:off x="1489329" y="2286000"/>
             <a:ext cx="548640" cy="548640"/>
           </a:xfrm>
           <a:prstGeom prst="ellipse">
@@ -3266,7 +3266,7 @@
         </p:nvSpPr>
         <p:spPr>
           <a:xfrm>
-            <a:off x="1531620" y="2286000"/>
+            <a:off x="1489329" y="2286000"/>
             <a:ext cx="548640" cy="548640"/>
           </a:xfrm>
           <a:prstGeom prst="rect">
@@ -3306,7 +3306,7 @@
         <p:spPr>
           <a:xfrm>
             <a:off x="685800" y="2971800"/>
-            <a:ext cx="2240280" cy="502920"/>
+            <a:ext cx="2155698" cy="502920"/>
           </a:xfrm>
           <a:prstGeom prst="rect">
             <a:avLst/>
@@ -3345,7 +3345,7 @@
         <p:spPr>
           <a:xfrm>
             <a:off x="731520" y="3429000"/>
-            <a:ext cx="2148840" cy="548640"/>
+            <a:ext cx="2064258" cy="548640"/>
           </a:xfrm>
           <a:prstGeom prst="rect">
             <a:avLst/>
@@ -3383,7 +3383,7 @@
         </p:nvSpPr>
         <p:spPr>
           <a:xfrm>
-            <a:off x="3081528" y="2697480"/>
+            <a:off x="2996946" y="2697480"/>
             <a:ext cx="420624" cy="548640"/>
           </a:xfrm>
           <a:prstGeom prst="rect">
@@ -3422,8 +3422,8 @@
         </p:nvSpPr>
         <p:spPr>
           <a:xfrm>
-            <a:off x="3520440" y="2011680"/>
-            <a:ext cx="2514600" cy="2011680"/>
+            <a:off x="3435858" y="2011680"/>
+            <a:ext cx="2430018" cy="2011680"/>
           </a:xfrm>
           <a:prstGeom prst="roundRect">
             <a:avLst>
@@ -3456,7 +3456,7 @@
         </p:nvSpPr>
         <p:spPr>
           <a:xfrm>
-            <a:off x="4503420" y="2286000"/>
+            <a:off x="4376547" y="2286000"/>
             <a:ext cx="548640" cy="548640"/>
           </a:xfrm>
           <a:prstGeom prst="ellipse">
@@ -3476,7 +3476,7 @@
         </p:nvSpPr>
         <p:spPr>
           <a:xfrm>
-            <a:off x="4503420" y="2286000"/>
+            <a:off x="4376547" y="2286000"/>
             <a:ext cx="548640" cy="548640"/>
           </a:xfrm>
           <a:prstGeom prst="rect">
@@ -3515,8 +3515,8 @@
         </p:nvSpPr>
         <p:spPr>
           <a:xfrm>
-            <a:off x="3657600" y="2971800"/>
-            <a:ext cx="2240280" cy="502920"/>
+            <a:off x="3573018" y="2971800"/>
+            <a:ext cx="2155698" cy="502920"/>
           </a:xfrm>
           <a:prstGeom prst="rect">
             <a:avLst/>
@@ -3554,8 +3554,8 @@
         </p:nvSpPr>
         <p:spPr>
           <a:xfrm>
-            <a:off x="3703320" y="3429000"/>
-            <a:ext cx="2148840" cy="548640"/>
+            <a:off x="3618738" y="3429000"/>
+            <a:ext cx="2064258" cy="548640"/>
           </a:xfrm>
           <a:prstGeom prst="rect">
             <a:avLst/>
@@ -3593,7 +3593,7 @@
         </p:nvSpPr>
         <p:spPr>
           <a:xfrm>
-            <a:off x="6053328" y="2697480"/>
+            <a:off x="5884164" y="2697480"/>
             <a:ext cx="420624" cy="548640"/>
           </a:xfrm>
           <a:prstGeom prst="rect">
@@ -3632,8 +3632,8 @@
         </p:nvSpPr>
         <p:spPr>
           <a:xfrm>
-            <a:off x="6492240" y="2011680"/>
-            <a:ext cx="2514600" cy="2011680"/>
+            <a:off x="6323076" y="2011680"/>
+            <a:ext cx="2430018" cy="2011680"/>
           </a:xfrm>
           <a:prstGeom prst="roundRect">
             <a:avLst>
@@ -3666,7 +3666,7 @@
         </p:nvSpPr>
         <p:spPr>
           <a:xfrm>
-            <a:off x="7475220" y="2286000"/>
+            <a:off x="7263765" y="2286000"/>
             <a:ext cx="548640" cy="548640"/>
           </a:xfrm>
           <a:prstGeom prst="ellipse">
@@ -3686,7 +3686,7 @@
         </p:nvSpPr>
         <p:spPr>
           <a:xfrm>
-            <a:off x="7475220" y="2286000"/>
+            <a:off x="7263765" y="2286000"/>
             <a:ext cx="548640" cy="548640"/>
           </a:xfrm>
           <a:prstGeom prst="rect">
@@ -3725,8 +3725,8 @@
         </p:nvSpPr>
         <p:spPr>
           <a:xfrm>
-            <a:off x="6629400" y="2971800"/>
-            <a:ext cx="2240280" cy="502920"/>
+            <a:off x="6460236" y="2971800"/>
+            <a:ext cx="2155698" cy="502920"/>
           </a:xfrm>
           <a:prstGeom prst="rect">
             <a:avLst/>
@@ -3764,8 +3764,8 @@
         </p:nvSpPr>
         <p:spPr>
           <a:xfrm>
-            <a:off x="6675120" y="3429000"/>
-            <a:ext cx="2148840" cy="548640"/>
+            <a:off x="6505956" y="3429000"/>
+            <a:ext cx="2064258" cy="548640"/>
           </a:xfrm>
           <a:prstGeom prst="rect">
             <a:avLst/>
@@ -3803,7 +3803,7 @@
         </p:nvSpPr>
         <p:spPr>
           <a:xfrm>
-            <a:off x="9025128" y="2697480"/>
+            <a:off x="8771382" y="2697480"/>
             <a:ext cx="420624" cy="548640"/>
           </a:xfrm>
           <a:prstGeom prst="rect">
@@ -3842,8 +3842,8 @@
         </p:nvSpPr>
         <p:spPr>
           <a:xfrm>
-            <a:off x="9464040" y="2011680"/>
-            <a:ext cx="2514600" cy="2011680"/>
+            <a:off x="9210294" y="2011680"/>
+            <a:ext cx="2430018" cy="2011680"/>
           </a:xfrm>
           <a:prstGeom prst="roundRect">
             <a:avLst>
@@ -3876,7 +3876,7 @@
         </p:nvSpPr>
         <p:spPr>
           <a:xfrm>
-            <a:off x="10447020" y="2286000"/>
+            <a:off x="10150983" y="2286000"/>
             <a:ext cx="548640" cy="548640"/>
           </a:xfrm>
           <a:prstGeom prst="ellipse">
@@ -3896,7 +3896,7 @@
         </p:nvSpPr>
         <p:spPr>
           <a:xfrm>
-            <a:off x="10447020" y="2286000"/>
+            <a:off x="10150983" y="2286000"/>
             <a:ext cx="548640" cy="548640"/>
           </a:xfrm>
           <a:prstGeom prst="rect">
@@ -3935,8 +3935,8 @@
         </p:nvSpPr>
         <p:spPr>
           <a:xfrm>
-            <a:off x="9601200" y="2971800"/>
-            <a:ext cx="2240280" cy="502920"/>
+            <a:off x="9347454" y="2971800"/>
+            <a:ext cx="2155698" cy="502920"/>
           </a:xfrm>
           <a:prstGeom prst="rect">
             <a:avLst/>
@@ -3974,8 +3974,8 @@
         </p:nvSpPr>
         <p:spPr>
           <a:xfrm>
-            <a:off x="9646920" y="3429000"/>
-            <a:ext cx="2148840" cy="548640"/>
+            <a:off x="9393174" y="3429000"/>
+            <a:ext cx="2064258" cy="548640"/>
           </a:xfrm>
           <a:prstGeom prst="rect">
             <a:avLst/>
@@ -5381,8 +5381,8 @@
         </p:nvSpPr>
         <p:spPr>
           <a:xfrm>
-            <a:off x="731520" y="3108960"/>
-            <a:ext cx="10725912" cy="0"/>
+            <a:off x="1325880" y="3108960"/>
+            <a:ext cx="9537192" cy="0"/>
           </a:xfrm>
           <a:prstGeom prst="line">
             <a:avLst/>
@@ -5398,33 +5398,13 @@
       </p:sp>
       <p:sp>
         <p:nvSpPr>
-          <p:cNvPr id="5" name="Shape 3"/>
-          <p:cNvSpPr/>
-          <p:nvPr/>
-        </p:nvSpPr>
-        <p:spPr>
-          <a:xfrm>
-            <a:off x="630936" y="3008376"/>
-            <a:ext cx="201168" cy="201168"/>
-          </a:xfrm>
-          <a:prstGeom prst="ellipse">
-            <a:avLst/>
-          </a:prstGeom>
-          <a:solidFill>
-            <a:srgbClr val="20182B"/>
-          </a:solidFill>
-          <a:ln/>
-        </p:spPr>
-      </p:sp>
-      <p:sp>
-        <p:nvSpPr>
-          <p:cNvPr id="6" name="Text 4"/>
-          <p:cNvSpPr/>
-          <p:nvPr/>
-        </p:nvSpPr>
-        <p:spPr>
-          <a:xfrm>
-            <a:off x="548640" y="1691640"/>
+          <p:cNvPr id="5" name="Text 3"/>
+          <p:cNvSpPr/>
+          <p:nvPr/>
+        </p:nvSpPr>
+        <p:spPr>
+          <a:xfrm>
+            <a:off x="548640" y="1737360"/>
             <a:ext cx="1554480" cy="274320"/>
           </a:xfrm>
           <a:prstGeom prst="rect">
@@ -5457,23 +5437,23 @@
       </p:sp>
       <p:sp>
         <p:nvSpPr>
-          <p:cNvPr id="7" name="Text 5"/>
-          <p:cNvSpPr/>
-          <p:nvPr/>
-        </p:nvSpPr>
-        <p:spPr>
-          <a:xfrm>
-            <a:off x="548640" y="1965960"/>
-            <a:ext cx="1554480" cy="640080"/>
-          </a:xfrm>
-          <a:prstGeom prst="rect">
-            <a:avLst/>
-          </a:prstGeom>
-          <a:noFill/>
-          <a:ln/>
-        </p:spPr>
-        <p:txBody>
-          <a:bodyPr wrap="square" lIns="0" tIns="0" rIns="0" bIns="0" rtlCol="0" anchor="t"/>
+          <p:cNvPr id="6" name="Text 4"/>
+          <p:cNvSpPr/>
+          <p:nvPr/>
+        </p:nvSpPr>
+        <p:spPr>
+          <a:xfrm>
+            <a:off x="548640" y="2029968"/>
+            <a:ext cx="1554480" cy="548640"/>
+          </a:xfrm>
+          <a:prstGeom prst="rect">
+            <a:avLst/>
+          </a:prstGeom>
+          <a:noFill/>
+          <a:ln/>
+        </p:spPr>
+        <p:txBody>
+          <a:bodyPr wrap="square" lIns="0" tIns="0" rIns="0" bIns="0" rtlCol="0" anchor="b"/>
           <a:lstStyle/>
           <a:p>
             <a:pPr algn="ctr" indent="0" marL="0">
@@ -5496,14 +5476,14 @@
       </p:sp>
       <p:sp>
         <p:nvSpPr>
-          <p:cNvPr id="8" name="Shape 6"/>
-          <p:cNvSpPr/>
-          <p:nvPr/>
-        </p:nvSpPr>
-        <p:spPr>
-          <a:xfrm>
-            <a:off x="731520" y="2606040"/>
-            <a:ext cx="0" cy="502920"/>
+          <p:cNvPr id="7" name="Shape 5"/>
+          <p:cNvSpPr/>
+          <p:nvPr/>
+        </p:nvSpPr>
+        <p:spPr>
+          <a:xfrm>
+            <a:off x="1325880" y="2578608"/>
+            <a:ext cx="0" cy="530352"/>
           </a:xfrm>
           <a:prstGeom prst="line">
             <a:avLst/>
@@ -5519,13 +5499,13 @@
       </p:sp>
       <p:sp>
         <p:nvSpPr>
-          <p:cNvPr id="9" name="Shape 7"/>
-          <p:cNvSpPr/>
-          <p:nvPr/>
-        </p:nvSpPr>
-        <p:spPr>
-          <a:xfrm>
-            <a:off x="2163209" y="3008376"/>
+          <p:cNvPr id="8" name="Shape 6"/>
+          <p:cNvSpPr/>
+          <p:nvPr/>
+        </p:nvSpPr>
+        <p:spPr>
+          <a:xfrm>
+            <a:off x="1225296" y="3008376"/>
             <a:ext cx="201168" cy="201168"/>
           </a:xfrm>
           <a:prstGeom prst="ellipse">
@@ -5539,13 +5519,13 @@
       </p:sp>
       <p:sp>
         <p:nvSpPr>
-          <p:cNvPr id="10" name="Text 8"/>
-          <p:cNvSpPr/>
-          <p:nvPr/>
-        </p:nvSpPr>
-        <p:spPr>
-          <a:xfrm>
-            <a:off x="1486553" y="3520440"/>
+          <p:cNvPr id="9" name="Text 7"/>
+          <p:cNvSpPr/>
+          <p:nvPr/>
+        </p:nvSpPr>
+        <p:spPr>
+          <a:xfrm>
+            <a:off x="1911096" y="3566160"/>
             <a:ext cx="1554480" cy="274320"/>
           </a:xfrm>
           <a:prstGeom prst="rect">
@@ -5578,14 +5558,14 @@
       </p:sp>
       <p:sp>
         <p:nvSpPr>
-          <p:cNvPr id="11" name="Text 9"/>
-          <p:cNvSpPr/>
-          <p:nvPr/>
-        </p:nvSpPr>
-        <p:spPr>
-          <a:xfrm>
-            <a:off x="1486553" y="3794760"/>
-            <a:ext cx="1554480" cy="640080"/>
+          <p:cNvPr id="10" name="Text 8"/>
+          <p:cNvSpPr/>
+          <p:nvPr/>
+        </p:nvSpPr>
+        <p:spPr>
+          <a:xfrm>
+            <a:off x="1911096" y="3858768"/>
+            <a:ext cx="1554480" cy="548640"/>
           </a:xfrm>
           <a:prstGeom prst="rect">
             <a:avLst/>
@@ -5617,14 +5597,14 @@
       </p:sp>
       <p:sp>
         <p:nvSpPr>
-          <p:cNvPr id="12" name="Shape 10"/>
-          <p:cNvSpPr/>
-          <p:nvPr/>
-        </p:nvSpPr>
-        <p:spPr>
-          <a:xfrm>
-            <a:off x="2263793" y="3108960"/>
-            <a:ext cx="0" cy="411480"/>
+          <p:cNvPr id="11" name="Shape 9"/>
+          <p:cNvSpPr/>
+          <p:nvPr/>
+        </p:nvSpPr>
+        <p:spPr>
+          <a:xfrm>
+            <a:off x="2688336" y="3108960"/>
+            <a:ext cx="0" cy="457200"/>
           </a:xfrm>
           <a:prstGeom prst="line">
             <a:avLst/>
@@ -5640,13 +5620,13 @@
       </p:sp>
       <p:sp>
         <p:nvSpPr>
-          <p:cNvPr id="13" name="Shape 11"/>
-          <p:cNvSpPr/>
-          <p:nvPr/>
-        </p:nvSpPr>
-        <p:spPr>
-          <a:xfrm>
-            <a:off x="3695482" y="3008376"/>
+          <p:cNvPr id="12" name="Shape 10"/>
+          <p:cNvSpPr/>
+          <p:nvPr/>
+        </p:nvSpPr>
+        <p:spPr>
+          <a:xfrm>
+            <a:off x="2587752" y="3008376"/>
             <a:ext cx="201168" cy="201168"/>
           </a:xfrm>
           <a:prstGeom prst="ellipse">
@@ -5660,13 +5640,13 @@
       </p:sp>
       <p:sp>
         <p:nvSpPr>
-          <p:cNvPr id="14" name="Text 12"/>
-          <p:cNvSpPr/>
-          <p:nvPr/>
-        </p:nvSpPr>
-        <p:spPr>
-          <a:xfrm>
-            <a:off x="3018826" y="1691640"/>
+          <p:cNvPr id="13" name="Text 11"/>
+          <p:cNvSpPr/>
+          <p:nvPr/>
+        </p:nvSpPr>
+        <p:spPr>
+          <a:xfrm>
+            <a:off x="3273552" y="1737360"/>
             <a:ext cx="1554480" cy="274320"/>
           </a:xfrm>
           <a:prstGeom prst="rect">
@@ -5699,23 +5679,23 @@
       </p:sp>
       <p:sp>
         <p:nvSpPr>
-          <p:cNvPr id="15" name="Text 13"/>
-          <p:cNvSpPr/>
-          <p:nvPr/>
-        </p:nvSpPr>
-        <p:spPr>
-          <a:xfrm>
-            <a:off x="3018826" y="1965960"/>
-            <a:ext cx="1554480" cy="640080"/>
-          </a:xfrm>
-          <a:prstGeom prst="rect">
-            <a:avLst/>
-          </a:prstGeom>
-          <a:noFill/>
-          <a:ln/>
-        </p:spPr>
-        <p:txBody>
-          <a:bodyPr wrap="square" lIns="0" tIns="0" rIns="0" bIns="0" rtlCol="0" anchor="t"/>
+          <p:cNvPr id="14" name="Text 12"/>
+          <p:cNvSpPr/>
+          <p:nvPr/>
+        </p:nvSpPr>
+        <p:spPr>
+          <a:xfrm>
+            <a:off x="3273552" y="2029968"/>
+            <a:ext cx="1554480" cy="548640"/>
+          </a:xfrm>
+          <a:prstGeom prst="rect">
+            <a:avLst/>
+          </a:prstGeom>
+          <a:noFill/>
+          <a:ln/>
+        </p:spPr>
+        <p:txBody>
+          <a:bodyPr wrap="square" lIns="0" tIns="0" rIns="0" bIns="0" rtlCol="0" anchor="b"/>
           <a:lstStyle/>
           <a:p>
             <a:pPr algn="ctr" indent="0" marL="0">
@@ -5738,14 +5718,14 @@
       </p:sp>
       <p:sp>
         <p:nvSpPr>
-          <p:cNvPr id="16" name="Shape 14"/>
-          <p:cNvSpPr/>
-          <p:nvPr/>
-        </p:nvSpPr>
-        <p:spPr>
-          <a:xfrm>
-            <a:off x="3796066" y="2606040"/>
-            <a:ext cx="0" cy="502920"/>
+          <p:cNvPr id="15" name="Shape 13"/>
+          <p:cNvSpPr/>
+          <p:nvPr/>
+        </p:nvSpPr>
+        <p:spPr>
+          <a:xfrm>
+            <a:off x="4050792" y="2578608"/>
+            <a:ext cx="0" cy="530352"/>
           </a:xfrm>
           <a:prstGeom prst="line">
             <a:avLst/>
@@ -5761,13 +5741,13 @@
       </p:sp>
       <p:sp>
         <p:nvSpPr>
-          <p:cNvPr id="17" name="Shape 15"/>
-          <p:cNvSpPr/>
-          <p:nvPr/>
-        </p:nvSpPr>
-        <p:spPr>
-          <a:xfrm>
-            <a:off x="5227755" y="3008376"/>
+          <p:cNvPr id="16" name="Shape 14"/>
+          <p:cNvSpPr/>
+          <p:nvPr/>
+        </p:nvSpPr>
+        <p:spPr>
+          <a:xfrm>
+            <a:off x="3950208" y="3008376"/>
             <a:ext cx="201168" cy="201168"/>
           </a:xfrm>
           <a:prstGeom prst="ellipse">
@@ -5781,13 +5761,13 @@
       </p:sp>
       <p:sp>
         <p:nvSpPr>
-          <p:cNvPr id="18" name="Text 16"/>
-          <p:cNvSpPr/>
-          <p:nvPr/>
-        </p:nvSpPr>
-        <p:spPr>
-          <a:xfrm>
-            <a:off x="4551099" y="3520440"/>
+          <p:cNvPr id="17" name="Text 15"/>
+          <p:cNvSpPr/>
+          <p:nvPr/>
+        </p:nvSpPr>
+        <p:spPr>
+          <a:xfrm>
+            <a:off x="4636008" y="3566160"/>
             <a:ext cx="1554480" cy="274320"/>
           </a:xfrm>
           <a:prstGeom prst="rect">
@@ -5820,14 +5800,14 @@
       </p:sp>
       <p:sp>
         <p:nvSpPr>
-          <p:cNvPr id="19" name="Text 17"/>
-          <p:cNvSpPr/>
-          <p:nvPr/>
-        </p:nvSpPr>
-        <p:spPr>
-          <a:xfrm>
-            <a:off x="4551099" y="3794760"/>
-            <a:ext cx="1554480" cy="640080"/>
+          <p:cNvPr id="18" name="Text 16"/>
+          <p:cNvSpPr/>
+          <p:nvPr/>
+        </p:nvSpPr>
+        <p:spPr>
+          <a:xfrm>
+            <a:off x="4636008" y="3858768"/>
+            <a:ext cx="1554480" cy="548640"/>
           </a:xfrm>
           <a:prstGeom prst="rect">
             <a:avLst/>
@@ -5859,14 +5839,14 @@
       </p:sp>
       <p:sp>
         <p:nvSpPr>
-          <p:cNvPr id="20" name="Shape 18"/>
-          <p:cNvSpPr/>
-          <p:nvPr/>
-        </p:nvSpPr>
-        <p:spPr>
-          <a:xfrm>
-            <a:off x="5328339" y="3108960"/>
-            <a:ext cx="0" cy="411480"/>
+          <p:cNvPr id="19" name="Shape 17"/>
+          <p:cNvSpPr/>
+          <p:nvPr/>
+        </p:nvSpPr>
+        <p:spPr>
+          <a:xfrm>
+            <a:off x="5413248" y="3108960"/>
+            <a:ext cx="0" cy="457200"/>
           </a:xfrm>
           <a:prstGeom prst="line">
             <a:avLst/>
@@ -5882,13 +5862,13 @@
       </p:sp>
       <p:sp>
         <p:nvSpPr>
-          <p:cNvPr id="21" name="Shape 19"/>
-          <p:cNvSpPr/>
-          <p:nvPr/>
-        </p:nvSpPr>
-        <p:spPr>
-          <a:xfrm>
-            <a:off x="6760029" y="3008376"/>
+          <p:cNvPr id="20" name="Shape 18"/>
+          <p:cNvSpPr/>
+          <p:nvPr/>
+        </p:nvSpPr>
+        <p:spPr>
+          <a:xfrm>
+            <a:off x="5312664" y="3008376"/>
             <a:ext cx="201168" cy="201168"/>
           </a:xfrm>
           <a:prstGeom prst="ellipse">
@@ -5902,13 +5882,13 @@
       </p:sp>
       <p:sp>
         <p:nvSpPr>
-          <p:cNvPr id="22" name="Text 20"/>
-          <p:cNvSpPr/>
-          <p:nvPr/>
-        </p:nvSpPr>
-        <p:spPr>
-          <a:xfrm>
-            <a:off x="6083373" y="1691640"/>
+          <p:cNvPr id="21" name="Text 19"/>
+          <p:cNvSpPr/>
+          <p:nvPr/>
+        </p:nvSpPr>
+        <p:spPr>
+          <a:xfrm>
+            <a:off x="5998464" y="1737360"/>
             <a:ext cx="1554480" cy="274320"/>
           </a:xfrm>
           <a:prstGeom prst="rect">
@@ -5941,23 +5921,23 @@
       </p:sp>
       <p:sp>
         <p:nvSpPr>
-          <p:cNvPr id="23" name="Text 21"/>
-          <p:cNvSpPr/>
-          <p:nvPr/>
-        </p:nvSpPr>
-        <p:spPr>
-          <a:xfrm>
-            <a:off x="6083373" y="1965960"/>
-            <a:ext cx="1554480" cy="640080"/>
-          </a:xfrm>
-          <a:prstGeom prst="rect">
-            <a:avLst/>
-          </a:prstGeom>
-          <a:noFill/>
-          <a:ln/>
-        </p:spPr>
-        <p:txBody>
-          <a:bodyPr wrap="square" lIns="0" tIns="0" rIns="0" bIns="0" rtlCol="0" anchor="t"/>
+          <p:cNvPr id="22" name="Text 20"/>
+          <p:cNvSpPr/>
+          <p:nvPr/>
+        </p:nvSpPr>
+        <p:spPr>
+          <a:xfrm>
+            <a:off x="5998464" y="2029968"/>
+            <a:ext cx="1554480" cy="548640"/>
+          </a:xfrm>
+          <a:prstGeom prst="rect">
+            <a:avLst/>
+          </a:prstGeom>
+          <a:noFill/>
+          <a:ln/>
+        </p:spPr>
+        <p:txBody>
+          <a:bodyPr wrap="square" lIns="0" tIns="0" rIns="0" bIns="0" rtlCol="0" anchor="b"/>
           <a:lstStyle/>
           <a:p>
             <a:pPr algn="ctr" indent="0" marL="0">
@@ -5980,14 +5960,14 @@
       </p:sp>
       <p:sp>
         <p:nvSpPr>
-          <p:cNvPr id="24" name="Shape 22"/>
-          <p:cNvSpPr/>
-          <p:nvPr/>
-        </p:nvSpPr>
-        <p:spPr>
-          <a:xfrm>
-            <a:off x="6860613" y="2606040"/>
-            <a:ext cx="0" cy="502920"/>
+          <p:cNvPr id="23" name="Shape 21"/>
+          <p:cNvSpPr/>
+          <p:nvPr/>
+        </p:nvSpPr>
+        <p:spPr>
+          <a:xfrm>
+            <a:off x="6775704" y="2578608"/>
+            <a:ext cx="0" cy="530352"/>
           </a:xfrm>
           <a:prstGeom prst="line">
             <a:avLst/>
@@ -6003,13 +5983,13 @@
       </p:sp>
       <p:sp>
         <p:nvSpPr>
-          <p:cNvPr id="25" name="Shape 23"/>
-          <p:cNvSpPr/>
-          <p:nvPr/>
-        </p:nvSpPr>
-        <p:spPr>
-          <a:xfrm>
-            <a:off x="8292302" y="3008376"/>
+          <p:cNvPr id="24" name="Shape 22"/>
+          <p:cNvSpPr/>
+          <p:nvPr/>
+        </p:nvSpPr>
+        <p:spPr>
+          <a:xfrm>
+            <a:off x="6675120" y="3008376"/>
             <a:ext cx="201168" cy="201168"/>
           </a:xfrm>
           <a:prstGeom prst="ellipse">
@@ -6023,13 +6003,13 @@
       </p:sp>
       <p:sp>
         <p:nvSpPr>
-          <p:cNvPr id="26" name="Text 24"/>
-          <p:cNvSpPr/>
-          <p:nvPr/>
-        </p:nvSpPr>
-        <p:spPr>
-          <a:xfrm>
-            <a:off x="7615646" y="3520440"/>
+          <p:cNvPr id="25" name="Text 23"/>
+          <p:cNvSpPr/>
+          <p:nvPr/>
+        </p:nvSpPr>
+        <p:spPr>
+          <a:xfrm>
+            <a:off x="7360920" y="3566160"/>
             <a:ext cx="1554480" cy="274320"/>
           </a:xfrm>
           <a:prstGeom prst="rect">
@@ -6062,14 +6042,14 @@
       </p:sp>
       <p:sp>
         <p:nvSpPr>
-          <p:cNvPr id="27" name="Text 25"/>
-          <p:cNvSpPr/>
-          <p:nvPr/>
-        </p:nvSpPr>
-        <p:spPr>
-          <a:xfrm>
-            <a:off x="7615646" y="3794760"/>
-            <a:ext cx="1554480" cy="640080"/>
+          <p:cNvPr id="26" name="Text 24"/>
+          <p:cNvSpPr/>
+          <p:nvPr/>
+        </p:nvSpPr>
+        <p:spPr>
+          <a:xfrm>
+            <a:off x="7360920" y="3858768"/>
+            <a:ext cx="1554480" cy="548640"/>
           </a:xfrm>
           <a:prstGeom prst="rect">
             <a:avLst/>
@@ -6101,14 +6081,14 @@
       </p:sp>
       <p:sp>
         <p:nvSpPr>
-          <p:cNvPr id="28" name="Shape 26"/>
-          <p:cNvSpPr/>
-          <p:nvPr/>
-        </p:nvSpPr>
-        <p:spPr>
-          <a:xfrm>
-            <a:off x="8392886" y="3108960"/>
-            <a:ext cx="0" cy="411480"/>
+          <p:cNvPr id="27" name="Shape 25"/>
+          <p:cNvSpPr/>
+          <p:nvPr/>
+        </p:nvSpPr>
+        <p:spPr>
+          <a:xfrm>
+            <a:off x="8138160" y="3108960"/>
+            <a:ext cx="0" cy="457200"/>
           </a:xfrm>
           <a:prstGeom prst="line">
             <a:avLst/>
@@ -6124,13 +6104,13 @@
       </p:sp>
       <p:sp>
         <p:nvSpPr>
-          <p:cNvPr id="29" name="Shape 27"/>
-          <p:cNvSpPr/>
-          <p:nvPr/>
-        </p:nvSpPr>
-        <p:spPr>
-          <a:xfrm>
-            <a:off x="9824575" y="3008376"/>
+          <p:cNvPr id="28" name="Shape 26"/>
+          <p:cNvSpPr/>
+          <p:nvPr/>
+        </p:nvSpPr>
+        <p:spPr>
+          <a:xfrm>
+            <a:off x="8037576" y="3008376"/>
             <a:ext cx="201168" cy="201168"/>
           </a:xfrm>
           <a:prstGeom prst="ellipse">
@@ -6144,13 +6124,13 @@
       </p:sp>
       <p:sp>
         <p:nvSpPr>
-          <p:cNvPr id="30" name="Text 28"/>
-          <p:cNvSpPr/>
-          <p:nvPr/>
-        </p:nvSpPr>
-        <p:spPr>
-          <a:xfrm>
-            <a:off x="9147919" y="1691640"/>
+          <p:cNvPr id="29" name="Text 27"/>
+          <p:cNvSpPr/>
+          <p:nvPr/>
+        </p:nvSpPr>
+        <p:spPr>
+          <a:xfrm>
+            <a:off x="8723376" y="1737360"/>
             <a:ext cx="1554480" cy="274320"/>
           </a:xfrm>
           <a:prstGeom prst="rect">
@@ -6183,23 +6163,23 @@
       </p:sp>
       <p:sp>
         <p:nvSpPr>
-          <p:cNvPr id="31" name="Text 29"/>
-          <p:cNvSpPr/>
-          <p:nvPr/>
-        </p:nvSpPr>
-        <p:spPr>
-          <a:xfrm>
-            <a:off x="9147919" y="1965960"/>
-            <a:ext cx="1554480" cy="640080"/>
-          </a:xfrm>
-          <a:prstGeom prst="rect">
-            <a:avLst/>
-          </a:prstGeom>
-          <a:noFill/>
-          <a:ln/>
-        </p:spPr>
-        <p:txBody>
-          <a:bodyPr wrap="square" lIns="0" tIns="0" rIns="0" bIns="0" rtlCol="0" anchor="t"/>
+          <p:cNvPr id="30" name="Text 28"/>
+          <p:cNvSpPr/>
+          <p:nvPr/>
+        </p:nvSpPr>
+        <p:spPr>
+          <a:xfrm>
+            <a:off x="8723376" y="2029968"/>
+            <a:ext cx="1554480" cy="548640"/>
+          </a:xfrm>
+          <a:prstGeom prst="rect">
+            <a:avLst/>
+          </a:prstGeom>
+          <a:noFill/>
+          <a:ln/>
+        </p:spPr>
+        <p:txBody>
+          <a:bodyPr wrap="square" lIns="0" tIns="0" rIns="0" bIns="0" rtlCol="0" anchor="b"/>
           <a:lstStyle/>
           <a:p>
             <a:pPr algn="ctr" indent="0" marL="0">
@@ -6222,14 +6202,14 @@
       </p:sp>
       <p:sp>
         <p:nvSpPr>
-          <p:cNvPr id="32" name="Shape 30"/>
-          <p:cNvSpPr/>
-          <p:nvPr/>
-        </p:nvSpPr>
-        <p:spPr>
-          <a:xfrm>
-            <a:off x="9925159" y="2606040"/>
-            <a:ext cx="0" cy="502920"/>
+          <p:cNvPr id="31" name="Shape 29"/>
+          <p:cNvSpPr/>
+          <p:nvPr/>
+        </p:nvSpPr>
+        <p:spPr>
+          <a:xfrm>
+            <a:off x="9500616" y="2578608"/>
+            <a:ext cx="0" cy="530352"/>
           </a:xfrm>
           <a:prstGeom prst="line">
             <a:avLst/>
@@ -6245,13 +6225,13 @@
       </p:sp>
       <p:sp>
         <p:nvSpPr>
-          <p:cNvPr id="33" name="Shape 31"/>
-          <p:cNvSpPr/>
-          <p:nvPr/>
-        </p:nvSpPr>
-        <p:spPr>
-          <a:xfrm>
-            <a:off x="11356848" y="3008376"/>
+          <p:cNvPr id="32" name="Shape 30"/>
+          <p:cNvSpPr/>
+          <p:nvPr/>
+        </p:nvSpPr>
+        <p:spPr>
+          <a:xfrm>
+            <a:off x="9400032" y="3008376"/>
             <a:ext cx="201168" cy="201168"/>
           </a:xfrm>
           <a:prstGeom prst="ellipse">
@@ -6265,13 +6245,13 @@
       </p:sp>
       <p:sp>
         <p:nvSpPr>
-          <p:cNvPr id="34" name="Text 32"/>
-          <p:cNvSpPr/>
-          <p:nvPr/>
-        </p:nvSpPr>
-        <p:spPr>
-          <a:xfrm>
-            <a:off x="10085832" y="3520440"/>
+          <p:cNvPr id="33" name="Text 31"/>
+          <p:cNvSpPr/>
+          <p:nvPr/>
+        </p:nvSpPr>
+        <p:spPr>
+          <a:xfrm>
+            <a:off x="10085832" y="3566160"/>
             <a:ext cx="1554480" cy="274320"/>
           </a:xfrm>
           <a:prstGeom prst="rect">
@@ -6304,14 +6284,14 @@
       </p:sp>
       <p:sp>
         <p:nvSpPr>
-          <p:cNvPr id="35" name="Text 33"/>
-          <p:cNvSpPr/>
-          <p:nvPr/>
-        </p:nvSpPr>
-        <p:spPr>
-          <a:xfrm>
-            <a:off x="10085832" y="3794760"/>
-            <a:ext cx="1554480" cy="640080"/>
+          <p:cNvPr id="34" name="Text 32"/>
+          <p:cNvSpPr/>
+          <p:nvPr/>
+        </p:nvSpPr>
+        <p:spPr>
+          <a:xfrm>
+            <a:off x="10085832" y="3858768"/>
+            <a:ext cx="1554480" cy="548640"/>
           </a:xfrm>
           <a:prstGeom prst="rect">
             <a:avLst/>
@@ -6343,14 +6323,14 @@
       </p:sp>
       <p:sp>
         <p:nvSpPr>
-          <p:cNvPr id="36" name="Shape 34"/>
-          <p:cNvSpPr/>
-          <p:nvPr/>
-        </p:nvSpPr>
-        <p:spPr>
-          <a:xfrm>
-            <a:off x="11457432" y="3108960"/>
-            <a:ext cx="0" cy="411480"/>
+          <p:cNvPr id="35" name="Shape 33"/>
+          <p:cNvSpPr/>
+          <p:nvPr/>
+        </p:nvSpPr>
+        <p:spPr>
+          <a:xfrm>
+            <a:off x="10863072" y="3108960"/>
+            <a:ext cx="0" cy="457200"/>
           </a:xfrm>
           <a:prstGeom prst="line">
             <a:avLst/>
@@ -6362,6 +6342,26 @@
             </a:solidFill>
             <a:prstDash val="solid"/>
           </a:ln>
+        </p:spPr>
+      </p:sp>
+      <p:sp>
+        <p:nvSpPr>
+          <p:cNvPr id="36" name="Shape 34"/>
+          <p:cNvSpPr/>
+          <p:nvPr/>
+        </p:nvSpPr>
+        <p:spPr>
+          <a:xfrm>
+            <a:off x="10762488" y="3008376"/>
+            <a:ext cx="201168" cy="201168"/>
+          </a:xfrm>
+          <a:prstGeom prst="ellipse">
+            <a:avLst/>
+          </a:prstGeom>
+          <a:solidFill>
+            <a:srgbClr val="20182B"/>
+          </a:solidFill>
+          <a:ln/>
         </p:spPr>
       </p:sp>
       <p:sp>
@@ -13746,12 +13746,12 @@
         </p:nvSpPr>
         <p:spPr>
           <a:xfrm>
-            <a:off x="548640" y="4023360"/>
-            <a:ext cx="1828800" cy="502920"/>
+            <a:off x="548640" y="4069080"/>
+            <a:ext cx="1696212" cy="548640"/>
           </a:xfrm>
           <a:prstGeom prst="roundRect">
             <a:avLst>
-              <a:gd name="adj" fmla="val 10909"/>
+              <a:gd name="adj" fmla="val 10000"/>
             </a:avLst>
           </a:prstGeom>
           <a:solidFill>
@@ -13773,8 +13773,8 @@
         </p:nvSpPr>
         <p:spPr>
           <a:xfrm>
-            <a:off x="548640" y="4023360"/>
-            <a:ext cx="1828800" cy="502920"/>
+            <a:off x="594360" y="4069080"/>
+            <a:ext cx="1604772" cy="548640"/>
           </a:xfrm>
           <a:prstGeom prst="rect">
             <a:avLst/>
@@ -13790,7 +13790,7 @@
               <a:buNone/>
             </a:pPr>
             <a:r>
-              <a:rPr lang="en-US" sz="1250" b="1" dirty="0">
+              <a:rPr lang="en-US" sz="1200" b="1" dirty="0">
                 <a:solidFill>
                   <a:srgbClr val="20182B"/>
                 </a:solidFill>
@@ -13800,7 +13800,7 @@
               </a:rPr>
               <a:t>LG</a:t>
             </a:r>
-            <a:endParaRPr lang="en-US" sz="1250" dirty="0"/>
+            <a:endParaRPr lang="en-US" sz="1200" dirty="0"/>
           </a:p>
         </p:txBody>
       </p:sp>
@@ -13812,12 +13812,12 @@
         </p:nvSpPr>
         <p:spPr>
           <a:xfrm>
-            <a:off x="2542032" y="4023360"/>
-            <a:ext cx="1828800" cy="502920"/>
+            <a:off x="2427732" y="4069080"/>
+            <a:ext cx="1696212" cy="548640"/>
           </a:xfrm>
           <a:prstGeom prst="roundRect">
             <a:avLst>
-              <a:gd name="adj" fmla="val 10909"/>
+              <a:gd name="adj" fmla="val 10000"/>
             </a:avLst>
           </a:prstGeom>
           <a:solidFill>
@@ -13839,8 +13839,8 @@
         </p:nvSpPr>
         <p:spPr>
           <a:xfrm>
-            <a:off x="2542032" y="4023360"/>
-            <a:ext cx="1828800" cy="502920"/>
+            <a:off x="2473452" y="4069080"/>
+            <a:ext cx="1604772" cy="548640"/>
           </a:xfrm>
           <a:prstGeom prst="rect">
             <a:avLst/>
@@ -13856,7 +13856,7 @@
               <a:buNone/>
             </a:pPr>
             <a:r>
-              <a:rPr lang="en-US" sz="1250" b="1" dirty="0">
+              <a:rPr lang="en-US" sz="1200" b="1" dirty="0">
                 <a:solidFill>
                   <a:srgbClr val="20182B"/>
                 </a:solidFill>
@@ -13866,7 +13866,7 @@
               </a:rPr>
               <a:t>Samsung</a:t>
             </a:r>
-            <a:endParaRPr lang="en-US" sz="1250" dirty="0"/>
+            <a:endParaRPr lang="en-US" sz="1200" dirty="0"/>
           </a:p>
         </p:txBody>
       </p:sp>
@@ -13878,12 +13878,12 @@
         </p:nvSpPr>
         <p:spPr>
           <a:xfrm>
-            <a:off x="4535424" y="4023360"/>
-            <a:ext cx="1828800" cy="502920"/>
+            <a:off x="4306824" y="4069080"/>
+            <a:ext cx="1696212" cy="548640"/>
           </a:xfrm>
           <a:prstGeom prst="roundRect">
             <a:avLst>
-              <a:gd name="adj" fmla="val 10909"/>
+              <a:gd name="adj" fmla="val 10000"/>
             </a:avLst>
           </a:prstGeom>
           <a:solidFill>
@@ -13905,8 +13905,8 @@
         </p:nvSpPr>
         <p:spPr>
           <a:xfrm>
-            <a:off x="4535424" y="4023360"/>
-            <a:ext cx="1828800" cy="502920"/>
+            <a:off x="4352544" y="4069080"/>
+            <a:ext cx="1604772" cy="548640"/>
           </a:xfrm>
           <a:prstGeom prst="rect">
             <a:avLst/>
@@ -13922,7 +13922,7 @@
               <a:buNone/>
             </a:pPr>
             <a:r>
-              <a:rPr lang="en-US" sz="1250" b="1" dirty="0">
+              <a:rPr lang="en-US" sz="1200" b="1" dirty="0">
                 <a:solidFill>
                   <a:srgbClr val="20182B"/>
                 </a:solidFill>
@@ -13932,7 +13932,7 @@
               </a:rPr>
               <a:t>Hewlett-Packard</a:t>
             </a:r>
-            <a:endParaRPr lang="en-US" sz="1250" dirty="0"/>
+            <a:endParaRPr lang="en-US" sz="1200" dirty="0"/>
           </a:p>
         </p:txBody>
       </p:sp>
@@ -13944,12 +13944,12 @@
         </p:nvSpPr>
         <p:spPr>
           <a:xfrm>
-            <a:off x="6528816" y="4023360"/>
-            <a:ext cx="1828800" cy="502920"/>
+            <a:off x="6185916" y="4069080"/>
+            <a:ext cx="1696212" cy="548640"/>
           </a:xfrm>
           <a:prstGeom prst="roundRect">
             <a:avLst>
-              <a:gd name="adj" fmla="val 10909"/>
+              <a:gd name="adj" fmla="val 10000"/>
             </a:avLst>
           </a:prstGeom>
           <a:solidFill>
@@ -13971,8 +13971,8 @@
         </p:nvSpPr>
         <p:spPr>
           <a:xfrm>
-            <a:off x="6528816" y="4023360"/>
-            <a:ext cx="1828800" cy="502920"/>
+            <a:off x="6231636" y="4069080"/>
+            <a:ext cx="1604772" cy="548640"/>
           </a:xfrm>
           <a:prstGeom prst="rect">
             <a:avLst/>
@@ -13988,7 +13988,7 @@
               <a:buNone/>
             </a:pPr>
             <a:r>
-              <a:rPr lang="en-US" sz="1250" b="1" dirty="0">
+              <a:rPr lang="en-US" sz="1200" b="1" dirty="0">
                 <a:solidFill>
                   <a:srgbClr val="20182B"/>
                 </a:solidFill>
@@ -13998,7 +13998,7 @@
               </a:rPr>
               <a:t>Bajaj</a:t>
             </a:r>
-            <a:endParaRPr lang="en-US" sz="1250" dirty="0"/>
+            <a:endParaRPr lang="en-US" sz="1200" dirty="0"/>
           </a:p>
         </p:txBody>
       </p:sp>
@@ -14010,12 +14010,12 @@
         </p:nvSpPr>
         <p:spPr>
           <a:xfrm>
-            <a:off x="8522208" y="4023360"/>
-            <a:ext cx="1828800" cy="502920"/>
+            <a:off x="8065008" y="4069080"/>
+            <a:ext cx="1696212" cy="548640"/>
           </a:xfrm>
           <a:prstGeom prst="roundRect">
             <a:avLst>
-              <a:gd name="adj" fmla="val 10909"/>
+              <a:gd name="adj" fmla="val 10000"/>
             </a:avLst>
           </a:prstGeom>
           <a:solidFill>
@@ -14037,8 +14037,8 @@
         </p:nvSpPr>
         <p:spPr>
           <a:xfrm>
-            <a:off x="8522208" y="4023360"/>
-            <a:ext cx="1828800" cy="502920"/>
+            <a:off x="8110728" y="4069080"/>
+            <a:ext cx="1604772" cy="548640"/>
           </a:xfrm>
           <a:prstGeom prst="rect">
             <a:avLst/>
@@ -14054,7 +14054,7 @@
               <a:buNone/>
             </a:pPr>
             <a:r>
-              <a:rPr lang="en-US" sz="1250" b="1" dirty="0">
+              <a:rPr lang="en-US" sz="1200" b="1" dirty="0">
                 <a:solidFill>
                   <a:srgbClr val="20182B"/>
                 </a:solidFill>
@@ -14064,7 +14064,7 @@
               </a:rPr>
               <a:t>Castrol</a:t>
             </a:r>
-            <a:endParaRPr lang="en-US" sz="1250" dirty="0"/>
+            <a:endParaRPr lang="en-US" sz="1200" dirty="0"/>
           </a:p>
         </p:txBody>
       </p:sp>
@@ -14076,12 +14076,12 @@
         </p:nvSpPr>
         <p:spPr>
           <a:xfrm>
-            <a:off x="10515600" y="4023360"/>
-            <a:ext cx="1828800" cy="502920"/>
+            <a:off x="9944100" y="4069080"/>
+            <a:ext cx="1696212" cy="548640"/>
           </a:xfrm>
           <a:prstGeom prst="roundRect">
             <a:avLst>
-              <a:gd name="adj" fmla="val 10909"/>
+              <a:gd name="adj" fmla="val 10000"/>
             </a:avLst>
           </a:prstGeom>
           <a:solidFill>
@@ -14103,8 +14103,8 @@
         </p:nvSpPr>
         <p:spPr>
           <a:xfrm>
-            <a:off x="10515600" y="4023360"/>
-            <a:ext cx="1828800" cy="502920"/>
+            <a:off x="9989820" y="4069080"/>
+            <a:ext cx="1604772" cy="548640"/>
           </a:xfrm>
           <a:prstGeom prst="rect">
             <a:avLst/>
@@ -14120,7 +14120,7 @@
               <a:buNone/>
             </a:pPr>
             <a:r>
-              <a:rPr lang="en-US" sz="1250" b="1" dirty="0">
+              <a:rPr lang="en-US" sz="1200" b="1" dirty="0">
                 <a:solidFill>
                   <a:srgbClr val="20182B"/>
                 </a:solidFill>
@@ -14130,7 +14130,7 @@
               </a:rPr>
               <a:t>Pepsi</a:t>
             </a:r>
-            <a:endParaRPr lang="en-US" sz="1250" dirty="0"/>
+            <a:endParaRPr lang="en-US" sz="1200" dirty="0"/>
           </a:p>
         </p:txBody>
       </p:sp>
@@ -14142,12 +14142,12 @@
         </p:nvSpPr>
         <p:spPr>
           <a:xfrm>
-            <a:off x="548640" y="4690872"/>
-            <a:ext cx="1828800" cy="502920"/>
+            <a:off x="548640" y="4800600"/>
+            <a:ext cx="1696212" cy="548640"/>
           </a:xfrm>
           <a:prstGeom prst="roundRect">
             <a:avLst>
-              <a:gd name="adj" fmla="val 10909"/>
+              <a:gd name="adj" fmla="val 10000"/>
             </a:avLst>
           </a:prstGeom>
           <a:solidFill>
@@ -14169,8 +14169,8 @@
         </p:nvSpPr>
         <p:spPr>
           <a:xfrm>
-            <a:off x="548640" y="4690872"/>
-            <a:ext cx="1828800" cy="502920"/>
+            <a:off x="594360" y="4800600"/>
+            <a:ext cx="1604772" cy="548640"/>
           </a:xfrm>
           <a:prstGeom prst="rect">
             <a:avLst/>
@@ -14186,7 +14186,7 @@
               <a:buNone/>
             </a:pPr>
             <a:r>
-              <a:rPr lang="en-US" sz="1250" b="1" dirty="0">
+              <a:rPr lang="en-US" sz="1200" b="1" dirty="0">
                 <a:solidFill>
                   <a:srgbClr val="20182B"/>
                 </a:solidFill>
@@ -14196,7 +14196,7 @@
               </a:rPr>
               <a:t>ITC</a:t>
             </a:r>
-            <a:endParaRPr lang="en-US" sz="1250" dirty="0"/>
+            <a:endParaRPr lang="en-US" sz="1200" dirty="0"/>
           </a:p>
         </p:txBody>
       </p:sp>
@@ -14208,12 +14208,12 @@
         </p:nvSpPr>
         <p:spPr>
           <a:xfrm>
-            <a:off x="2542032" y="4690872"/>
-            <a:ext cx="1828800" cy="502920"/>
+            <a:off x="2427732" y="4800600"/>
+            <a:ext cx="1696212" cy="548640"/>
           </a:xfrm>
           <a:prstGeom prst="roundRect">
             <a:avLst>
-              <a:gd name="adj" fmla="val 10909"/>
+              <a:gd name="adj" fmla="val 10000"/>
             </a:avLst>
           </a:prstGeom>
           <a:solidFill>
@@ -14235,8 +14235,8 @@
         </p:nvSpPr>
         <p:spPr>
           <a:xfrm>
-            <a:off x="2542032" y="4690872"/>
-            <a:ext cx="1828800" cy="502920"/>
+            <a:off x="2473452" y="4800600"/>
+            <a:ext cx="1604772" cy="548640"/>
           </a:xfrm>
           <a:prstGeom prst="rect">
             <a:avLst/>
@@ -14252,7 +14252,7 @@
               <a:buNone/>
             </a:pPr>
             <a:r>
-              <a:rPr lang="en-US" sz="1250" b="1" dirty="0">
+              <a:rPr lang="en-US" sz="1200" b="1" dirty="0">
                 <a:solidFill>
                   <a:srgbClr val="20182B"/>
                 </a:solidFill>
@@ -14262,7 +14262,7 @@
               </a:rPr>
               <a:t>Burberry</a:t>
             </a:r>
-            <a:endParaRPr lang="en-US" sz="1250" dirty="0"/>
+            <a:endParaRPr lang="en-US" sz="1200" dirty="0"/>
           </a:p>
         </p:txBody>
       </p:sp>
@@ -14274,12 +14274,12 @@
         </p:nvSpPr>
         <p:spPr>
           <a:xfrm>
-            <a:off x="4535424" y="4690872"/>
-            <a:ext cx="1828800" cy="502920"/>
+            <a:off x="4306824" y="4800600"/>
+            <a:ext cx="1696212" cy="548640"/>
           </a:xfrm>
           <a:prstGeom prst="roundRect">
             <a:avLst>
-              <a:gd name="adj" fmla="val 10909"/>
+              <a:gd name="adj" fmla="val 10000"/>
             </a:avLst>
           </a:prstGeom>
           <a:solidFill>
@@ -14301,8 +14301,8 @@
         </p:nvSpPr>
         <p:spPr>
           <a:xfrm>
-            <a:off x="4535424" y="4690872"/>
-            <a:ext cx="1828800" cy="502920"/>
+            <a:off x="4352544" y="4800600"/>
+            <a:ext cx="1604772" cy="548640"/>
           </a:xfrm>
           <a:prstGeom prst="rect">
             <a:avLst/>
@@ -14318,7 +14318,7 @@
               <a:buNone/>
             </a:pPr>
             <a:r>
-              <a:rPr lang="en-US" sz="1250" b="1" dirty="0">
+              <a:rPr lang="en-US" sz="1200" b="1" dirty="0">
                 <a:solidFill>
                   <a:srgbClr val="20182B"/>
                 </a:solidFill>
@@ -14328,7 +14328,7 @@
               </a:rPr>
               <a:t>Louis Vuitton</a:t>
             </a:r>
-            <a:endParaRPr lang="en-US" sz="1250" dirty="0"/>
+            <a:endParaRPr lang="en-US" sz="1200" dirty="0"/>
           </a:p>
         </p:txBody>
       </p:sp>
@@ -14340,12 +14340,12 @@
         </p:nvSpPr>
         <p:spPr>
           <a:xfrm>
-            <a:off x="6528816" y="4690872"/>
-            <a:ext cx="1828800" cy="502920"/>
+            <a:off x="6185916" y="4800600"/>
+            <a:ext cx="1696212" cy="548640"/>
           </a:xfrm>
           <a:prstGeom prst="roundRect">
             <a:avLst>
-              <a:gd name="adj" fmla="val 10909"/>
+              <a:gd name="adj" fmla="val 10000"/>
             </a:avLst>
           </a:prstGeom>
           <a:solidFill>
@@ -14367,8 +14367,8 @@
         </p:nvSpPr>
         <p:spPr>
           <a:xfrm>
-            <a:off x="6528816" y="4690872"/>
-            <a:ext cx="1828800" cy="502920"/>
+            <a:off x="6231636" y="4800600"/>
+            <a:ext cx="1604772" cy="548640"/>
           </a:xfrm>
           <a:prstGeom prst="rect">
             <a:avLst/>
@@ -14384,7 +14384,7 @@
               <a:buNone/>
             </a:pPr>
             <a:r>
-              <a:rPr lang="en-US" sz="1250" b="1" dirty="0">
+              <a:rPr lang="en-US" sz="1200" b="1" dirty="0">
                 <a:solidFill>
                   <a:srgbClr val="20182B"/>
                 </a:solidFill>
@@ -14394,7 +14394,7 @@
               </a:rPr>
               <a:t>Panasonic</a:t>
             </a:r>
-            <a:endParaRPr lang="en-US" sz="1250" dirty="0"/>
+            <a:endParaRPr lang="en-US" sz="1200" dirty="0"/>
           </a:p>
         </p:txBody>
       </p:sp>
@@ -14406,12 +14406,12 @@
         </p:nvSpPr>
         <p:spPr>
           <a:xfrm>
-            <a:off x="8522208" y="4690872"/>
-            <a:ext cx="1828800" cy="502920"/>
+            <a:off x="8065008" y="4800600"/>
+            <a:ext cx="1696212" cy="548640"/>
           </a:xfrm>
           <a:prstGeom prst="roundRect">
             <a:avLst>
-              <a:gd name="adj" fmla="val 10909"/>
+              <a:gd name="adj" fmla="val 10000"/>
             </a:avLst>
           </a:prstGeom>
           <a:solidFill>
@@ -14433,8 +14433,8 @@
         </p:nvSpPr>
         <p:spPr>
           <a:xfrm>
-            <a:off x="8522208" y="4690872"/>
-            <a:ext cx="1828800" cy="502920"/>
+            <a:off x="8110728" y="4800600"/>
+            <a:ext cx="1604772" cy="548640"/>
           </a:xfrm>
           <a:prstGeom prst="rect">
             <a:avLst/>
@@ -14450,7 +14450,7 @@
               <a:buNone/>
             </a:pPr>
             <a:r>
-              <a:rPr lang="en-US" sz="1250" b="1" dirty="0">
+              <a:rPr lang="en-US" sz="1200" b="1" dirty="0">
                 <a:solidFill>
                   <a:srgbClr val="20182B"/>
                 </a:solidFill>
@@ -14460,7 +14460,7 @@
               </a:rPr>
               <a:t>Pearson</a:t>
             </a:r>
-            <a:endParaRPr lang="en-US" sz="1250" dirty="0"/>
+            <a:endParaRPr lang="en-US" sz="1200" dirty="0"/>
           </a:p>
         </p:txBody>
       </p:sp>
@@ -14472,12 +14472,12 @@
         </p:nvSpPr>
         <p:spPr>
           <a:xfrm>
-            <a:off x="10515600" y="4690872"/>
-            <a:ext cx="1828800" cy="502920"/>
+            <a:off x="9944100" y="4800600"/>
+            <a:ext cx="1696212" cy="548640"/>
           </a:xfrm>
           <a:prstGeom prst="roundRect">
             <a:avLst>
-              <a:gd name="adj" fmla="val 10909"/>
+              <a:gd name="adj" fmla="val 10000"/>
             </a:avLst>
           </a:prstGeom>
           <a:solidFill>
@@ -14499,8 +14499,8 @@
         </p:nvSpPr>
         <p:spPr>
           <a:xfrm>
-            <a:off x="10515600" y="4690872"/>
-            <a:ext cx="1828800" cy="502920"/>
+            <a:off x="9989820" y="4800600"/>
+            <a:ext cx="1604772" cy="548640"/>
           </a:xfrm>
           <a:prstGeom prst="rect">
             <a:avLst/>
@@ -14516,7 +14516,7 @@
               <a:buNone/>
             </a:pPr>
             <a:r>
-              <a:rPr lang="en-US" sz="1250" b="1" dirty="0">
+              <a:rPr lang="en-US" sz="1200" b="1" dirty="0">
                 <a:solidFill>
                   <a:srgbClr val="20182B"/>
                 </a:solidFill>
@@ -14526,7 +14526,7 @@
               </a:rPr>
               <a:t>ICC World Cup</a:t>
             </a:r>
-            <a:endParaRPr lang="en-US" sz="1250" dirty="0"/>
+            <a:endParaRPr lang="en-US" sz="1200" dirty="0"/>
           </a:p>
         </p:txBody>
       </p:sp>

</xml_diff>

<commit_message>
Fix ProMarcom logo background and text overflow in deck
- Flood-fill ProMarcom logo background to transparent; present on a clean white chip (removes heavy black box)
- Switch body font from Century Gothic to Corbel to prevent text overflow/overlap from the wider font
- Tidy cover: clean image edge, safe text widths

Co-Authored-By: Claude Opus 4.8 <noreply@anthropic.com>
Claude-Session: https://claude.ai/code/session_01SPjFYHW1nTDVr5tUuToRXR
</commit_message>
<xml_diff>
--- a/doft_diwali_popup/Doft_Diwali_PopUp_ProMarcom_Pitch.pptx
+++ b/doft_diwali_popup/Doft_Diwali_PopUp_ProMarcom_Pitch.pptx
@@ -470,8 +470,8 @@
               <a:solidFill>
                 <a:srgbClr val="35302B"/>
               </a:solidFill>
-              <a:latin typeface="Century Gothic"/>
-              <a:cs typeface="Century Gothic"/>
+              <a:latin typeface="Corbel"/>
+              <a:cs typeface="Corbel"/>
             </a:defRPr>
           </a:pPr>
           <a:endParaRPr lang="en-US"/>
@@ -2685,8 +2685,8 @@
         </p:blipFill>
         <p:spPr>
           <a:xfrm>
-            <a:off x="7818120" y="0"/>
-            <a:ext cx="4370832" cy="6858000"/>
+            <a:off x="7955280" y="0"/>
+            <a:ext cx="4233672" cy="6858000"/>
           </a:xfrm>
           <a:prstGeom prst="rect">
             <a:avLst/>
@@ -2701,18 +2701,19 @@
         </p:nvSpPr>
         <p:spPr>
           <a:xfrm>
-            <a:off x="6995160" y="0"/>
-            <a:ext cx="1280160" cy="6858000"/>
-          </a:xfrm>
-          <a:prstGeom prst="rect">
-            <a:avLst/>
-          </a:prstGeom>
-          <a:solidFill>
-            <a:srgbClr val="F6F1E6">
-              <a:alpha val="60000"/>
-            </a:srgbClr>
-          </a:solidFill>
-          <a:ln/>
+            <a:off x="7955280" y="0"/>
+            <a:ext cx="0" cy="6858000"/>
+          </a:xfrm>
+          <a:prstGeom prst="line">
+            <a:avLst/>
+          </a:prstGeom>
+          <a:noFill/>
+          <a:ln w="25400">
+            <a:solidFill>
+              <a:srgbClr val="FFFFFF"/>
+            </a:solidFill>
+            <a:prstDash val="solid"/>
+          </a:ln>
         </p:spPr>
       </p:sp>
       <p:sp>
@@ -2810,9 +2811,9 @@
                 <a:solidFill>
                   <a:srgbClr val="8C7F72"/>
                 </a:solidFill>
-                <a:latin typeface="Century Gothic" pitchFamily="34" charset="0"/>
-                <a:ea typeface="Century Gothic" pitchFamily="34" charset="-122"/>
-                <a:cs typeface="Century Gothic" pitchFamily="34" charset="-120"/>
+                <a:latin typeface="Corbel" pitchFamily="34" charset="0"/>
+                <a:ea typeface="Corbel" pitchFamily="34" charset="-122"/>
+                <a:cs typeface="Corbel" pitchFamily="34" charset="-120"/>
               </a:rPr>
               <a:t>client logo — placeholder</a:t>
             </a:r>
@@ -2829,7 +2830,7 @@
         <p:spPr>
           <a:xfrm>
             <a:off x="566928" y="1965960"/>
-            <a:ext cx="6949440" cy="274320"/>
+            <a:ext cx="7114032" cy="274320"/>
           </a:xfrm>
           <a:prstGeom prst="rect">
             <a:avLst/>
@@ -2849,9 +2850,9 @@
                 <a:solidFill>
                   <a:srgbClr val="B8924A"/>
                 </a:solidFill>
-                <a:latin typeface="Century Gothic" pitchFamily="34" charset="0"/>
-                <a:ea typeface="Century Gothic" pitchFamily="34" charset="-122"/>
-                <a:cs typeface="Century Gothic" pitchFamily="34" charset="-120"/>
+                <a:latin typeface="Corbel" pitchFamily="34" charset="0"/>
+                <a:ea typeface="Corbel" pitchFamily="34" charset="-122"/>
+                <a:cs typeface="Corbel" pitchFamily="34" charset="-120"/>
               </a:rPr>
               <a:t>CONTRACTOR EXECUTION &amp; PARTNERSHIP PROPOSAL</a:t>
             </a:r>
@@ -2868,7 +2869,7 @@
         <p:spPr>
           <a:xfrm>
             <a:off x="566928" y="2331720"/>
-            <a:ext cx="7315200" cy="868680"/>
+            <a:ext cx="7114032" cy="868680"/>
           </a:xfrm>
           <a:prstGeom prst="rect">
             <a:avLst/>
@@ -2884,7 +2885,7 @@
               <a:buNone/>
             </a:pPr>
             <a:r>
-              <a:rPr lang="en-US" sz="5200" b="1" dirty="0">
+              <a:rPr lang="en-US" sz="5000" b="1" dirty="0">
                 <a:solidFill>
                   <a:srgbClr val="35302B"/>
                 </a:solidFill>
@@ -2894,7 +2895,7 @@
               </a:rPr>
               <a:t>Diwali Pop-Up</a:t>
             </a:r>
-            <a:endParaRPr lang="en-US" sz="5200" dirty="0"/>
+            <a:endParaRPr lang="en-US" sz="5000" dirty="0"/>
           </a:p>
         </p:txBody>
       </p:sp>
@@ -2906,8 +2907,8 @@
         </p:nvSpPr>
         <p:spPr>
           <a:xfrm>
-            <a:off x="566928" y="3182112"/>
-            <a:ext cx="7315200" cy="868680"/>
+            <a:off x="566928" y="3200400"/>
+            <a:ext cx="7114032" cy="868680"/>
           </a:xfrm>
           <a:prstGeom prst="rect">
             <a:avLst/>
@@ -2923,7 +2924,7 @@
               <a:buNone/>
             </a:pPr>
             <a:r>
-              <a:rPr lang="en-US" sz="5200" b="1" dirty="0">
+              <a:rPr lang="en-US" sz="5000" b="1" dirty="0">
                 <a:solidFill>
                   <a:srgbClr val="9E5A45"/>
                 </a:solidFill>
@@ -2933,7 +2934,7 @@
               </a:rPr>
               <a:t>Retail Operations</a:t>
             </a:r>
-            <a:endParaRPr lang="en-US" sz="5200" dirty="0"/>
+            <a:endParaRPr lang="en-US" sz="5000" dirty="0"/>
           </a:p>
         </p:txBody>
       </p:sp>
@@ -2945,7 +2946,7 @@
         </p:nvSpPr>
         <p:spPr>
           <a:xfrm>
-            <a:off x="585216" y="4224528"/>
+            <a:off x="585216" y="4206240"/>
             <a:ext cx="3291840" cy="0"/>
           </a:xfrm>
           <a:prstGeom prst="line">
@@ -2968,8 +2969,8 @@
         </p:nvSpPr>
         <p:spPr>
           <a:xfrm>
-            <a:off x="566928" y="4370832"/>
-            <a:ext cx="7132320" cy="365760"/>
+            <a:off x="566928" y="4352544"/>
+            <a:ext cx="7114032" cy="365760"/>
           </a:xfrm>
           <a:prstGeom prst="rect">
             <a:avLst/>
@@ -2989,9 +2990,9 @@
                 <a:solidFill>
                   <a:srgbClr val="8C7F72"/>
                 </a:solidFill>
-                <a:latin typeface="Century Gothic" pitchFamily="34" charset="0"/>
-                <a:ea typeface="Century Gothic" pitchFamily="34" charset="-122"/>
-                <a:cs typeface="Century Gothic" pitchFamily="34" charset="-120"/>
+                <a:latin typeface="Corbel" pitchFamily="34" charset="0"/>
+                <a:ea typeface="Corbel" pitchFamily="34" charset="-122"/>
+                <a:cs typeface="Corbel" pitchFamily="34" charset="-120"/>
               </a:rPr>
               <a:t>For  </a:t>
             </a:r>
@@ -3003,9 +3004,9 @@
                 <a:solidFill>
                   <a:srgbClr val="35302B"/>
                 </a:solidFill>
-                <a:latin typeface="Century Gothic" pitchFamily="34" charset="0"/>
-                <a:ea typeface="Century Gothic" pitchFamily="34" charset="-122"/>
-                <a:cs typeface="Century Gothic" pitchFamily="34" charset="-120"/>
+                <a:latin typeface="Corbel" pitchFamily="34" charset="0"/>
+                <a:ea typeface="Corbel" pitchFamily="34" charset="-122"/>
+                <a:cs typeface="Corbel" pitchFamily="34" charset="-120"/>
               </a:rPr>
               <a:t>Doft Candles</a:t>
             </a:r>
@@ -3017,9 +3018,9 @@
                 <a:solidFill>
                   <a:srgbClr val="8C7F72"/>
                 </a:solidFill>
-                <a:latin typeface="Century Gothic" pitchFamily="34" charset="0"/>
-                <a:ea typeface="Century Gothic" pitchFamily="34" charset="-122"/>
-                <a:cs typeface="Century Gothic" pitchFamily="34" charset="-120"/>
+                <a:latin typeface="Corbel" pitchFamily="34" charset="0"/>
+                <a:ea typeface="Corbel" pitchFamily="34" charset="-122"/>
+                <a:cs typeface="Corbel" pitchFamily="34" charset="-120"/>
               </a:rPr>
               <a:t>     ·     Diwali Seasons 2026 · 2027 · 2028</a:t>
             </a:r>
@@ -3035,8 +3036,8 @@
         </p:nvSpPr>
         <p:spPr>
           <a:xfrm>
-            <a:off x="566928" y="5074920"/>
-            <a:ext cx="6766560" cy="365760"/>
+            <a:off x="566928" y="5029200"/>
+            <a:ext cx="7114032" cy="365760"/>
           </a:xfrm>
           <a:prstGeom prst="rect">
             <a:avLst/>
@@ -3074,8 +3075,8 @@
         </p:nvSpPr>
         <p:spPr>
           <a:xfrm>
-            <a:off x="566928" y="5715000"/>
-            <a:ext cx="1280160" cy="384048"/>
+            <a:off x="566928" y="5742432"/>
+            <a:ext cx="1280160" cy="457200"/>
           </a:xfrm>
           <a:prstGeom prst="rect">
             <a:avLst/>
@@ -3095,9 +3096,9 @@
                 <a:solidFill>
                   <a:srgbClr val="8C7F72"/>
                 </a:solidFill>
-                <a:latin typeface="Century Gothic" pitchFamily="34" charset="0"/>
-                <a:ea typeface="Century Gothic" pitchFamily="34" charset="-122"/>
-                <a:cs typeface="Century Gothic" pitchFamily="34" charset="-120"/>
+                <a:latin typeface="Corbel" pitchFamily="34" charset="0"/>
+                <a:ea typeface="Corbel" pitchFamily="34" charset="-122"/>
+                <a:cs typeface="Corbel" pitchFamily="34" charset="-120"/>
               </a:rPr>
               <a:t>Prepared by</a:t>
             </a:r>
@@ -3113,18 +3114,30 @@
         </p:nvSpPr>
         <p:spPr>
           <a:xfrm>
-            <a:off x="1618488" y="5715000"/>
-            <a:ext cx="1554480" cy="384048"/>
+            <a:off x="1618488" y="5705856"/>
+            <a:ext cx="1554480" cy="457200"/>
           </a:xfrm>
           <a:prstGeom prst="roundRect">
             <a:avLst>
-              <a:gd name="adj" fmla="val 11905"/>
+              <a:gd name="adj" fmla="val 10000"/>
             </a:avLst>
           </a:prstGeom>
           <a:solidFill>
-            <a:srgbClr val="1C1518"/>
+            <a:srgbClr val="FFFFFF"/>
           </a:solidFill>
-          <a:ln/>
+          <a:ln w="12700">
+            <a:solidFill>
+              <a:srgbClr val="E3D8C7"/>
+            </a:solidFill>
+            <a:prstDash val="solid"/>
+          </a:ln>
+          <a:effectLst>
+            <a:outerShdw sx="100000" sy="100000" kx="0" ky="0" algn="bl" rotWithShape="0" blurRad="50800" dist="12700" dir="5400000">
+              <a:srgbClr val="B8A894">
+                <a:alpha val="35000"/>
+              </a:srgbClr>
+            </a:outerShdw>
+          </a:effectLst>
         </p:spPr>
       </p:sp>
       <p:pic>
@@ -3143,8 +3156,8 @@
         </p:blipFill>
         <p:spPr>
           <a:xfrm>
-            <a:off x="1746504" y="5758955"/>
-            <a:ext cx="1298448" cy="296137"/>
+            <a:off x="1737360" y="5784302"/>
+            <a:ext cx="1316736" cy="300308"/>
           </a:xfrm>
           <a:prstGeom prst="rect">
             <a:avLst/>
@@ -3212,9 +3225,9 @@
                 <a:solidFill>
                   <a:srgbClr val="B8924A"/>
                 </a:solidFill>
-                <a:latin typeface="Century Gothic" pitchFamily="34" charset="0"/>
-                <a:ea typeface="Century Gothic" pitchFamily="34" charset="-122"/>
-                <a:cs typeface="Century Gothic" pitchFamily="34" charset="-120"/>
+                <a:latin typeface="Corbel" pitchFamily="34" charset="0"/>
+                <a:ea typeface="Corbel" pitchFamily="34" charset="-122"/>
+                <a:cs typeface="Corbel" pitchFamily="34" charset="-120"/>
               </a:rPr>
               <a:t>SUPPLY CHAIN</a:t>
             </a:r>
@@ -3269,18 +3282,30 @@
         </p:nvSpPr>
         <p:spPr>
           <a:xfrm>
-            <a:off x="10204704" y="457200"/>
-            <a:ext cx="1417320" cy="384048"/>
+            <a:off x="10140696" y="420624"/>
+            <a:ext cx="1481328" cy="457200"/>
           </a:xfrm>
           <a:prstGeom prst="roundRect">
             <a:avLst>
-              <a:gd name="adj" fmla="val 11905"/>
+              <a:gd name="adj" fmla="val 10000"/>
             </a:avLst>
           </a:prstGeom>
           <a:solidFill>
-            <a:srgbClr val="1C1518"/>
+            <a:srgbClr val="FFFFFF"/>
           </a:solidFill>
-          <a:ln/>
+          <a:ln w="12700">
+            <a:solidFill>
+              <a:srgbClr val="E3D8C7"/>
+            </a:solidFill>
+            <a:prstDash val="solid"/>
+          </a:ln>
+          <a:effectLst>
+            <a:outerShdw sx="100000" sy="100000" kx="0" ky="0" algn="bl" rotWithShape="0" blurRad="50800" dist="12700" dir="5400000">
+              <a:srgbClr val="B8A894">
+                <a:alpha val="35000"/>
+              </a:srgbClr>
+            </a:outerShdw>
+          </a:effectLst>
         </p:spPr>
       </p:sp>
       <p:pic>
@@ -3299,8 +3324,8 @@
         </p:blipFill>
         <p:spPr>
           <a:xfrm>
-            <a:off x="10332720" y="516796"/>
-            <a:ext cx="1161288" cy="264855"/>
+            <a:off x="10259568" y="507412"/>
+            <a:ext cx="1243584" cy="283624"/>
           </a:xfrm>
           <a:prstGeom prst="rect">
             <a:avLst/>
@@ -3468,9 +3493,9 @@
                 <a:solidFill>
                   <a:srgbClr val="35302B"/>
                 </a:solidFill>
-                <a:latin typeface="Century Gothic" pitchFamily="34" charset="0"/>
-                <a:ea typeface="Century Gothic" pitchFamily="34" charset="-122"/>
-                <a:cs typeface="Century Gothic" pitchFamily="34" charset="-120"/>
+                <a:latin typeface="Corbel" pitchFamily="34" charset="0"/>
+                <a:ea typeface="Corbel" pitchFamily="34" charset="-122"/>
+                <a:cs typeface="Corbel" pitchFamily="34" charset="-120"/>
               </a:rPr>
               <a:t>Collect stock from Doft's warehouse; insured in transit</a:t>
             </a:r>
@@ -3507,9 +3532,9 @@
                 <a:solidFill>
                   <a:srgbClr val="B8924A"/>
                 </a:solidFill>
-                <a:latin typeface="Century Gothic" pitchFamily="34" charset="0"/>
-                <a:ea typeface="Century Gothic" pitchFamily="34" charset="-122"/>
-                <a:cs typeface="Century Gothic" pitchFamily="34" charset="-120"/>
+                <a:latin typeface="Corbel" pitchFamily="34" charset="0"/>
+                <a:ea typeface="Corbel" pitchFamily="34" charset="-122"/>
+                <a:cs typeface="Corbel" pitchFamily="34" charset="-120"/>
               </a:rPr>
               <a:t>→</a:t>
             </a:r>
@@ -3678,9 +3703,9 @@
                 <a:solidFill>
                   <a:srgbClr val="35302B"/>
                 </a:solidFill>
-                <a:latin typeface="Century Gothic" pitchFamily="34" charset="0"/>
-                <a:ea typeface="Century Gothic" pitchFamily="34" charset="-122"/>
-                <a:cs typeface="Century Gothic" pitchFamily="34" charset="-120"/>
+                <a:latin typeface="Corbel" pitchFamily="34" charset="0"/>
+                <a:ea typeface="Corbel" pitchFamily="34" charset="-122"/>
+                <a:cs typeface="Corbel" pitchFamily="34" charset="-120"/>
               </a:rPr>
               <a:t>Local buffer beside each kiosk for fast replenishment</a:t>
             </a:r>
@@ -3717,9 +3742,9 @@
                 <a:solidFill>
                   <a:srgbClr val="B8924A"/>
                 </a:solidFill>
-                <a:latin typeface="Century Gothic" pitchFamily="34" charset="0"/>
-                <a:ea typeface="Century Gothic" pitchFamily="34" charset="-122"/>
-                <a:cs typeface="Century Gothic" pitchFamily="34" charset="-120"/>
+                <a:latin typeface="Corbel" pitchFamily="34" charset="0"/>
+                <a:ea typeface="Corbel" pitchFamily="34" charset="-122"/>
+                <a:cs typeface="Corbel" pitchFamily="34" charset="-120"/>
               </a:rPr>
               <a:t>→</a:t>
             </a:r>
@@ -3888,9 +3913,9 @@
                 <a:solidFill>
                   <a:srgbClr val="35302B"/>
                 </a:solidFill>
-                <a:latin typeface="Century Gothic" pitchFamily="34" charset="0"/>
-                <a:ea typeface="Century Gothic" pitchFamily="34" charset="-122"/>
-                <a:cs typeface="Century Gothic" pitchFamily="34" charset="-120"/>
+                <a:latin typeface="Corbel" pitchFamily="34" charset="0"/>
+                <a:ea typeface="Corbel" pitchFamily="34" charset="-122"/>
+                <a:cs typeface="Corbel" pitchFamily="34" charset="-120"/>
               </a:rPr>
               <a:t>Daily fill to plan; reorder triggered by minimum levels</a:t>
             </a:r>
@@ -3927,9 +3952,9 @@
                 <a:solidFill>
                   <a:srgbClr val="B8924A"/>
                 </a:solidFill>
-                <a:latin typeface="Century Gothic" pitchFamily="34" charset="0"/>
-                <a:ea typeface="Century Gothic" pitchFamily="34" charset="-122"/>
-                <a:cs typeface="Century Gothic" pitchFamily="34" charset="-120"/>
+                <a:latin typeface="Corbel" pitchFamily="34" charset="0"/>
+                <a:ea typeface="Corbel" pitchFamily="34" charset="-122"/>
+                <a:cs typeface="Corbel" pitchFamily="34" charset="-120"/>
               </a:rPr>
               <a:t>→</a:t>
             </a:r>
@@ -4098,9 +4123,9 @@
                 <a:solidFill>
                   <a:srgbClr val="35302B"/>
                 </a:solidFill>
-                <a:latin typeface="Century Gothic" pitchFamily="34" charset="0"/>
-                <a:ea typeface="Century Gothic" pitchFamily="34" charset="-122"/>
-                <a:cs typeface="Century Gothic" pitchFamily="34" charset="-120"/>
+                <a:latin typeface="Corbel" pitchFamily="34" charset="0"/>
+                <a:ea typeface="Corbel" pitchFamily="34" charset="-122"/>
+                <a:cs typeface="Corbel" pitchFamily="34" charset="-120"/>
               </a:rPr>
               <a:t>Daily counts; unsold inventory returned with full reconciliation</a:t>
             </a:r>
@@ -4176,9 +4201,9 @@
                 <a:solidFill>
                   <a:srgbClr val="8C7F72"/>
                 </a:solidFill>
-                <a:latin typeface="Century Gothic" pitchFamily="34" charset="0"/>
-                <a:ea typeface="Century Gothic" pitchFamily="34" charset="-122"/>
-                <a:cs typeface="Century Gothic" pitchFamily="34" charset="-120"/>
+                <a:latin typeface="Corbel" pitchFamily="34" charset="0"/>
+                <a:ea typeface="Corbel" pitchFamily="34" charset="-122"/>
+                <a:cs typeface="Corbel" pitchFamily="34" charset="-120"/>
               </a:rPr>
               <a:t>ProMarcom  ×  Doft Candles</a:t>
             </a:r>
@@ -4286,9 +4311,9 @@
                 <a:solidFill>
                   <a:srgbClr val="B8924A"/>
                 </a:solidFill>
-                <a:latin typeface="Century Gothic" pitchFamily="34" charset="0"/>
-                <a:ea typeface="Century Gothic" pitchFamily="34" charset="-122"/>
-                <a:cs typeface="Century Gothic" pitchFamily="34" charset="-120"/>
+                <a:latin typeface="Corbel" pitchFamily="34" charset="0"/>
+                <a:ea typeface="Corbel" pitchFamily="34" charset="-122"/>
+                <a:cs typeface="Corbel" pitchFamily="34" charset="-120"/>
               </a:rPr>
               <a:t>OPERATIONS</a:t>
             </a:r>
@@ -4343,18 +4368,30 @@
         </p:nvSpPr>
         <p:spPr>
           <a:xfrm>
-            <a:off x="10204704" y="457200"/>
-            <a:ext cx="1417320" cy="384048"/>
+            <a:off x="10140696" y="420624"/>
+            <a:ext cx="1481328" cy="457200"/>
           </a:xfrm>
           <a:prstGeom prst="roundRect">
             <a:avLst>
-              <a:gd name="adj" fmla="val 11905"/>
+              <a:gd name="adj" fmla="val 10000"/>
             </a:avLst>
           </a:prstGeom>
           <a:solidFill>
-            <a:srgbClr val="1C1518"/>
+            <a:srgbClr val="FFFFFF"/>
           </a:solidFill>
-          <a:ln/>
+          <a:ln w="12700">
+            <a:solidFill>
+              <a:srgbClr val="E3D8C7"/>
+            </a:solidFill>
+            <a:prstDash val="solid"/>
+          </a:ln>
+          <a:effectLst>
+            <a:outerShdw sx="100000" sy="100000" kx="0" ky="0" algn="bl" rotWithShape="0" blurRad="50800" dist="12700" dir="5400000">
+              <a:srgbClr val="B8A894">
+                <a:alpha val="35000"/>
+              </a:srgbClr>
+            </a:outerShdw>
+          </a:effectLst>
         </p:spPr>
       </p:sp>
       <p:pic>
@@ -4373,8 +4410,8 @@
         </p:blipFill>
         <p:spPr>
           <a:xfrm>
-            <a:off x="10332720" y="516796"/>
-            <a:ext cx="1161288" cy="264855"/>
+            <a:off x="10259568" y="507412"/>
+            <a:ext cx="1243584" cy="283624"/>
           </a:xfrm>
           <a:prstGeom prst="rect">
             <a:avLst/>
@@ -4410,9 +4447,9 @@
                 <a:solidFill>
                   <a:srgbClr val="8C7F72"/>
                 </a:solidFill>
-                <a:latin typeface="Century Gothic" pitchFamily="34" charset="0"/>
-                <a:ea typeface="Century Gothic" pitchFamily="34" charset="-122"/>
-                <a:cs typeface="Century Gothic" pitchFamily="34" charset="-120"/>
+                <a:latin typeface="Corbel" pitchFamily="34" charset="0"/>
+                <a:ea typeface="Corbel" pitchFamily="34" charset="-122"/>
+                <a:cs typeface="Corbel" pitchFamily="34" charset="-120"/>
               </a:rPr>
               <a:t>Consistent open-to-close execution, with a standard daily report to Doft per kiosk — consolidated by city.</a:t>
             </a:r>
@@ -5215,9 +5252,9 @@
                 <a:solidFill>
                   <a:srgbClr val="D9B86B"/>
                 </a:solidFill>
-                <a:latin typeface="Century Gothic" pitchFamily="34" charset="0"/>
-                <a:ea typeface="Century Gothic" pitchFamily="34" charset="-122"/>
-                <a:cs typeface="Century Gothic" pitchFamily="34" charset="-120"/>
+                <a:latin typeface="Corbel" pitchFamily="34" charset="0"/>
+                <a:ea typeface="Corbel" pitchFamily="34" charset="-122"/>
+                <a:cs typeface="Corbel" pitchFamily="34" charset="-120"/>
               </a:rPr>
               <a:t>GOVERNANCE CADENCE</a:t>
             </a:r>
@@ -5254,9 +5291,9 @@
                 <a:solidFill>
                   <a:srgbClr val="D9B86B"/>
                 </a:solidFill>
-                <a:latin typeface="Century Gothic" pitchFamily="34" charset="0"/>
-                <a:ea typeface="Century Gothic" pitchFamily="34" charset="-122"/>
-                <a:cs typeface="Century Gothic" pitchFamily="34" charset="-120"/>
+                <a:latin typeface="Corbel" pitchFamily="34" charset="0"/>
+                <a:ea typeface="Corbel" pitchFamily="34" charset="-122"/>
+                <a:cs typeface="Corbel" pitchFamily="34" charset="-120"/>
               </a:rPr>
               <a:t>Daily</a:t>
             </a:r>
@@ -5268,9 +5305,9 @@
                 <a:solidFill>
                   <a:srgbClr val="F3ECE0"/>
                 </a:solidFill>
-                <a:latin typeface="Century Gothic" pitchFamily="34" charset="0"/>
-                <a:ea typeface="Century Gothic" pitchFamily="34" charset="-122"/>
-                <a:cs typeface="Century Gothic" pitchFamily="34" charset="-120"/>
+                <a:latin typeface="Corbel" pitchFamily="34" charset="0"/>
+                <a:ea typeface="Corbel" pitchFamily="34" charset="-122"/>
+                <a:cs typeface="Corbel" pitchFamily="34" charset="-120"/>
               </a:rPr>
               <a:t> written report      ·      </a:t>
             </a:r>
@@ -5282,9 +5319,9 @@
                 <a:solidFill>
                   <a:srgbClr val="D9B86B"/>
                 </a:solidFill>
-                <a:latin typeface="Century Gothic" pitchFamily="34" charset="0"/>
-                <a:ea typeface="Century Gothic" pitchFamily="34" charset="-122"/>
-                <a:cs typeface="Century Gothic" pitchFamily="34" charset="-120"/>
+                <a:latin typeface="Corbel" pitchFamily="34" charset="0"/>
+                <a:ea typeface="Corbel" pitchFamily="34" charset="-122"/>
+                <a:cs typeface="Corbel" pitchFamily="34" charset="-120"/>
               </a:rPr>
               <a:t>Weekly</a:t>
             </a:r>
@@ -5296,9 +5333,9 @@
                 <a:solidFill>
                   <a:srgbClr val="F3ECE0"/>
                 </a:solidFill>
-                <a:latin typeface="Century Gothic" pitchFamily="34" charset="0"/>
-                <a:ea typeface="Century Gothic" pitchFamily="34" charset="-122"/>
-                <a:cs typeface="Century Gothic" pitchFamily="34" charset="-120"/>
+                <a:latin typeface="Corbel" pitchFamily="34" charset="0"/>
+                <a:ea typeface="Corbel" pitchFamily="34" charset="-122"/>
+                <a:cs typeface="Corbel" pitchFamily="34" charset="-120"/>
               </a:rPr>
               <a:t> city review call      ·      </a:t>
             </a:r>
@@ -5310,9 +5347,9 @@
                 <a:solidFill>
                   <a:srgbClr val="D9B86B"/>
                 </a:solidFill>
-                <a:latin typeface="Century Gothic" pitchFamily="34" charset="0"/>
-                <a:ea typeface="Century Gothic" pitchFamily="34" charset="-122"/>
-                <a:cs typeface="Century Gothic" pitchFamily="34" charset="-120"/>
+                <a:latin typeface="Corbel" pitchFamily="34" charset="0"/>
+                <a:ea typeface="Corbel" pitchFamily="34" charset="-122"/>
+                <a:cs typeface="Corbel" pitchFamily="34" charset="-120"/>
               </a:rPr>
               <a:t>End-of-season</a:t>
             </a:r>
@@ -5324,9 +5361,9 @@
                 <a:solidFill>
                   <a:srgbClr val="F3ECE0"/>
                 </a:solidFill>
-                <a:latin typeface="Century Gothic" pitchFamily="34" charset="0"/>
-                <a:ea typeface="Century Gothic" pitchFamily="34" charset="-122"/>
-                <a:cs typeface="Century Gothic" pitchFamily="34" charset="-120"/>
+                <a:latin typeface="Corbel" pitchFamily="34" charset="0"/>
+                <a:ea typeface="Corbel" pitchFamily="34" charset="-122"/>
+                <a:cs typeface="Corbel" pitchFamily="34" charset="-120"/>
               </a:rPr>
               <a:t> reconciliation &amp; review</a:t>
             </a:r>
@@ -5363,9 +5400,9 @@
                 <a:solidFill>
                   <a:srgbClr val="8C7F72"/>
                 </a:solidFill>
-                <a:latin typeface="Century Gothic" pitchFamily="34" charset="0"/>
-                <a:ea typeface="Century Gothic" pitchFamily="34" charset="-122"/>
-                <a:cs typeface="Century Gothic" pitchFamily="34" charset="-120"/>
+                <a:latin typeface="Corbel" pitchFamily="34" charset="0"/>
+                <a:ea typeface="Corbel" pitchFamily="34" charset="-122"/>
+                <a:cs typeface="Corbel" pitchFamily="34" charset="-120"/>
               </a:rPr>
               <a:t>ProMarcom  ×  Doft Candles</a:t>
             </a:r>
@@ -5473,9 +5510,9 @@
                 <a:solidFill>
                   <a:srgbClr val="B8924A"/>
                 </a:solidFill>
-                <a:latin typeface="Century Gothic" pitchFamily="34" charset="0"/>
-                <a:ea typeface="Century Gothic" pitchFamily="34" charset="-122"/>
-                <a:cs typeface="Century Gothic" pitchFamily="34" charset="-120"/>
+                <a:latin typeface="Corbel" pitchFamily="34" charset="0"/>
+                <a:ea typeface="Corbel" pitchFamily="34" charset="-122"/>
+                <a:cs typeface="Corbel" pitchFamily="34" charset="-120"/>
               </a:rPr>
               <a:t>PLAN</a:t>
             </a:r>
@@ -5530,18 +5567,30 @@
         </p:nvSpPr>
         <p:spPr>
           <a:xfrm>
-            <a:off x="10204704" y="457200"/>
-            <a:ext cx="1417320" cy="384048"/>
+            <a:off x="10140696" y="420624"/>
+            <a:ext cx="1481328" cy="457200"/>
           </a:xfrm>
           <a:prstGeom prst="roundRect">
             <a:avLst>
-              <a:gd name="adj" fmla="val 11905"/>
+              <a:gd name="adj" fmla="val 10000"/>
             </a:avLst>
           </a:prstGeom>
           <a:solidFill>
-            <a:srgbClr val="1C1518"/>
+            <a:srgbClr val="FFFFFF"/>
           </a:solidFill>
-          <a:ln/>
+          <a:ln w="12700">
+            <a:solidFill>
+              <a:srgbClr val="E3D8C7"/>
+            </a:solidFill>
+            <a:prstDash val="solid"/>
+          </a:ln>
+          <a:effectLst>
+            <a:outerShdw sx="100000" sy="100000" kx="0" ky="0" algn="bl" rotWithShape="0" blurRad="50800" dist="12700" dir="5400000">
+              <a:srgbClr val="B8A894">
+                <a:alpha val="35000"/>
+              </a:srgbClr>
+            </a:outerShdw>
+          </a:effectLst>
         </p:spPr>
       </p:sp>
       <p:pic>
@@ -5560,8 +5609,8 @@
         </p:blipFill>
         <p:spPr>
           <a:xfrm>
-            <a:off x="10332720" y="516796"/>
-            <a:ext cx="1161288" cy="264855"/>
+            <a:off x="10259568" y="507412"/>
+            <a:ext cx="1243584" cy="283624"/>
           </a:xfrm>
           <a:prstGeom prst="rect">
             <a:avLst/>
@@ -5659,9 +5708,9 @@
                 <a:solidFill>
                   <a:srgbClr val="35302B"/>
                 </a:solidFill>
-                <a:latin typeface="Century Gothic" pitchFamily="34" charset="0"/>
-                <a:ea typeface="Century Gothic" pitchFamily="34" charset="-122"/>
-                <a:cs typeface="Century Gothic" pitchFamily="34" charset="-120"/>
+                <a:latin typeface="Corbel" pitchFamily="34" charset="0"/>
+                <a:ea typeface="Corbel" pitchFamily="34" charset="-122"/>
+                <a:cs typeface="Corbel" pitchFamily="34" charset="-120"/>
               </a:rPr>
               <a:t>Award &amp; kick-off</a:t>
             </a:r>
@@ -5780,9 +5829,9 @@
                 <a:solidFill>
                   <a:srgbClr val="35302B"/>
                 </a:solidFill>
-                <a:latin typeface="Century Gothic" pitchFamily="34" charset="0"/>
-                <a:ea typeface="Century Gothic" pitchFamily="34" charset="-122"/>
-                <a:cs typeface="Century Gothic" pitchFamily="34" charset="-120"/>
+                <a:latin typeface="Corbel" pitchFamily="34" charset="0"/>
+                <a:ea typeface="Corbel" pitchFamily="34" charset="-122"/>
+                <a:cs typeface="Corbel" pitchFamily="34" charset="-120"/>
               </a:rPr>
               <a:t>Malls &amp; licences</a:t>
             </a:r>
@@ -5901,9 +5950,9 @@
                 <a:solidFill>
                   <a:srgbClr val="35302B"/>
                 </a:solidFill>
-                <a:latin typeface="Century Gothic" pitchFamily="34" charset="0"/>
-                <a:ea typeface="Century Gothic" pitchFamily="34" charset="-122"/>
-                <a:cs typeface="Century Gothic" pitchFamily="34" charset="-120"/>
+                <a:latin typeface="Corbel" pitchFamily="34" charset="0"/>
+                <a:ea typeface="Corbel" pitchFamily="34" charset="-122"/>
+                <a:cs typeface="Corbel" pitchFamily="34" charset="-120"/>
               </a:rPr>
               <a:t>Recruit &amp; BGV</a:t>
             </a:r>
@@ -6022,9 +6071,9 @@
                 <a:solidFill>
                   <a:srgbClr val="35302B"/>
                 </a:solidFill>
-                <a:latin typeface="Century Gothic" pitchFamily="34" charset="0"/>
-                <a:ea typeface="Century Gothic" pitchFamily="34" charset="-122"/>
-                <a:cs typeface="Century Gothic" pitchFamily="34" charset="-120"/>
+                <a:latin typeface="Corbel" pitchFamily="34" charset="0"/>
+                <a:ea typeface="Corbel" pitchFamily="34" charset="-122"/>
+                <a:cs typeface="Corbel" pitchFamily="34" charset="-120"/>
               </a:rPr>
               <a:t>Kiosk fit-out</a:t>
             </a:r>
@@ -6143,9 +6192,9 @@
                 <a:solidFill>
                   <a:srgbClr val="35302B"/>
                 </a:solidFill>
-                <a:latin typeface="Century Gothic" pitchFamily="34" charset="0"/>
-                <a:ea typeface="Century Gothic" pitchFamily="34" charset="-122"/>
-                <a:cs typeface="Century Gothic" pitchFamily="34" charset="-120"/>
+                <a:latin typeface="Corbel" pitchFamily="34" charset="0"/>
+                <a:ea typeface="Corbel" pitchFamily="34" charset="-122"/>
+                <a:cs typeface="Corbel" pitchFamily="34" charset="-120"/>
               </a:rPr>
               <a:t>Doft training</a:t>
             </a:r>
@@ -6264,9 +6313,9 @@
                 <a:solidFill>
                   <a:srgbClr val="35302B"/>
                 </a:solidFill>
-                <a:latin typeface="Century Gothic" pitchFamily="34" charset="0"/>
-                <a:ea typeface="Century Gothic" pitchFamily="34" charset="-122"/>
-                <a:cs typeface="Century Gothic" pitchFamily="34" charset="-120"/>
+                <a:latin typeface="Corbel" pitchFamily="34" charset="0"/>
+                <a:ea typeface="Corbel" pitchFamily="34" charset="-122"/>
+                <a:cs typeface="Corbel" pitchFamily="34" charset="-120"/>
               </a:rPr>
               <a:t>Stock &amp; first fill</a:t>
             </a:r>
@@ -6385,9 +6434,9 @@
                 <a:solidFill>
                   <a:srgbClr val="35302B"/>
                 </a:solidFill>
-                <a:latin typeface="Century Gothic" pitchFamily="34" charset="0"/>
-                <a:ea typeface="Century Gothic" pitchFamily="34" charset="-122"/>
-                <a:cs typeface="Century Gothic" pitchFamily="34" charset="-120"/>
+                <a:latin typeface="Corbel" pitchFamily="34" charset="0"/>
+                <a:ea typeface="Corbel" pitchFamily="34" charset="-122"/>
+                <a:cs typeface="Corbel" pitchFamily="34" charset="-120"/>
               </a:rPr>
               <a:t>Go-live — ops</a:t>
             </a:r>
@@ -6506,9 +6555,9 @@
                 <a:solidFill>
                   <a:srgbClr val="35302B"/>
                 </a:solidFill>
-                <a:latin typeface="Century Gothic" pitchFamily="34" charset="0"/>
-                <a:ea typeface="Century Gothic" pitchFamily="34" charset="-122"/>
-                <a:cs typeface="Century Gothic" pitchFamily="34" charset="-120"/>
+                <a:latin typeface="Corbel" pitchFamily="34" charset="0"/>
+                <a:ea typeface="Corbel" pitchFamily="34" charset="-122"/>
+                <a:cs typeface="Corbel" pitchFamily="34" charset="-120"/>
               </a:rPr>
               <a:t>Dismantle &amp; review</a:t>
             </a:r>
@@ -6588,9 +6637,9 @@
                 <a:solidFill>
                   <a:srgbClr val="8C7F72"/>
                 </a:solidFill>
-                <a:latin typeface="Century Gothic" pitchFamily="34" charset="0"/>
-                <a:ea typeface="Century Gothic" pitchFamily="34" charset="-122"/>
-                <a:cs typeface="Century Gothic" pitchFamily="34" charset="-120"/>
+                <a:latin typeface="Corbel" pitchFamily="34" charset="0"/>
+                <a:ea typeface="Corbel" pitchFamily="34" charset="-122"/>
+                <a:cs typeface="Corbel" pitchFamily="34" charset="-120"/>
               </a:rPr>
               <a:t>Relative to go-live (T). Operations run 3–5 weeks per the brief. Full per-region Gantt is in the operations workbook.</a:t>
             </a:r>
@@ -6627,9 +6676,9 @@
                 <a:solidFill>
                   <a:srgbClr val="8C7F72"/>
                 </a:solidFill>
-                <a:latin typeface="Century Gothic" pitchFamily="34" charset="0"/>
-                <a:ea typeface="Century Gothic" pitchFamily="34" charset="-122"/>
-                <a:cs typeface="Century Gothic" pitchFamily="34" charset="-120"/>
+                <a:latin typeface="Corbel" pitchFamily="34" charset="0"/>
+                <a:ea typeface="Corbel" pitchFamily="34" charset="-122"/>
+                <a:cs typeface="Corbel" pitchFamily="34" charset="-120"/>
               </a:rPr>
               <a:t>ProMarcom  ×  Doft Candles</a:t>
             </a:r>
@@ -6737,9 +6786,9 @@
                 <a:solidFill>
                   <a:srgbClr val="D9B86B"/>
                 </a:solidFill>
-                <a:latin typeface="Century Gothic" pitchFamily="34" charset="0"/>
-                <a:ea typeface="Century Gothic" pitchFamily="34" charset="-122"/>
-                <a:cs typeface="Century Gothic" pitchFamily="34" charset="-120"/>
+                <a:latin typeface="Corbel" pitchFamily="34" charset="0"/>
+                <a:ea typeface="Corbel" pitchFamily="34" charset="-122"/>
+                <a:cs typeface="Corbel" pitchFamily="34" charset="-120"/>
               </a:rPr>
               <a:t>ROLLOUT</a:t>
             </a:r>
@@ -6815,9 +6864,9 @@
                 <a:solidFill>
                   <a:srgbClr val="C9B4AC"/>
                 </a:solidFill>
-                <a:latin typeface="Century Gothic" pitchFamily="34" charset="0"/>
-                <a:ea typeface="Century Gothic" pitchFamily="34" charset="-122"/>
-                <a:cs typeface="Century Gothic" pitchFamily="34" charset="-120"/>
+                <a:latin typeface="Corbel" pitchFamily="34" charset="0"/>
+                <a:ea typeface="Corbel" pitchFamily="34" charset="-122"/>
+                <a:cs typeface="Corbel" pitchFamily="34" charset="-120"/>
               </a:rPr>
               <a:t>A starting scenario for a premium brand — fully scalable. Final cities &amp; kiosk counts are yours to set.</a:t>
             </a:r>
@@ -6920,9 +6969,9 @@
                 <a:solidFill>
                   <a:srgbClr val="D9B86B"/>
                 </a:solidFill>
-                <a:latin typeface="Century Gothic" pitchFamily="34" charset="0"/>
-                <a:ea typeface="Century Gothic" pitchFamily="34" charset="-122"/>
-                <a:cs typeface="Century Gothic" pitchFamily="34" charset="-120"/>
+                <a:latin typeface="Corbel" pitchFamily="34" charset="0"/>
+                <a:ea typeface="Corbel" pitchFamily="34" charset="-122"/>
+                <a:cs typeface="Corbel" pitchFamily="34" charset="-120"/>
               </a:rPr>
               <a:t>3 kiosks</a:t>
             </a:r>
@@ -7025,9 +7074,9 @@
                 <a:solidFill>
                   <a:srgbClr val="D9B86B"/>
                 </a:solidFill>
-                <a:latin typeface="Century Gothic" pitchFamily="34" charset="0"/>
-                <a:ea typeface="Century Gothic" pitchFamily="34" charset="-122"/>
-                <a:cs typeface="Century Gothic" pitchFamily="34" charset="-120"/>
+                <a:latin typeface="Corbel" pitchFamily="34" charset="0"/>
+                <a:ea typeface="Corbel" pitchFamily="34" charset="-122"/>
+                <a:cs typeface="Corbel" pitchFamily="34" charset="-120"/>
               </a:rPr>
               <a:t>3 kiosks</a:t>
             </a:r>
@@ -7130,9 +7179,9 @@
                 <a:solidFill>
                   <a:srgbClr val="D9B86B"/>
                 </a:solidFill>
-                <a:latin typeface="Century Gothic" pitchFamily="34" charset="0"/>
-                <a:ea typeface="Century Gothic" pitchFamily="34" charset="-122"/>
-                <a:cs typeface="Century Gothic" pitchFamily="34" charset="-120"/>
+                <a:latin typeface="Corbel" pitchFamily="34" charset="0"/>
+                <a:ea typeface="Corbel" pitchFamily="34" charset="-122"/>
+                <a:cs typeface="Corbel" pitchFamily="34" charset="-120"/>
               </a:rPr>
               <a:t>3 kiosks</a:t>
             </a:r>
@@ -7231,9 +7280,9 @@
                 <a:solidFill>
                   <a:srgbClr val="C9B4AC"/>
                 </a:solidFill>
-                <a:latin typeface="Century Gothic" pitchFamily="34" charset="0"/>
-                <a:ea typeface="Century Gothic" pitchFamily="34" charset="-122"/>
-                <a:cs typeface="Century Gothic" pitchFamily="34" charset="-120"/>
+                <a:latin typeface="Corbel" pitchFamily="34" charset="0"/>
+                <a:ea typeface="Corbel" pitchFamily="34" charset="-122"/>
+                <a:cs typeface="Corbel" pitchFamily="34" charset="-120"/>
               </a:rPr>
               <a:t>Total kiosks</a:t>
             </a:r>
@@ -7332,9 +7381,9 @@
                 <a:solidFill>
                   <a:srgbClr val="C9B4AC"/>
                 </a:solidFill>
-                <a:latin typeface="Century Gothic" pitchFamily="34" charset="0"/>
-                <a:ea typeface="Century Gothic" pitchFamily="34" charset="-122"/>
-                <a:cs typeface="Century Gothic" pitchFamily="34" charset="-120"/>
+                <a:latin typeface="Corbel" pitchFamily="34" charset="0"/>
+                <a:ea typeface="Corbel" pitchFamily="34" charset="-122"/>
+                <a:cs typeface="Corbel" pitchFamily="34" charset="-120"/>
               </a:rPr>
               <a:t>Trained staff</a:t>
             </a:r>
@@ -7433,9 +7482,9 @@
                 <a:solidFill>
                   <a:srgbClr val="C9B4AC"/>
                 </a:solidFill>
-                <a:latin typeface="Century Gothic" pitchFamily="34" charset="0"/>
-                <a:ea typeface="Century Gothic" pitchFamily="34" charset="-122"/>
-                <a:cs typeface="Century Gothic" pitchFamily="34" charset="-120"/>
+                <a:latin typeface="Corbel" pitchFamily="34" charset="0"/>
+                <a:ea typeface="Corbel" pitchFamily="34" charset="-122"/>
+                <a:cs typeface="Corbel" pitchFamily="34" charset="-120"/>
               </a:rPr>
               <a:t>Operating window</a:t>
             </a:r>
@@ -7534,9 +7583,9 @@
                 <a:solidFill>
                   <a:srgbClr val="C9B4AC"/>
                 </a:solidFill>
-                <a:latin typeface="Century Gothic" pitchFamily="34" charset="0"/>
-                <a:ea typeface="Century Gothic" pitchFamily="34" charset="-122"/>
-                <a:cs typeface="Century Gothic" pitchFamily="34" charset="-120"/>
+                <a:latin typeface="Corbel" pitchFamily="34" charset="0"/>
+                <a:ea typeface="Corbel" pitchFamily="34" charset="-122"/>
+                <a:cs typeface="Corbel" pitchFamily="34" charset="-120"/>
               </a:rPr>
               <a:t>Committed through</a:t>
             </a:r>
@@ -7573,9 +7622,9 @@
                 <a:solidFill>
                   <a:srgbClr val="C9B4AC"/>
                 </a:solidFill>
-                <a:latin typeface="Century Gothic" pitchFamily="34" charset="0"/>
-                <a:ea typeface="Century Gothic" pitchFamily="34" charset="-122"/>
-                <a:cs typeface="Century Gothic" pitchFamily="34" charset="-120"/>
+                <a:latin typeface="Corbel" pitchFamily="34" charset="0"/>
+                <a:ea typeface="Corbel" pitchFamily="34" charset="-122"/>
+                <a:cs typeface="Corbel" pitchFamily="34" charset="-120"/>
               </a:rPr>
               <a:t>Scenario only — the brief specifies 2–4 pop-ups per region across multiple cities. Change two inputs in the workbook to re-scope.</a:t>
             </a:r>
@@ -7612,9 +7661,9 @@
                 <a:solidFill>
                   <a:srgbClr val="C9B4AC"/>
                 </a:solidFill>
-                <a:latin typeface="Century Gothic" pitchFamily="34" charset="0"/>
-                <a:ea typeface="Century Gothic" pitchFamily="34" charset="-122"/>
-                <a:cs typeface="Century Gothic" pitchFamily="34" charset="-120"/>
+                <a:latin typeface="Corbel" pitchFamily="34" charset="0"/>
+                <a:ea typeface="Corbel" pitchFamily="34" charset="-122"/>
+                <a:cs typeface="Corbel" pitchFamily="34" charset="-120"/>
               </a:rPr>
               <a:t>ProMarcom  ×  Doft Candles</a:t>
             </a:r>
@@ -7722,9 +7771,9 @@
                 <a:solidFill>
                   <a:srgbClr val="B8924A"/>
                 </a:solidFill>
-                <a:latin typeface="Century Gothic" pitchFamily="34" charset="0"/>
-                <a:ea typeface="Century Gothic" pitchFamily="34" charset="-122"/>
-                <a:cs typeface="Century Gothic" pitchFamily="34" charset="-120"/>
+                <a:latin typeface="Corbel" pitchFamily="34" charset="0"/>
+                <a:ea typeface="Corbel" pitchFamily="34" charset="-122"/>
+                <a:cs typeface="Corbel" pitchFamily="34" charset="-120"/>
               </a:rPr>
               <a:t>COMMERCIALS</a:t>
             </a:r>
@@ -7779,18 +7828,30 @@
         </p:nvSpPr>
         <p:spPr>
           <a:xfrm>
-            <a:off x="10204704" y="457200"/>
-            <a:ext cx="1417320" cy="384048"/>
+            <a:off x="10140696" y="420624"/>
+            <a:ext cx="1481328" cy="457200"/>
           </a:xfrm>
           <a:prstGeom prst="roundRect">
             <a:avLst>
-              <a:gd name="adj" fmla="val 11905"/>
+              <a:gd name="adj" fmla="val 10000"/>
             </a:avLst>
           </a:prstGeom>
           <a:solidFill>
-            <a:srgbClr val="1C1518"/>
+            <a:srgbClr val="FFFFFF"/>
           </a:solidFill>
-          <a:ln/>
+          <a:ln w="12700">
+            <a:solidFill>
+              <a:srgbClr val="E3D8C7"/>
+            </a:solidFill>
+            <a:prstDash val="solid"/>
+          </a:ln>
+          <a:effectLst>
+            <a:outerShdw sx="100000" sy="100000" kx="0" ky="0" algn="bl" rotWithShape="0" blurRad="50800" dist="12700" dir="5400000">
+              <a:srgbClr val="B8A894">
+                <a:alpha val="35000"/>
+              </a:srgbClr>
+            </a:outerShdw>
+          </a:effectLst>
         </p:spPr>
       </p:sp>
       <p:pic>
@@ -7809,8 +7870,8 @@
         </p:blipFill>
         <p:spPr>
           <a:xfrm>
-            <a:off x="10332720" y="516796"/>
-            <a:ext cx="1161288" cy="264855"/>
+            <a:off x="10259568" y="507412"/>
+            <a:ext cx="1243584" cy="283624"/>
           </a:xfrm>
           <a:prstGeom prst="rect">
             <a:avLst/>
@@ -7846,9 +7907,9 @@
                 <a:solidFill>
                   <a:srgbClr val="8C7F72"/>
                 </a:solidFill>
-                <a:latin typeface="Century Gothic" pitchFamily="34" charset="0"/>
-                <a:ea typeface="Century Gothic" pitchFamily="34" charset="-122"/>
-                <a:cs typeface="Century Gothic" pitchFamily="34" charset="-120"/>
+                <a:latin typeface="Corbel" pitchFamily="34" charset="0"/>
+                <a:ea typeface="Corbel" pitchFamily="34" charset="-122"/>
+                <a:cs typeface="Corbel" pitchFamily="34" charset="-120"/>
               </a:rPr>
               <a:t>Priced bottom-up per kiosk, then rolled up. Every line is an editable input in the workbook.</a:t>
             </a:r>
@@ -7928,9 +7989,9 @@
                 <a:solidFill>
                   <a:srgbClr val="35302B"/>
                 </a:solidFill>
-                <a:latin typeface="Century Gothic" pitchFamily="34" charset="0"/>
-                <a:ea typeface="Century Gothic" pitchFamily="34" charset="-122"/>
-                <a:cs typeface="Century Gothic" pitchFamily="34" charset="-120"/>
+                <a:latin typeface="Corbel" pitchFamily="34" charset="0"/>
+                <a:ea typeface="Corbel" pitchFamily="34" charset="-122"/>
+                <a:cs typeface="Corbel" pitchFamily="34" charset="-120"/>
               </a:rPr>
               <a:t>Direct cost / kiosk</a:t>
             </a:r>
@@ -8033,9 +8094,9 @@
                 <a:solidFill>
                   <a:srgbClr val="35302B"/>
                 </a:solidFill>
-                <a:latin typeface="Century Gothic" pitchFamily="34" charset="0"/>
-                <a:ea typeface="Century Gothic" pitchFamily="34" charset="-122"/>
-                <a:cs typeface="Century Gothic" pitchFamily="34" charset="-120"/>
+                <a:latin typeface="Corbel" pitchFamily="34" charset="0"/>
+                <a:ea typeface="Corbel" pitchFamily="34" charset="-122"/>
+                <a:cs typeface="Corbel" pitchFamily="34" charset="-120"/>
               </a:rPr>
               <a:t>+ Management margin (15%)</a:t>
             </a:r>
@@ -8138,9 +8199,9 @@
                 <a:solidFill>
                   <a:srgbClr val="35302B"/>
                 </a:solidFill>
-                <a:latin typeface="Century Gothic" pitchFamily="34" charset="0"/>
-                <a:ea typeface="Century Gothic" pitchFamily="34" charset="-122"/>
-                <a:cs typeface="Century Gothic" pitchFamily="34" charset="-120"/>
+                <a:latin typeface="Corbel" pitchFamily="34" charset="0"/>
+                <a:ea typeface="Corbel" pitchFamily="34" charset="-122"/>
+                <a:cs typeface="Corbel" pitchFamily="34" charset="-120"/>
               </a:rPr>
               <a:t>Contract value / kiosk (pre-GST)</a:t>
             </a:r>
@@ -8243,9 +8304,9 @@
                 <a:solidFill>
                   <a:srgbClr val="35302B"/>
                 </a:solidFill>
-                <a:latin typeface="Century Gothic" pitchFamily="34" charset="0"/>
-                <a:ea typeface="Century Gothic" pitchFamily="34" charset="-122"/>
-                <a:cs typeface="Century Gothic" pitchFamily="34" charset="-120"/>
+                <a:latin typeface="Corbel" pitchFamily="34" charset="0"/>
+                <a:ea typeface="Corbel" pitchFamily="34" charset="-122"/>
+                <a:cs typeface="Corbel" pitchFamily="34" charset="-120"/>
               </a:rPr>
               <a:t>× 9 kiosks (illustrative)</a:t>
             </a:r>
@@ -8348,9 +8409,9 @@
                 <a:solidFill>
                   <a:srgbClr val="35302B"/>
                 </a:solidFill>
-                <a:latin typeface="Century Gothic" pitchFamily="34" charset="0"/>
-                <a:ea typeface="Century Gothic" pitchFamily="34" charset="-122"/>
-                <a:cs typeface="Century Gothic" pitchFamily="34" charset="-120"/>
+                <a:latin typeface="Corbel" pitchFamily="34" charset="0"/>
+                <a:ea typeface="Corbel" pitchFamily="34" charset="-122"/>
+                <a:cs typeface="Corbel" pitchFamily="34" charset="-120"/>
               </a:rPr>
               <a:t>+ GST (18%)</a:t>
             </a:r>
@@ -8453,9 +8514,9 @@
                 <a:solidFill>
                   <a:srgbClr val="F3ECE0"/>
                 </a:solidFill>
-                <a:latin typeface="Century Gothic" pitchFamily="34" charset="0"/>
-                <a:ea typeface="Century Gothic" pitchFamily="34" charset="-122"/>
-                <a:cs typeface="Century Gothic" pitchFamily="34" charset="-120"/>
+                <a:latin typeface="Corbel" pitchFamily="34" charset="0"/>
+                <a:ea typeface="Corbel" pitchFamily="34" charset="-122"/>
+                <a:cs typeface="Corbel" pitchFamily="34" charset="-120"/>
               </a:rPr>
               <a:t>Total programme (incl. GST)</a:t>
             </a:r>
@@ -8531,9 +8592,9 @@
                 <a:solidFill>
                   <a:srgbClr val="8C7F72"/>
                 </a:solidFill>
-                <a:latin typeface="Century Gothic" pitchFamily="34" charset="0"/>
-                <a:ea typeface="Century Gothic" pitchFamily="34" charset="-122"/>
-                <a:cs typeface="Century Gothic" pitchFamily="34" charset="-120"/>
+                <a:latin typeface="Corbel" pitchFamily="34" charset="0"/>
+                <a:ea typeface="Corbel" pitchFamily="34" charset="-122"/>
+                <a:cs typeface="Corbel" pitchFamily="34" charset="-120"/>
               </a:rPr>
               <a:t>* Mall licence / space fee is the biggest swing item and is often reimbursed by the brand. Figures illustrative at placeholder rates.</a:t>
             </a:r>
@@ -8570,9 +8631,9 @@
                 <a:solidFill>
                   <a:srgbClr val="8C7F72"/>
                 </a:solidFill>
-                <a:latin typeface="Century Gothic" pitchFamily="34" charset="0"/>
-                <a:ea typeface="Century Gothic" pitchFamily="34" charset="-122"/>
-                <a:cs typeface="Century Gothic" pitchFamily="34" charset="-120"/>
+                <a:latin typeface="Corbel" pitchFamily="34" charset="0"/>
+                <a:ea typeface="Corbel" pitchFamily="34" charset="-122"/>
+                <a:cs typeface="Corbel" pitchFamily="34" charset="-120"/>
               </a:rPr>
               <a:t>ProMarcom  ×  Doft Candles</a:t>
             </a:r>
@@ -8680,9 +8741,9 @@
                 <a:solidFill>
                   <a:srgbClr val="B8924A"/>
                 </a:solidFill>
-                <a:latin typeface="Century Gothic" pitchFamily="34" charset="0"/>
-                <a:ea typeface="Century Gothic" pitchFamily="34" charset="-122"/>
-                <a:cs typeface="Century Gothic" pitchFamily="34" charset="-120"/>
+                <a:latin typeface="Corbel" pitchFamily="34" charset="0"/>
+                <a:ea typeface="Corbel" pitchFamily="34" charset="-122"/>
+                <a:cs typeface="Corbel" pitchFamily="34" charset="-120"/>
               </a:rPr>
               <a:t>ASSURANCE</a:t>
             </a:r>
@@ -8737,18 +8798,30 @@
         </p:nvSpPr>
         <p:spPr>
           <a:xfrm>
-            <a:off x="10204704" y="457200"/>
-            <a:ext cx="1417320" cy="384048"/>
+            <a:off x="10140696" y="420624"/>
+            <a:ext cx="1481328" cy="457200"/>
           </a:xfrm>
           <a:prstGeom prst="roundRect">
             <a:avLst>
-              <a:gd name="adj" fmla="val 11905"/>
+              <a:gd name="adj" fmla="val 10000"/>
             </a:avLst>
           </a:prstGeom>
           <a:solidFill>
-            <a:srgbClr val="1C1518"/>
+            <a:srgbClr val="FFFFFF"/>
           </a:solidFill>
-          <a:ln/>
+          <a:ln w="12700">
+            <a:solidFill>
+              <a:srgbClr val="E3D8C7"/>
+            </a:solidFill>
+            <a:prstDash val="solid"/>
+          </a:ln>
+          <a:effectLst>
+            <a:outerShdw sx="100000" sy="100000" kx="0" ky="0" algn="bl" rotWithShape="0" blurRad="50800" dist="12700" dir="5400000">
+              <a:srgbClr val="B8A894">
+                <a:alpha val="35000"/>
+              </a:srgbClr>
+            </a:outerShdw>
+          </a:effectLst>
         </p:spPr>
       </p:sp>
       <p:pic>
@@ -8767,8 +8840,8 @@
         </p:blipFill>
         <p:spPr>
           <a:xfrm>
-            <a:off x="10332720" y="516796"/>
-            <a:ext cx="1161288" cy="264855"/>
+            <a:off x="10259568" y="507412"/>
+            <a:ext cx="1243584" cy="283624"/>
           </a:xfrm>
           <a:prstGeom prst="rect">
             <a:avLst/>
@@ -8844,9 +8917,9 @@
                 <a:solidFill>
                   <a:srgbClr val="D9B86B"/>
                 </a:solidFill>
-                <a:latin typeface="Century Gothic" pitchFamily="34" charset="0"/>
-                <a:ea typeface="Century Gothic" pitchFamily="34" charset="-122"/>
-                <a:cs typeface="Century Gothic" pitchFamily="34" charset="-120"/>
+                <a:latin typeface="Corbel" pitchFamily="34" charset="0"/>
+                <a:ea typeface="Corbel" pitchFamily="34" charset="-122"/>
+                <a:cs typeface="Corbel" pitchFamily="34" charset="-120"/>
               </a:rPr>
               <a:t>RISK</a:t>
             </a:r>
@@ -8883,9 +8956,9 @@
                 <a:solidFill>
                   <a:srgbClr val="D9B86B"/>
                 </a:solidFill>
-                <a:latin typeface="Century Gothic" pitchFamily="34" charset="0"/>
-                <a:ea typeface="Century Gothic" pitchFamily="34" charset="-122"/>
-                <a:cs typeface="Century Gothic" pitchFamily="34" charset="-120"/>
+                <a:latin typeface="Corbel" pitchFamily="34" charset="0"/>
+                <a:ea typeface="Corbel" pitchFamily="34" charset="-122"/>
+                <a:cs typeface="Corbel" pitchFamily="34" charset="-120"/>
               </a:rPr>
               <a:t>MITIGATION</a:t>
             </a:r>
@@ -8986,9 +9059,9 @@
                 <a:solidFill>
                   <a:srgbClr val="35302B"/>
                 </a:solidFill>
-                <a:latin typeface="Century Gothic" pitchFamily="34" charset="0"/>
-                <a:ea typeface="Century Gothic" pitchFamily="34" charset="-122"/>
-                <a:cs typeface="Century Gothic" pitchFamily="34" charset="-120"/>
+                <a:latin typeface="Corbel" pitchFamily="34" charset="0"/>
+                <a:ea typeface="Corbel" pitchFamily="34" charset="-122"/>
+                <a:cs typeface="Corbel" pitchFamily="34" charset="-120"/>
               </a:rPr>
               <a:t>15% trained bench; same-day no-cost replacement</a:t>
             </a:r>
@@ -9089,9 +9162,9 @@
                 <a:solidFill>
                   <a:srgbClr val="35302B"/>
                 </a:solidFill>
-                <a:latin typeface="Century Gothic" pitchFamily="34" charset="0"/>
-                <a:ea typeface="Century Gothic" pitchFamily="34" charset="-122"/>
-                <a:cs typeface="Century Gothic" pitchFamily="34" charset="-120"/>
+                <a:latin typeface="Corbel" pitchFamily="34" charset="0"/>
+                <a:ea typeface="Corbel" pitchFamily="34" charset="-122"/>
+                <a:cs typeface="Corbel" pitchFamily="34" charset="-120"/>
               </a:rPr>
               <a:t>Licensing kicked off at T-7w; parallel mall shortlist</a:t>
             </a:r>
@@ -9192,9 +9265,9 @@
                 <a:solidFill>
                   <a:srgbClr val="35302B"/>
                 </a:solidFill>
-                <a:latin typeface="Century Gothic" pitchFamily="34" charset="0"/>
-                <a:ea typeface="Century Gothic" pitchFamily="34" charset="-122"/>
-                <a:cs typeface="Century Gothic" pitchFamily="34" charset="-120"/>
+                <a:latin typeface="Corbel" pitchFamily="34" charset="0"/>
+                <a:ea typeface="Corbel" pitchFamily="34" charset="-122"/>
+                <a:cs typeface="Corbel" pitchFamily="34" charset="-120"/>
               </a:rPr>
               <a:t>Reorder levels + daily replenishment from stockroom</a:t>
             </a:r>
@@ -9295,9 +9368,9 @@
                 <a:solidFill>
                   <a:srgbClr val="35302B"/>
                 </a:solidFill>
-                <a:latin typeface="Century Gothic" pitchFamily="34" charset="0"/>
-                <a:ea typeface="Century Gothic" pitchFamily="34" charset="-122"/>
-                <a:cs typeface="Century Gothic" pitchFamily="34" charset="-120"/>
+                <a:latin typeface="Corbel" pitchFamily="34" charset="0"/>
+                <a:ea typeface="Corbel" pitchFamily="34" charset="-122"/>
+                <a:cs typeface="Corbel" pitchFamily="34" charset="-120"/>
               </a:rPr>
               <a:t>Backup EDC + connectivity failover; trained cashier</a:t>
             </a:r>
@@ -9398,9 +9471,9 @@
                 <a:solidFill>
                   <a:srgbClr val="35302B"/>
                 </a:solidFill>
-                <a:latin typeface="Century Gothic" pitchFamily="34" charset="0"/>
-                <a:ea typeface="Century Gothic" pitchFamily="34" charset="-122"/>
-                <a:cs typeface="Century Gothic" pitchFamily="34" charset="-120"/>
+                <a:latin typeface="Corbel" pitchFamily="34" charset="0"/>
+                <a:ea typeface="Corbel" pitchFamily="34" charset="-122"/>
+                <a:cs typeface="Corbel" pitchFamily="34" charset="-120"/>
               </a:rPr>
               <a:t>Vendor SLA + 3-day buffer before go-live</a:t>
             </a:r>
@@ -9437,9 +9510,9 @@
                 <a:solidFill>
                   <a:srgbClr val="8C7F72"/>
                 </a:solidFill>
-                <a:latin typeface="Century Gothic" pitchFamily="34" charset="0"/>
-                <a:ea typeface="Century Gothic" pitchFamily="34" charset="-122"/>
-                <a:cs typeface="Century Gothic" pitchFamily="34" charset="-120"/>
+                <a:latin typeface="Corbel" pitchFamily="34" charset="0"/>
+                <a:ea typeface="Corbel" pitchFamily="34" charset="-122"/>
+                <a:cs typeface="Corbel" pitchFamily="34" charset="-120"/>
               </a:rPr>
               <a:t>ProMarcom  ×  Doft Candles</a:t>
             </a:r>
@@ -9547,9 +9620,9 @@
                 <a:solidFill>
                   <a:srgbClr val="B8924A"/>
                 </a:solidFill>
-                <a:latin typeface="Century Gothic" pitchFamily="34" charset="0"/>
-                <a:ea typeface="Century Gothic" pitchFamily="34" charset="-122"/>
-                <a:cs typeface="Century Gothic" pitchFamily="34" charset="-120"/>
+                <a:latin typeface="Corbel" pitchFamily="34" charset="0"/>
+                <a:ea typeface="Corbel" pitchFamily="34" charset="-122"/>
+                <a:cs typeface="Corbel" pitchFamily="34" charset="-120"/>
               </a:rPr>
               <a:t>TOOLKIT</a:t>
             </a:r>
@@ -9604,18 +9677,30 @@
         </p:nvSpPr>
         <p:spPr>
           <a:xfrm>
-            <a:off x="10204704" y="457200"/>
-            <a:ext cx="1417320" cy="384048"/>
+            <a:off x="10140696" y="420624"/>
+            <a:ext cx="1481328" cy="457200"/>
           </a:xfrm>
           <a:prstGeom prst="roundRect">
             <a:avLst>
-              <a:gd name="adj" fmla="val 11905"/>
+              <a:gd name="adj" fmla="val 10000"/>
             </a:avLst>
           </a:prstGeom>
           <a:solidFill>
-            <a:srgbClr val="1C1518"/>
+            <a:srgbClr val="FFFFFF"/>
           </a:solidFill>
-          <a:ln/>
+          <a:ln w="12700">
+            <a:solidFill>
+              <a:srgbClr val="E3D8C7"/>
+            </a:solidFill>
+            <a:prstDash val="solid"/>
+          </a:ln>
+          <a:effectLst>
+            <a:outerShdw sx="100000" sy="100000" kx="0" ky="0" algn="bl" rotWithShape="0" blurRad="50800" dist="12700" dir="5400000">
+              <a:srgbClr val="B8A894">
+                <a:alpha val="35000"/>
+              </a:srgbClr>
+            </a:outerShdw>
+          </a:effectLst>
         </p:spPr>
       </p:sp>
       <p:pic>
@@ -9634,8 +9719,8 @@
         </p:blipFill>
         <p:spPr>
           <a:xfrm>
-            <a:off x="10332720" y="516796"/>
-            <a:ext cx="1161288" cy="264855"/>
+            <a:off x="10259568" y="507412"/>
+            <a:ext cx="1243584" cy="283624"/>
           </a:xfrm>
           <a:prstGeom prst="rect">
             <a:avLst/>
@@ -9671,9 +9756,9 @@
                 <a:solidFill>
                   <a:srgbClr val="8C7F72"/>
                 </a:solidFill>
-                <a:latin typeface="Century Gothic" pitchFamily="34" charset="0"/>
-                <a:ea typeface="Century Gothic" pitchFamily="34" charset="-122"/>
-                <a:cs typeface="Century Gothic" pitchFamily="34" charset="-120"/>
+                <a:latin typeface="Corbel" pitchFamily="34" charset="0"/>
+                <a:ea typeface="Corbel" pitchFamily="34" charset="-122"/>
+                <a:cs typeface="Corbel" pitchFamily="34" charset="-120"/>
               </a:rPr>
               <a:t>This deck ships with a live Excel workbook — the operating system for the engagement. Edit the assumptions; everything recalculates.</a:t>
             </a:r>
@@ -9776,9 +9861,9 @@
                 <a:solidFill>
                   <a:srgbClr val="35302B"/>
                 </a:solidFill>
-                <a:latin typeface="Century Gothic" pitchFamily="34" charset="0"/>
-                <a:ea typeface="Century Gothic" pitchFamily="34" charset="-122"/>
-                <a:cs typeface="Century Gothic" pitchFamily="34" charset="-120"/>
+                <a:latin typeface="Corbel" pitchFamily="34" charset="0"/>
+                <a:ea typeface="Corbel" pitchFamily="34" charset="-122"/>
+                <a:cs typeface="Corbel" pitchFamily="34" charset="-120"/>
               </a:rPr>
               <a:t>Assumptions</a:t>
             </a:r>
@@ -9881,9 +9966,9 @@
                 <a:solidFill>
                   <a:srgbClr val="35302B"/>
                 </a:solidFill>
-                <a:latin typeface="Century Gothic" pitchFamily="34" charset="0"/>
-                <a:ea typeface="Century Gothic" pitchFamily="34" charset="-122"/>
-                <a:cs typeface="Century Gothic" pitchFamily="34" charset="-120"/>
+                <a:latin typeface="Corbel" pitchFamily="34" charset="0"/>
+                <a:ea typeface="Corbel" pitchFamily="34" charset="-122"/>
+                <a:cs typeface="Corbel" pitchFamily="34" charset="-120"/>
               </a:rPr>
               <a:t>Project Timeline</a:t>
             </a:r>
@@ -9986,9 +10071,9 @@
                 <a:solidFill>
                   <a:srgbClr val="35302B"/>
                 </a:solidFill>
-                <a:latin typeface="Century Gothic" pitchFamily="34" charset="0"/>
-                <a:ea typeface="Century Gothic" pitchFamily="34" charset="-122"/>
-                <a:cs typeface="Century Gothic" pitchFamily="34" charset="-120"/>
+                <a:latin typeface="Corbel" pitchFamily="34" charset="0"/>
+                <a:ea typeface="Corbel" pitchFamily="34" charset="-122"/>
+                <a:cs typeface="Corbel" pitchFamily="34" charset="-120"/>
               </a:rPr>
               <a:t>Staffing Plan</a:t>
             </a:r>
@@ -10091,9 +10176,9 @@
                 <a:solidFill>
                   <a:srgbClr val="35302B"/>
                 </a:solidFill>
-                <a:latin typeface="Century Gothic" pitchFamily="34" charset="0"/>
-                <a:ea typeface="Century Gothic" pitchFamily="34" charset="-122"/>
-                <a:cs typeface="Century Gothic" pitchFamily="34" charset="-120"/>
+                <a:latin typeface="Corbel" pitchFamily="34" charset="0"/>
+                <a:ea typeface="Corbel" pitchFamily="34" charset="-122"/>
+                <a:cs typeface="Corbel" pitchFamily="34" charset="-120"/>
               </a:rPr>
               <a:t>Manpower Cost</a:t>
             </a:r>
@@ -10196,9 +10281,9 @@
                 <a:solidFill>
                   <a:srgbClr val="35302B"/>
                 </a:solidFill>
-                <a:latin typeface="Century Gothic" pitchFamily="34" charset="0"/>
-                <a:ea typeface="Century Gothic" pitchFamily="34" charset="-122"/>
-                <a:cs typeface="Century Gothic" pitchFamily="34" charset="-120"/>
+                <a:latin typeface="Corbel" pitchFamily="34" charset="0"/>
+                <a:ea typeface="Corbel" pitchFamily="34" charset="-122"/>
+                <a:cs typeface="Corbel" pitchFamily="34" charset="-120"/>
               </a:rPr>
               <a:t>Budget Summary</a:t>
             </a:r>
@@ -10301,9 +10386,9 @@
                 <a:solidFill>
                   <a:srgbClr val="35302B"/>
                 </a:solidFill>
-                <a:latin typeface="Century Gothic" pitchFamily="34" charset="0"/>
-                <a:ea typeface="Century Gothic" pitchFamily="34" charset="-122"/>
-                <a:cs typeface="Century Gothic" pitchFamily="34" charset="-120"/>
+                <a:latin typeface="Corbel" pitchFamily="34" charset="0"/>
+                <a:ea typeface="Corbel" pitchFamily="34" charset="-122"/>
+                <a:cs typeface="Corbel" pitchFamily="34" charset="-120"/>
               </a:rPr>
               <a:t>Recruitment Tracker</a:t>
             </a:r>
@@ -10406,9 +10491,9 @@
                 <a:solidFill>
                   <a:srgbClr val="35302B"/>
                 </a:solidFill>
-                <a:latin typeface="Century Gothic" pitchFamily="34" charset="0"/>
-                <a:ea typeface="Century Gothic" pitchFamily="34" charset="-122"/>
-                <a:cs typeface="Century Gothic" pitchFamily="34" charset="-120"/>
+                <a:latin typeface="Corbel" pitchFamily="34" charset="0"/>
+                <a:ea typeface="Corbel" pitchFamily="34" charset="-122"/>
+                <a:cs typeface="Corbel" pitchFamily="34" charset="-120"/>
               </a:rPr>
               <a:t>Attendance</a:t>
             </a:r>
@@ -10511,9 +10596,9 @@
                 <a:solidFill>
                   <a:srgbClr val="35302B"/>
                 </a:solidFill>
-                <a:latin typeface="Century Gothic" pitchFamily="34" charset="0"/>
-                <a:ea typeface="Century Gothic" pitchFamily="34" charset="-122"/>
-                <a:cs typeface="Century Gothic" pitchFamily="34" charset="-120"/>
+                <a:latin typeface="Corbel" pitchFamily="34" charset="0"/>
+                <a:ea typeface="Corbel" pitchFamily="34" charset="-122"/>
+                <a:cs typeface="Corbel" pitchFamily="34" charset="-120"/>
               </a:rPr>
               <a:t>Daily Sales</a:t>
             </a:r>
@@ -10616,9 +10701,9 @@
                 <a:solidFill>
                   <a:srgbClr val="35302B"/>
                 </a:solidFill>
-                <a:latin typeface="Century Gothic" pitchFamily="34" charset="0"/>
-                <a:ea typeface="Century Gothic" pitchFamily="34" charset="-122"/>
-                <a:cs typeface="Century Gothic" pitchFamily="34" charset="-120"/>
+                <a:latin typeface="Corbel" pitchFamily="34" charset="0"/>
+                <a:ea typeface="Corbel" pitchFamily="34" charset="-122"/>
+                <a:cs typeface="Corbel" pitchFamily="34" charset="-120"/>
               </a:rPr>
               <a:t>Inventory &amp; Replenish</a:t>
             </a:r>
@@ -10721,9 +10806,9 @@
                 <a:solidFill>
                   <a:srgbClr val="35302B"/>
                 </a:solidFill>
-                <a:latin typeface="Century Gothic" pitchFamily="34" charset="0"/>
-                <a:ea typeface="Century Gothic" pitchFamily="34" charset="-122"/>
-                <a:cs typeface="Century Gothic" pitchFamily="34" charset="-120"/>
+                <a:latin typeface="Corbel" pitchFamily="34" charset="0"/>
+                <a:ea typeface="Corbel" pitchFamily="34" charset="-122"/>
+                <a:cs typeface="Corbel" pitchFamily="34" charset="-120"/>
               </a:rPr>
               <a:t>Footfall &amp; Conversion</a:t>
             </a:r>
@@ -10826,9 +10911,9 @@
                 <a:solidFill>
                   <a:srgbClr val="35302B"/>
                 </a:solidFill>
-                <a:latin typeface="Century Gothic" pitchFamily="34" charset="0"/>
-                <a:ea typeface="Century Gothic" pitchFamily="34" charset="-122"/>
-                <a:cs typeface="Century Gothic" pitchFamily="34" charset="-120"/>
+                <a:latin typeface="Corbel" pitchFamily="34" charset="0"/>
+                <a:ea typeface="Corbel" pitchFamily="34" charset="-122"/>
+                <a:cs typeface="Corbel" pitchFamily="34" charset="-120"/>
               </a:rPr>
               <a:t>Customer Feedback</a:t>
             </a:r>
@@ -10931,9 +11016,9 @@
                 <a:solidFill>
                   <a:srgbClr val="35302B"/>
                 </a:solidFill>
-                <a:latin typeface="Century Gothic" pitchFamily="34" charset="0"/>
-                <a:ea typeface="Century Gothic" pitchFamily="34" charset="-122"/>
-                <a:cs typeface="Century Gothic" pitchFamily="34" charset="-120"/>
+                <a:latin typeface="Corbel" pitchFamily="34" charset="0"/>
+                <a:ea typeface="Corbel" pitchFamily="34" charset="-122"/>
+                <a:cs typeface="Corbel" pitchFamily="34" charset="-120"/>
               </a:rPr>
               <a:t>Compliance Checklist</a:t>
             </a:r>
@@ -11036,9 +11121,9 @@
                 <a:solidFill>
                   <a:srgbClr val="35302B"/>
                 </a:solidFill>
-                <a:latin typeface="Century Gothic" pitchFamily="34" charset="0"/>
-                <a:ea typeface="Century Gothic" pitchFamily="34" charset="-122"/>
-                <a:cs typeface="Century Gothic" pitchFamily="34" charset="-120"/>
+                <a:latin typeface="Corbel" pitchFamily="34" charset="0"/>
+                <a:ea typeface="Corbel" pitchFamily="34" charset="-122"/>
+                <a:cs typeface="Corbel" pitchFamily="34" charset="-120"/>
               </a:rPr>
               <a:t>Risk Register</a:t>
             </a:r>
@@ -11075,9 +11160,9 @@
                 <a:solidFill>
                   <a:srgbClr val="8C7F72"/>
                 </a:solidFill>
-                <a:latin typeface="Century Gothic" pitchFamily="34" charset="0"/>
-                <a:ea typeface="Century Gothic" pitchFamily="34" charset="-122"/>
-                <a:cs typeface="Century Gothic" pitchFamily="34" charset="-120"/>
+                <a:latin typeface="Corbel" pitchFamily="34" charset="0"/>
+                <a:ea typeface="Corbel" pitchFamily="34" charset="-122"/>
+                <a:cs typeface="Corbel" pitchFamily="34" charset="-120"/>
               </a:rPr>
               <a:t>ProMarcom  ×  Doft Candles</a:t>
             </a:r>
@@ -11269,9 +11354,9 @@
                 <a:solidFill>
                   <a:srgbClr val="C9B4AC"/>
                 </a:solidFill>
-                <a:latin typeface="Century Gothic" pitchFamily="34" charset="0"/>
-                <a:ea typeface="Century Gothic" pitchFamily="34" charset="-122"/>
-                <a:cs typeface="Century Gothic" pitchFamily="34" charset="-120"/>
+                <a:latin typeface="Corbel" pitchFamily="34" charset="0"/>
+                <a:ea typeface="Corbel" pitchFamily="34" charset="-122"/>
+                <a:cs typeface="Corbel" pitchFamily="34" charset="-120"/>
               </a:rPr>
               <a:t>A premium retail partner with proven mall, VM and multi-city manpower experience — committed to Doft for Diwali 2026, 2027 and 2028.</a:t>
             </a:r>
@@ -11331,9 +11416,9 @@
                 <a:solidFill>
                   <a:srgbClr val="C9B4AC"/>
                 </a:solidFill>
-                <a:latin typeface="Century Gothic" pitchFamily="34" charset="0"/>
-                <a:ea typeface="Century Gothic" pitchFamily="34" charset="-122"/>
-                <a:cs typeface="Century Gothic" pitchFamily="34" charset="-120"/>
+                <a:latin typeface="Corbel" pitchFamily="34" charset="0"/>
+                <a:ea typeface="Corbel" pitchFamily="34" charset="-122"/>
+                <a:cs typeface="Corbel" pitchFamily="34" charset="-120"/>
               </a:rPr>
               <a:t>Prepared by</a:t>
             </a:r>
@@ -11350,17 +11435,29 @@
         <p:spPr>
           <a:xfrm>
             <a:off x="1572768" y="4023360"/>
-            <a:ext cx="1645920" cy="384048"/>
+            <a:ext cx="1645920" cy="457200"/>
           </a:xfrm>
           <a:prstGeom prst="roundRect">
             <a:avLst>
-              <a:gd name="adj" fmla="val 11905"/>
+              <a:gd name="adj" fmla="val 10000"/>
             </a:avLst>
           </a:prstGeom>
           <a:solidFill>
-            <a:srgbClr val="1C1518"/>
+            <a:srgbClr val="FFFFFF"/>
           </a:solidFill>
-          <a:ln/>
+          <a:ln w="12700">
+            <a:solidFill>
+              <a:srgbClr val="E3D8C7"/>
+            </a:solidFill>
+            <a:prstDash val="solid"/>
+          </a:ln>
+          <a:effectLst>
+            <a:outerShdw sx="100000" sy="100000" kx="0" ky="0" algn="bl" rotWithShape="0" blurRad="50800" dist="12700" dir="5400000">
+              <a:srgbClr val="B8A894">
+                <a:alpha val="35000"/>
+              </a:srgbClr>
+            </a:outerShdw>
+          </a:effectLst>
         </p:spPr>
       </p:sp>
       <p:pic>
@@ -11379,8 +11476,8 @@
         </p:blipFill>
         <p:spPr>
           <a:xfrm>
-            <a:off x="1700784" y="4056888"/>
-            <a:ext cx="1389888" cy="316992"/>
+            <a:off x="1691640" y="4091379"/>
+            <a:ext cx="1408176" cy="321163"/>
           </a:xfrm>
           <a:prstGeom prst="rect">
             <a:avLst/>
@@ -11484,9 +11581,9 @@
                 <a:solidFill>
                   <a:srgbClr val="C9B4AC"/>
                 </a:solidFill>
-                <a:latin typeface="Century Gothic" pitchFamily="34" charset="0"/>
-                <a:ea typeface="Century Gothic" pitchFamily="34" charset="-122"/>
-                <a:cs typeface="Century Gothic" pitchFamily="34" charset="-120"/>
+                <a:latin typeface="Corbel" pitchFamily="34" charset="0"/>
+                <a:ea typeface="Corbel" pitchFamily="34" charset="-122"/>
+                <a:cs typeface="Corbel" pitchFamily="34" charset="-120"/>
               </a:rPr>
               <a:t>client logo — placeholder</a:t>
             </a:r>
@@ -11523,9 +11620,9 @@
                 <a:solidFill>
                   <a:srgbClr val="D9B86B"/>
                 </a:solidFill>
-                <a:latin typeface="Century Gothic" pitchFamily="34" charset="0"/>
-                <a:ea typeface="Century Gothic" pitchFamily="34" charset="-122"/>
-                <a:cs typeface="Century Gothic" pitchFamily="34" charset="-120"/>
+                <a:latin typeface="Corbel" pitchFamily="34" charset="0"/>
+                <a:ea typeface="Corbel" pitchFamily="34" charset="-122"/>
+                <a:cs typeface="Corbel" pitchFamily="34" charset="-120"/>
               </a:rPr>
               <a:t>Prashant</a:t>
             </a:r>
@@ -11601,9 +11698,9 @@
                 <a:solidFill>
                   <a:srgbClr val="C9B4AC"/>
                 </a:solidFill>
-                <a:latin typeface="Century Gothic" pitchFamily="34" charset="0"/>
-                <a:ea typeface="Century Gothic" pitchFamily="34" charset="-122"/>
-                <a:cs typeface="Century Gothic" pitchFamily="34" charset="-120"/>
+                <a:latin typeface="Corbel" pitchFamily="34" charset="0"/>
+                <a:ea typeface="Corbel" pitchFamily="34" charset="-122"/>
+                <a:cs typeface="Corbel" pitchFamily="34" charset="-120"/>
               </a:rPr>
               <a:t>prashant@eventsactive.com</a:t>
             </a:r>
@@ -11640,9 +11737,9 @@
                 <a:solidFill>
                   <a:srgbClr val="D9B86B"/>
                 </a:solidFill>
-                <a:latin typeface="Century Gothic" pitchFamily="34" charset="0"/>
-                <a:ea typeface="Century Gothic" pitchFamily="34" charset="-122"/>
-                <a:cs typeface="Century Gothic" pitchFamily="34" charset="-120"/>
+                <a:latin typeface="Corbel" pitchFamily="34" charset="0"/>
+                <a:ea typeface="Corbel" pitchFamily="34" charset="-122"/>
+                <a:cs typeface="Corbel" pitchFamily="34" charset="-120"/>
               </a:rPr>
               <a:t>Web  ·  USA</a:t>
             </a:r>
@@ -11718,9 +11815,9 @@
                 <a:solidFill>
                   <a:srgbClr val="C9B4AC"/>
                 </a:solidFill>
-                <a:latin typeface="Century Gothic" pitchFamily="34" charset="0"/>
-                <a:ea typeface="Century Gothic" pitchFamily="34" charset="-122"/>
-                <a:cs typeface="Century Gothic" pitchFamily="34" charset="-120"/>
+                <a:latin typeface="Corbel" pitchFamily="34" charset="0"/>
+                <a:ea typeface="Corbel" pitchFamily="34" charset="-122"/>
+                <a:cs typeface="Corbel" pitchFamily="34" charset="-120"/>
               </a:rPr>
               <a:t>Padma  ·  +1 (408) 679-7148</a:t>
             </a:r>
@@ -11757,9 +11854,9 @@
                 <a:solidFill>
                   <a:srgbClr val="8A7078"/>
                 </a:solidFill>
-                <a:latin typeface="Century Gothic" pitchFamily="34" charset="0"/>
-                <a:ea typeface="Century Gothic" pitchFamily="34" charset="-122"/>
-                <a:cs typeface="Century Gothic" pitchFamily="34" charset="-120"/>
+                <a:latin typeface="Corbel" pitchFamily="34" charset="0"/>
+                <a:ea typeface="Corbel" pitchFamily="34" charset="-122"/>
+                <a:cs typeface="Corbel" pitchFamily="34" charset="-120"/>
               </a:rPr>
               <a:t>Prepared as a planning response to the Doft Candles Request for Contractor. Figures illustrative at placeholder rates.</a:t>
             </a:r>
@@ -11828,9 +11925,9 @@
                 <a:solidFill>
                   <a:srgbClr val="B8924A"/>
                 </a:solidFill>
-                <a:latin typeface="Century Gothic" pitchFamily="34" charset="0"/>
-                <a:ea typeface="Century Gothic" pitchFamily="34" charset="-122"/>
-                <a:cs typeface="Century Gothic" pitchFamily="34" charset="-120"/>
+                <a:latin typeface="Corbel" pitchFamily="34" charset="0"/>
+                <a:ea typeface="Corbel" pitchFamily="34" charset="-122"/>
+                <a:cs typeface="Corbel" pitchFamily="34" charset="-120"/>
               </a:rPr>
               <a:t>THE ASK</a:t>
             </a:r>
@@ -11885,18 +11982,30 @@
         </p:nvSpPr>
         <p:spPr>
           <a:xfrm>
-            <a:off x="10204704" y="457200"/>
-            <a:ext cx="1417320" cy="384048"/>
+            <a:off x="10140696" y="420624"/>
+            <a:ext cx="1481328" cy="457200"/>
           </a:xfrm>
           <a:prstGeom prst="roundRect">
             <a:avLst>
-              <a:gd name="adj" fmla="val 11905"/>
+              <a:gd name="adj" fmla="val 10000"/>
             </a:avLst>
           </a:prstGeom>
           <a:solidFill>
-            <a:srgbClr val="1C1518"/>
+            <a:srgbClr val="FFFFFF"/>
           </a:solidFill>
-          <a:ln/>
+          <a:ln w="12700">
+            <a:solidFill>
+              <a:srgbClr val="E3D8C7"/>
+            </a:solidFill>
+            <a:prstDash val="solid"/>
+          </a:ln>
+          <a:effectLst>
+            <a:outerShdw sx="100000" sy="100000" kx="0" ky="0" algn="bl" rotWithShape="0" blurRad="50800" dist="12700" dir="5400000">
+              <a:srgbClr val="B8A894">
+                <a:alpha val="35000"/>
+              </a:srgbClr>
+            </a:outerShdw>
+          </a:effectLst>
         </p:spPr>
       </p:sp>
       <p:pic>
@@ -11915,8 +12024,8 @@
         </p:blipFill>
         <p:spPr>
           <a:xfrm>
-            <a:off x="10332720" y="516796"/>
-            <a:ext cx="1161288" cy="264855"/>
+            <a:off x="10259568" y="507412"/>
+            <a:ext cx="1243584" cy="283624"/>
           </a:xfrm>
           <a:prstGeom prst="rect">
             <a:avLst/>
@@ -11952,9 +12061,9 @@
                 <a:solidFill>
                   <a:srgbClr val="8C7F72"/>
                 </a:solidFill>
-                <a:latin typeface="Century Gothic" pitchFamily="34" charset="0"/>
-                <a:ea typeface="Century Gothic" pitchFamily="34" charset="-122"/>
-                <a:cs typeface="Century Gothic" pitchFamily="34" charset="-120"/>
+                <a:latin typeface="Corbel" pitchFamily="34" charset="0"/>
+                <a:ea typeface="Corbel" pitchFamily="34" charset="-122"/>
+                <a:cs typeface="Corbel" pitchFamily="34" charset="-120"/>
               </a:rPr>
               <a:t>Premium seasonal pop-up kiosks in leading malls — staffed and run end-to-end, as a long-term partner for Diwali 2026–28.</a:t>
             </a:r>
@@ -12084,9 +12193,9 @@
                 <a:solidFill>
                   <a:srgbClr val="35302B"/>
                 </a:solidFill>
-                <a:latin typeface="Century Gothic" pitchFamily="34" charset="0"/>
-                <a:ea typeface="Century Gothic" pitchFamily="34" charset="-122"/>
-                <a:cs typeface="Century Gothic" pitchFamily="34" charset="-120"/>
+                <a:latin typeface="Corbel" pitchFamily="34" charset="0"/>
+                <a:ea typeface="Corbel" pitchFamily="34" charset="-122"/>
+                <a:cs typeface="Corbel" pitchFamily="34" charset="-120"/>
               </a:rPr>
               <a:t>Operating window before Diwali, each season</a:t>
             </a:r>
@@ -12216,9 +12325,9 @@
                 <a:solidFill>
                   <a:srgbClr val="35302B"/>
                 </a:solidFill>
-                <a:latin typeface="Century Gothic" pitchFamily="34" charset="0"/>
-                <a:ea typeface="Century Gothic" pitchFamily="34" charset="-122"/>
-                <a:cs typeface="Century Gothic" pitchFamily="34" charset="-120"/>
+                <a:latin typeface="Corbel" pitchFamily="34" charset="0"/>
+                <a:ea typeface="Corbel" pitchFamily="34" charset="-122"/>
+                <a:cs typeface="Corbel" pitchFamily="34" charset="-120"/>
               </a:rPr>
               <a:t>Kiosk footprint, plus a ~90 sq ft stockroom</a:t>
             </a:r>
@@ -12348,9 +12457,9 @@
                 <a:solidFill>
                   <a:srgbClr val="35302B"/>
                 </a:solidFill>
-                <a:latin typeface="Century Gothic" pitchFamily="34" charset="0"/>
-                <a:ea typeface="Century Gothic" pitchFamily="34" charset="-122"/>
-                <a:cs typeface="Century Gothic" pitchFamily="34" charset="-120"/>
+                <a:latin typeface="Corbel" pitchFamily="34" charset="0"/>
+                <a:ea typeface="Corbel" pitchFamily="34" charset="-122"/>
+                <a:cs typeface="Corbel" pitchFamily="34" charset="-120"/>
               </a:rPr>
               <a:t>Pop-ups per region, across multiple cities</a:t>
             </a:r>
@@ -12480,9 +12589,9 @@
                 <a:solidFill>
                   <a:srgbClr val="35302B"/>
                 </a:solidFill>
-                <a:latin typeface="Century Gothic" pitchFamily="34" charset="0"/>
-                <a:ea typeface="Century Gothic" pitchFamily="34" charset="-122"/>
-                <a:cs typeface="Century Gothic" pitchFamily="34" charset="-120"/>
+                <a:latin typeface="Corbel" pitchFamily="34" charset="0"/>
+                <a:ea typeface="Corbel" pitchFamily="34" charset="-122"/>
+                <a:cs typeface="Corbel" pitchFamily="34" charset="-120"/>
               </a:rPr>
               <a:t>Full staffing team at every pop-up</a:t>
             </a:r>
@@ -12612,9 +12721,9 @@
                 <a:solidFill>
                   <a:srgbClr val="35302B"/>
                 </a:solidFill>
-                <a:latin typeface="Century Gothic" pitchFamily="34" charset="0"/>
-                <a:ea typeface="Century Gothic" pitchFamily="34" charset="-122"/>
-                <a:cs typeface="Century Gothic" pitchFamily="34" charset="-120"/>
+                <a:latin typeface="Corbel" pitchFamily="34" charset="0"/>
+                <a:ea typeface="Corbel" pitchFamily="34" charset="-122"/>
+                <a:cs typeface="Corbel" pitchFamily="34" charset="-120"/>
               </a:rPr>
               <a:t>Doft product &amp; sales training, 100% attendance</a:t>
             </a:r>
@@ -12744,9 +12853,9 @@
                 <a:solidFill>
                   <a:srgbClr val="35302B"/>
                 </a:solidFill>
-                <a:latin typeface="Century Gothic" pitchFamily="34" charset="0"/>
-                <a:ea typeface="Century Gothic" pitchFamily="34" charset="-122"/>
-                <a:cs typeface="Century Gothic" pitchFamily="34" charset="-120"/>
+                <a:latin typeface="Corbel" pitchFamily="34" charset="0"/>
+                <a:ea typeface="Corbel" pitchFamily="34" charset="-122"/>
+                <a:cs typeface="Corbel" pitchFamily="34" charset="-120"/>
               </a:rPr>
               <a:t>Stock, furniture, POS/EDC, returnable uniforms</a:t>
             </a:r>
@@ -12783,9 +12892,9 @@
                 <a:solidFill>
                   <a:srgbClr val="8C7F72"/>
                 </a:solidFill>
-                <a:latin typeface="Century Gothic" pitchFamily="34" charset="0"/>
-                <a:ea typeface="Century Gothic" pitchFamily="34" charset="-122"/>
-                <a:cs typeface="Century Gothic" pitchFamily="34" charset="-120"/>
+                <a:latin typeface="Corbel" pitchFamily="34" charset="0"/>
+                <a:ea typeface="Corbel" pitchFamily="34" charset="-122"/>
+                <a:cs typeface="Corbel" pitchFamily="34" charset="-120"/>
               </a:rPr>
               <a:t>ProMarcom  ×  Doft Candles</a:t>
             </a:r>
@@ -12913,9 +13022,9 @@
                 <a:solidFill>
                   <a:srgbClr val="D9B86B"/>
                 </a:solidFill>
-                <a:latin typeface="Century Gothic" pitchFamily="34" charset="0"/>
-                <a:ea typeface="Century Gothic" pitchFamily="34" charset="-122"/>
-                <a:cs typeface="Century Gothic" pitchFamily="34" charset="-120"/>
+                <a:latin typeface="Corbel" pitchFamily="34" charset="0"/>
+                <a:ea typeface="Corbel" pitchFamily="34" charset="-122"/>
+                <a:cs typeface="Corbel" pitchFamily="34" charset="-120"/>
               </a:rPr>
               <a:t>WHY PROMARCOM</a:t>
             </a:r>
@@ -12991,9 +13100,9 @@
                 <a:solidFill>
                   <a:srgbClr val="C9B4AC"/>
                 </a:solidFill>
-                <a:latin typeface="Century Gothic" pitchFamily="34" charset="0"/>
-                <a:ea typeface="Century Gothic" pitchFamily="34" charset="-122"/>
-                <a:cs typeface="Century Gothic" pitchFamily="34" charset="-120"/>
+                <a:latin typeface="Corbel" pitchFamily="34" charset="0"/>
+                <a:ea typeface="Corbel" pitchFamily="34" charset="-122"/>
+                <a:cs typeface="Corbel" pitchFamily="34" charset="-120"/>
               </a:rPr>
               <a:t>ProMarcom delivers below-the-line, retail and experiential marketing end to end — concept, design, fabrication, manpower, operations and reporting.</a:t>
             </a:r>
@@ -13155,9 +13264,9 @@
                 <a:solidFill>
                   <a:srgbClr val="C9B4AC"/>
                 </a:solidFill>
-                <a:latin typeface="Century Gothic" pitchFamily="34" charset="0"/>
-                <a:ea typeface="Century Gothic" pitchFamily="34" charset="-122"/>
-                <a:cs typeface="Century Gothic" pitchFamily="34" charset="-120"/>
+                <a:latin typeface="Corbel" pitchFamily="34" charset="0"/>
+                <a:ea typeface="Corbel" pitchFamily="34" charset="-122"/>
+                <a:cs typeface="Corbel" pitchFamily="34" charset="-120"/>
               </a:rPr>
               <a:t>Multi-month mall activations and in-shop demonstrations for global brands.</a:t>
             </a:r>
@@ -13319,9 +13428,9 @@
                 <a:solidFill>
                   <a:srgbClr val="C9B4AC"/>
                 </a:solidFill>
-                <a:latin typeface="Century Gothic" pitchFamily="34" charset="0"/>
-                <a:ea typeface="Century Gothic" pitchFamily="34" charset="-122"/>
-                <a:cs typeface="Century Gothic" pitchFamily="34" charset="-120"/>
+                <a:latin typeface="Corbel" pitchFamily="34" charset="0"/>
+                <a:ea typeface="Corbel" pitchFamily="34" charset="-122"/>
+                <a:cs typeface="Corbel" pitchFamily="34" charset="-120"/>
               </a:rPr>
               <a:t>Show-windows &amp; VM for Burberry, Louis Vuitton, LG, Samsung across 90+ cities.</a:t>
             </a:r>
@@ -13483,9 +13592,9 @@
                 <a:solidFill>
                   <a:srgbClr val="C9B4AC"/>
                 </a:solidFill>
-                <a:latin typeface="Century Gothic" pitchFamily="34" charset="0"/>
-                <a:ea typeface="Century Gothic" pitchFamily="34" charset="-122"/>
-                <a:cs typeface="Century Gothic" pitchFamily="34" charset="-120"/>
+                <a:latin typeface="Corbel" pitchFamily="34" charset="0"/>
+                <a:ea typeface="Corbel" pitchFamily="34" charset="-122"/>
+                <a:cs typeface="Corbel" pitchFamily="34" charset="-120"/>
               </a:rPr>
               <a:t>Recruit, train, deploy and manage large field teams with tracking and reporting.</a:t>
             </a:r>
@@ -13647,9 +13756,9 @@
                 <a:solidFill>
                   <a:srgbClr val="C9B4AC"/>
                 </a:solidFill>
-                <a:latin typeface="Century Gothic" pitchFamily="34" charset="0"/>
-                <a:ea typeface="Century Gothic" pitchFamily="34" charset="-122"/>
-                <a:cs typeface="Century Gothic" pitchFamily="34" charset="-120"/>
+                <a:latin typeface="Corbel" pitchFamily="34" charset="0"/>
+                <a:ea typeface="Corbel" pitchFamily="34" charset="-122"/>
+                <a:cs typeface="Corbel" pitchFamily="34" charset="-120"/>
               </a:rPr>
               <a:t>1,000–24,000 sqm exhibitions; events for LG, Samsung, HP, ICC World Cup.</a:t>
             </a:r>
@@ -13686,9 +13795,9 @@
                 <a:solidFill>
                   <a:srgbClr val="C9B4AC"/>
                 </a:solidFill>
-                <a:latin typeface="Century Gothic" pitchFamily="34" charset="0"/>
-                <a:ea typeface="Century Gothic" pitchFamily="34" charset="-122"/>
-                <a:cs typeface="Century Gothic" pitchFamily="34" charset="-120"/>
+                <a:latin typeface="Corbel" pitchFamily="34" charset="0"/>
+                <a:ea typeface="Corbel" pitchFamily="34" charset="-122"/>
+                <a:cs typeface="Corbel" pitchFamily="34" charset="-120"/>
               </a:rPr>
               <a:t>ProMarcom  ×  Doft Candles</a:t>
             </a:r>
@@ -13796,9 +13905,9 @@
                 <a:solidFill>
                   <a:srgbClr val="B8924A"/>
                 </a:solidFill>
-                <a:latin typeface="Century Gothic" pitchFamily="34" charset="0"/>
-                <a:ea typeface="Century Gothic" pitchFamily="34" charset="-122"/>
-                <a:cs typeface="Century Gothic" pitchFamily="34" charset="-120"/>
+                <a:latin typeface="Corbel" pitchFamily="34" charset="0"/>
+                <a:ea typeface="Corbel" pitchFamily="34" charset="-122"/>
+                <a:cs typeface="Corbel" pitchFamily="34" charset="-120"/>
               </a:rPr>
               <a:t>CREDENTIALS</a:t>
             </a:r>
@@ -13853,18 +13962,30 @@
         </p:nvSpPr>
         <p:spPr>
           <a:xfrm>
-            <a:off x="10204704" y="457200"/>
-            <a:ext cx="1417320" cy="384048"/>
+            <a:off x="10140696" y="420624"/>
+            <a:ext cx="1481328" cy="457200"/>
           </a:xfrm>
           <a:prstGeom prst="roundRect">
             <a:avLst>
-              <a:gd name="adj" fmla="val 11905"/>
+              <a:gd name="adj" fmla="val 10000"/>
             </a:avLst>
           </a:prstGeom>
           <a:solidFill>
-            <a:srgbClr val="1C1518"/>
+            <a:srgbClr val="FFFFFF"/>
           </a:solidFill>
-          <a:ln/>
+          <a:ln w="12700">
+            <a:solidFill>
+              <a:srgbClr val="E3D8C7"/>
+            </a:solidFill>
+            <a:prstDash val="solid"/>
+          </a:ln>
+          <a:effectLst>
+            <a:outerShdw sx="100000" sy="100000" kx="0" ky="0" algn="bl" rotWithShape="0" blurRad="50800" dist="12700" dir="5400000">
+              <a:srgbClr val="B8A894">
+                <a:alpha val="35000"/>
+              </a:srgbClr>
+            </a:outerShdw>
+          </a:effectLst>
         </p:spPr>
       </p:sp>
       <p:pic>
@@ -13883,8 +14004,8 @@
         </p:blipFill>
         <p:spPr>
           <a:xfrm>
-            <a:off x="10332720" y="516796"/>
-            <a:ext cx="1161288" cy="264855"/>
+            <a:off x="10259568" y="507412"/>
+            <a:ext cx="1243584" cy="283624"/>
           </a:xfrm>
           <a:prstGeom prst="rect">
             <a:avLst/>
@@ -13993,9 +14114,9 @@
                 <a:solidFill>
                   <a:srgbClr val="35302B"/>
                 </a:solidFill>
-                <a:latin typeface="Century Gothic" pitchFamily="34" charset="0"/>
-                <a:ea typeface="Century Gothic" pitchFamily="34" charset="-122"/>
-                <a:cs typeface="Century Gothic" pitchFamily="34" charset="-120"/>
+                <a:latin typeface="Corbel" pitchFamily="34" charset="0"/>
+                <a:ea typeface="Corbel" pitchFamily="34" charset="-122"/>
+                <a:cs typeface="Corbel" pitchFamily="34" charset="-120"/>
               </a:rPr>
               <a:t>Cities covered for retail VM &amp; activations</a:t>
             </a:r>
@@ -14105,9 +14226,9 @@
                 <a:solidFill>
                   <a:srgbClr val="35302B"/>
                 </a:solidFill>
-                <a:latin typeface="Century Gothic" pitchFamily="34" charset="0"/>
-                <a:ea typeface="Century Gothic" pitchFamily="34" charset="-122"/>
-                <a:cs typeface="Century Gothic" pitchFamily="34" charset="-120"/>
+                <a:latin typeface="Corbel" pitchFamily="34" charset="0"/>
+                <a:ea typeface="Corbel" pitchFamily="34" charset="-122"/>
+                <a:cs typeface="Corbel" pitchFamily="34" charset="-120"/>
               </a:rPr>
               <a:t>Man-days on one multi-city retail rollout</a:t>
             </a:r>
@@ -14217,9 +14338,9 @@
                 <a:solidFill>
                   <a:srgbClr val="35302B"/>
                 </a:solidFill>
-                <a:latin typeface="Century Gothic" pitchFamily="34" charset="0"/>
-                <a:ea typeface="Century Gothic" pitchFamily="34" charset="-122"/>
-                <a:cs typeface="Century Gothic" pitchFamily="34" charset="-120"/>
+                <a:latin typeface="Corbel" pitchFamily="34" charset="0"/>
+                <a:ea typeface="Corbel" pitchFamily="34" charset="-122"/>
+                <a:cs typeface="Corbel" pitchFamily="34" charset="-120"/>
               </a:rPr>
               <a:t>Sqm of exhibition floor managed (max)</a:t>
             </a:r>
@@ -14329,9 +14450,9 @@
                 <a:solidFill>
                   <a:srgbClr val="35302B"/>
                 </a:solidFill>
-                <a:latin typeface="Century Gothic" pitchFamily="34" charset="0"/>
-                <a:ea typeface="Century Gothic" pitchFamily="34" charset="-122"/>
-                <a:cs typeface="Century Gothic" pitchFamily="34" charset="-120"/>
+                <a:latin typeface="Corbel" pitchFamily="34" charset="0"/>
+                <a:ea typeface="Corbel" pitchFamily="34" charset="-122"/>
+                <a:cs typeface="Corbel" pitchFamily="34" charset="-120"/>
               </a:rPr>
               <a:t>As LG's BTL / retail / digital partner</a:t>
             </a:r>
@@ -14368,9 +14489,9 @@
                 <a:solidFill>
                   <a:srgbClr val="8C7F72"/>
                 </a:solidFill>
-                <a:latin typeface="Century Gothic" pitchFamily="34" charset="0"/>
-                <a:ea typeface="Century Gothic" pitchFamily="34" charset="-122"/>
-                <a:cs typeface="Century Gothic" pitchFamily="34" charset="-120"/>
+                <a:latin typeface="Corbel" pitchFamily="34" charset="0"/>
+                <a:ea typeface="Corbel" pitchFamily="34" charset="-122"/>
+                <a:cs typeface="Corbel" pitchFamily="34" charset="-120"/>
               </a:rPr>
               <a:t>Trusted by leading brands</a:t>
             </a:r>
@@ -15199,9 +15320,9 @@
                 <a:solidFill>
                   <a:srgbClr val="8C7F72"/>
                 </a:solidFill>
-                <a:latin typeface="Century Gothic" pitchFamily="34" charset="0"/>
-                <a:ea typeface="Century Gothic" pitchFamily="34" charset="-122"/>
-                <a:cs typeface="Century Gothic" pitchFamily="34" charset="-120"/>
+                <a:latin typeface="Corbel" pitchFamily="34" charset="0"/>
+                <a:ea typeface="Corbel" pitchFamily="34" charset="-122"/>
+                <a:cs typeface="Corbel" pitchFamily="34" charset="-120"/>
               </a:rPr>
               <a:t>Illustrative selection from ProMarcom credentials.</a:t>
             </a:r>
@@ -15238,9 +15359,9 @@
                 <a:solidFill>
                   <a:srgbClr val="8C7F72"/>
                 </a:solidFill>
-                <a:latin typeface="Century Gothic" pitchFamily="34" charset="0"/>
-                <a:ea typeface="Century Gothic" pitchFamily="34" charset="-122"/>
-                <a:cs typeface="Century Gothic" pitchFamily="34" charset="-120"/>
+                <a:latin typeface="Corbel" pitchFamily="34" charset="0"/>
+                <a:ea typeface="Corbel" pitchFamily="34" charset="-122"/>
+                <a:cs typeface="Corbel" pitchFamily="34" charset="-120"/>
               </a:rPr>
               <a:t>ProMarcom  ×  Doft Candles</a:t>
             </a:r>
@@ -15348,9 +15469,9 @@
                 <a:solidFill>
                   <a:srgbClr val="B8924A"/>
                 </a:solidFill>
-                <a:latin typeface="Century Gothic" pitchFamily="34" charset="0"/>
-                <a:ea typeface="Century Gothic" pitchFamily="34" charset="-122"/>
-                <a:cs typeface="Century Gothic" pitchFamily="34" charset="-120"/>
+                <a:latin typeface="Corbel" pitchFamily="34" charset="0"/>
+                <a:ea typeface="Corbel" pitchFamily="34" charset="-122"/>
+                <a:cs typeface="Corbel" pitchFamily="34" charset="-120"/>
               </a:rPr>
               <a:t>RELEVANT EXPERIENCE</a:t>
             </a:r>
@@ -15405,18 +15526,30 @@
         </p:nvSpPr>
         <p:spPr>
           <a:xfrm>
-            <a:off x="10204704" y="457200"/>
-            <a:ext cx="1417320" cy="384048"/>
+            <a:off x="10140696" y="420624"/>
+            <a:ext cx="1481328" cy="457200"/>
           </a:xfrm>
           <a:prstGeom prst="roundRect">
             <a:avLst>
-              <a:gd name="adj" fmla="val 11905"/>
+              <a:gd name="adj" fmla="val 10000"/>
             </a:avLst>
           </a:prstGeom>
           <a:solidFill>
-            <a:srgbClr val="1C1518"/>
+            <a:srgbClr val="FFFFFF"/>
           </a:solidFill>
-          <a:ln/>
+          <a:ln w="12700">
+            <a:solidFill>
+              <a:srgbClr val="E3D8C7"/>
+            </a:solidFill>
+            <a:prstDash val="solid"/>
+          </a:ln>
+          <a:effectLst>
+            <a:outerShdw sx="100000" sy="100000" kx="0" ky="0" algn="bl" rotWithShape="0" blurRad="50800" dist="12700" dir="5400000">
+              <a:srgbClr val="B8A894">
+                <a:alpha val="35000"/>
+              </a:srgbClr>
+            </a:outerShdw>
+          </a:effectLst>
         </p:spPr>
       </p:sp>
       <p:pic>
@@ -15435,8 +15568,8 @@
         </p:blipFill>
         <p:spPr>
           <a:xfrm>
-            <a:off x="10332720" y="516796"/>
-            <a:ext cx="1161288" cy="264855"/>
+            <a:off x="10259568" y="507412"/>
+            <a:ext cx="1243584" cy="283624"/>
           </a:xfrm>
           <a:prstGeom prst="rect">
             <a:avLst/>
@@ -15590,9 +15723,9 @@
                 <a:solidFill>
                   <a:srgbClr val="9E5A45"/>
                 </a:solidFill>
-                <a:latin typeface="Century Gothic" pitchFamily="34" charset="0"/>
-                <a:ea typeface="Century Gothic" pitchFamily="34" charset="-122"/>
-                <a:cs typeface="Century Gothic" pitchFamily="34" charset="-120"/>
+                <a:latin typeface="Corbel" pitchFamily="34" charset="0"/>
+                <a:ea typeface="Corbel" pitchFamily="34" charset="-122"/>
+                <a:cs typeface="Corbel" pitchFamily="34" charset="-120"/>
               </a:rPr>
               <a:t>Mumbai &amp; Bengaluru</a:t>
             </a:r>
@@ -15629,9 +15762,9 @@
                 <a:solidFill>
                   <a:srgbClr val="35302B"/>
                 </a:solidFill>
-                <a:latin typeface="Century Gothic" pitchFamily="34" charset="0"/>
-                <a:ea typeface="Century Gothic" pitchFamily="34" charset="-122"/>
-                <a:cs typeface="Century Gothic" pitchFamily="34" charset="-120"/>
+                <a:latin typeface="Corbel" pitchFamily="34" charset="0"/>
+                <a:ea typeface="Corbel" pitchFamily="34" charset="-122"/>
+                <a:cs typeface="Corbel" pitchFamily="34" charset="-120"/>
               </a:rPr>
               <a:t>3-month mall promotion: fabrication, manpower, props, merchandising, logistics &amp; reporting.</a:t>
             </a:r>
@@ -15786,9 +15919,9 @@
                 <a:solidFill>
                   <a:srgbClr val="9E5A45"/>
                 </a:solidFill>
-                <a:latin typeface="Century Gothic" pitchFamily="34" charset="0"/>
-                <a:ea typeface="Century Gothic" pitchFamily="34" charset="-122"/>
-                <a:cs typeface="Century Gothic" pitchFamily="34" charset="-120"/>
+                <a:latin typeface="Corbel" pitchFamily="34" charset="0"/>
+                <a:ea typeface="Corbel" pitchFamily="34" charset="-122"/>
+                <a:cs typeface="Corbel" pitchFamily="34" charset="-120"/>
               </a:rPr>
               <a:t>Premium Retail VM</a:t>
             </a:r>
@@ -15825,9 +15958,9 @@
                 <a:solidFill>
                   <a:srgbClr val="35302B"/>
                 </a:solidFill>
-                <a:latin typeface="Century Gothic" pitchFamily="34" charset="0"/>
-                <a:ea typeface="Century Gothic" pitchFamily="34" charset="-122"/>
-                <a:cs typeface="Century Gothic" pitchFamily="34" charset="-120"/>
+                <a:latin typeface="Corbel" pitchFamily="34" charset="0"/>
+                <a:ea typeface="Corbel" pitchFamily="34" charset="-122"/>
+                <a:cs typeface="Corbel" pitchFamily="34" charset="-120"/>
               </a:rPr>
               <a:t>Luxury show-windows, in-shop props &amp; merchandise — the premium standard Doft demands.</a:t>
             </a:r>
@@ -15982,9 +16115,9 @@
                 <a:solidFill>
                   <a:srgbClr val="9E5A45"/>
                 </a:solidFill>
-                <a:latin typeface="Century Gothic" pitchFamily="34" charset="0"/>
-                <a:ea typeface="Century Gothic" pitchFamily="34" charset="-122"/>
-                <a:cs typeface="Century Gothic" pitchFamily="34" charset="-120"/>
+                <a:latin typeface="Corbel" pitchFamily="34" charset="0"/>
+                <a:ea typeface="Corbel" pitchFamily="34" charset="-122"/>
+                <a:cs typeface="Corbel" pitchFamily="34" charset="-120"/>
               </a:rPr>
               <a:t>70+ cities · 3,000 man-days</a:t>
             </a:r>
@@ -16021,9 +16154,9 @@
                 <a:solidFill>
                   <a:srgbClr val="35302B"/>
                 </a:solidFill>
-                <a:latin typeface="Century Gothic" pitchFamily="34" charset="0"/>
-                <a:ea typeface="Century Gothic" pitchFamily="34" charset="-122"/>
-                <a:cs typeface="Century Gothic" pitchFamily="34" charset="-120"/>
+                <a:latin typeface="Corbel" pitchFamily="34" charset="0"/>
+                <a:ea typeface="Corbel" pitchFamily="34" charset="-122"/>
+                <a:cs typeface="Corbel" pitchFamily="34" charset="-120"/>
               </a:rPr>
               <a:t>Shop-to-shop retail activation across India — multi-city manpower at scale.</a:t>
             </a:r>
@@ -16060,9 +16193,9 @@
                 <a:solidFill>
                   <a:srgbClr val="8C7F72"/>
                 </a:solidFill>
-                <a:latin typeface="Century Gothic" pitchFamily="34" charset="0"/>
-                <a:ea typeface="Century Gothic" pitchFamily="34" charset="-122"/>
-                <a:cs typeface="Century Gothic" pitchFamily="34" charset="-120"/>
+                <a:latin typeface="Corbel" pitchFamily="34" charset="0"/>
+                <a:ea typeface="Corbel" pitchFamily="34" charset="-122"/>
+                <a:cs typeface="Corbel" pitchFamily="34" charset="-120"/>
               </a:rPr>
               <a:t>ProMarcom  ×  Doft Candles</a:t>
             </a:r>
@@ -16170,9 +16303,9 @@
                 <a:solidFill>
                   <a:srgbClr val="B8924A"/>
                 </a:solidFill>
-                <a:latin typeface="Century Gothic" pitchFamily="34" charset="0"/>
-                <a:ea typeface="Century Gothic" pitchFamily="34" charset="-122"/>
-                <a:cs typeface="Century Gothic" pitchFamily="34" charset="-120"/>
+                <a:latin typeface="Corbel" pitchFamily="34" charset="0"/>
+                <a:ea typeface="Corbel" pitchFamily="34" charset="-122"/>
+                <a:cs typeface="Corbel" pitchFamily="34" charset="-120"/>
               </a:rPr>
               <a:t>OUR APPROACH</a:t>
             </a:r>
@@ -16227,18 +16360,30 @@
         </p:nvSpPr>
         <p:spPr>
           <a:xfrm>
-            <a:off x="10204704" y="457200"/>
-            <a:ext cx="1417320" cy="384048"/>
+            <a:off x="10140696" y="420624"/>
+            <a:ext cx="1481328" cy="457200"/>
           </a:xfrm>
           <a:prstGeom prst="roundRect">
             <a:avLst>
-              <a:gd name="adj" fmla="val 11905"/>
+              <a:gd name="adj" fmla="val 10000"/>
             </a:avLst>
           </a:prstGeom>
           <a:solidFill>
-            <a:srgbClr val="1C1518"/>
+            <a:srgbClr val="FFFFFF"/>
           </a:solidFill>
-          <a:ln/>
+          <a:ln w="12700">
+            <a:solidFill>
+              <a:srgbClr val="E3D8C7"/>
+            </a:solidFill>
+            <a:prstDash val="solid"/>
+          </a:ln>
+          <a:effectLst>
+            <a:outerShdw sx="100000" sy="100000" kx="0" ky="0" algn="bl" rotWithShape="0" blurRad="50800" dist="12700" dir="5400000">
+              <a:srgbClr val="B8A894">
+                <a:alpha val="35000"/>
+              </a:srgbClr>
+            </a:outerShdw>
+          </a:effectLst>
         </p:spPr>
       </p:sp>
       <p:pic>
@@ -16257,8 +16402,8 @@
         </p:blipFill>
         <p:spPr>
           <a:xfrm>
-            <a:off x="10332720" y="516796"/>
-            <a:ext cx="1161288" cy="264855"/>
+            <a:off x="10259568" y="507412"/>
+            <a:ext cx="1243584" cy="283624"/>
           </a:xfrm>
           <a:prstGeom prst="rect">
             <a:avLst/>
@@ -16406,9 +16551,9 @@
                 <a:solidFill>
                   <a:srgbClr val="35302B"/>
                 </a:solidFill>
-                <a:latin typeface="Century Gothic" pitchFamily="34" charset="0"/>
-                <a:ea typeface="Century Gothic" pitchFamily="34" charset="-122"/>
-                <a:cs typeface="Century Gothic" pitchFamily="34" charset="-120"/>
+                <a:latin typeface="Corbel" pitchFamily="34" charset="0"/>
+                <a:ea typeface="Corbel" pitchFamily="34" charset="-122"/>
+                <a:cs typeface="Corbel" pitchFamily="34" charset="-120"/>
               </a:rPr>
               <a:t>On-site fabrication &amp; install to Doft design</a:t>
             </a:r>
@@ -16557,9 +16702,9 @@
                 <a:solidFill>
                   <a:srgbClr val="35302B"/>
                 </a:solidFill>
-                <a:latin typeface="Century Gothic" pitchFamily="34" charset="0"/>
-                <a:ea typeface="Century Gothic" pitchFamily="34" charset="-122"/>
-                <a:cs typeface="Century Gothic" pitchFamily="34" charset="-120"/>
+                <a:latin typeface="Corbel" pitchFamily="34" charset="0"/>
+                <a:ea typeface="Corbel" pitchFamily="34" charset="-122"/>
+                <a:cs typeface="Corbel" pitchFamily="34" charset="-120"/>
               </a:rPr>
               <a:t>Liaison, licences, permits, approvals</a:t>
             </a:r>
@@ -16708,9 +16853,9 @@
                 <a:solidFill>
                   <a:srgbClr val="35302B"/>
                 </a:solidFill>
-                <a:latin typeface="Century Gothic" pitchFamily="34" charset="0"/>
-                <a:ea typeface="Century Gothic" pitchFamily="34" charset="-122"/>
-                <a:cs typeface="Century Gothic" pitchFamily="34" charset="-120"/>
+                <a:latin typeface="Corbel" pitchFamily="34" charset="0"/>
+                <a:ea typeface="Corbel" pitchFamily="34" charset="-122"/>
+                <a:cs typeface="Corbel" pitchFamily="34" charset="-120"/>
               </a:rPr>
               <a:t>Ghaziabad pickup, replenishment, returns</a:t>
             </a:r>
@@ -16859,9 +17004,9 @@
                 <a:solidFill>
                   <a:srgbClr val="35302B"/>
                 </a:solidFill>
-                <a:latin typeface="Century Gothic" pitchFamily="34" charset="0"/>
-                <a:ea typeface="Century Gothic" pitchFamily="34" charset="-122"/>
-                <a:cs typeface="Century Gothic" pitchFamily="34" charset="-120"/>
+                <a:latin typeface="Corbel" pitchFamily="34" charset="0"/>
+                <a:ea typeface="Corbel" pitchFamily="34" charset="-122"/>
+                <a:cs typeface="Corbel" pitchFamily="34" charset="-120"/>
               </a:rPr>
               <a:t>Hire, BGV, payroll, statutory compliance</a:t>
             </a:r>
@@ -17010,9 +17155,9 @@
                 <a:solidFill>
                   <a:srgbClr val="C9B4AC"/>
                 </a:solidFill>
-                <a:latin typeface="Century Gothic" pitchFamily="34" charset="0"/>
-                <a:ea typeface="Century Gothic" pitchFamily="34" charset="-122"/>
-                <a:cs typeface="Century Gothic" pitchFamily="34" charset="-120"/>
+                <a:latin typeface="Corbel" pitchFamily="34" charset="0"/>
+                <a:ea typeface="Corbel" pitchFamily="34" charset="-122"/>
+                <a:cs typeface="Corbel" pitchFamily="34" charset="-120"/>
               </a:rPr>
               <a:t>100% attendance + a trained bench</a:t>
             </a:r>
@@ -17161,9 +17306,9 @@
                 <a:solidFill>
                   <a:srgbClr val="C9B4AC"/>
                 </a:solidFill>
-                <a:latin typeface="Century Gothic" pitchFamily="34" charset="0"/>
-                <a:ea typeface="Century Gothic" pitchFamily="34" charset="-122"/>
-                <a:cs typeface="Century Gothic" pitchFamily="34" charset="-120"/>
+                <a:latin typeface="Corbel" pitchFamily="34" charset="0"/>
+                <a:ea typeface="Corbel" pitchFamily="34" charset="-122"/>
+                <a:cs typeface="Corbel" pitchFamily="34" charset="-120"/>
               </a:rPr>
               <a:t>Open–close, sales, POS, VM, cash</a:t>
             </a:r>
@@ -17312,9 +17457,9 @@
                 <a:solidFill>
                   <a:srgbClr val="C9B4AC"/>
                 </a:solidFill>
-                <a:latin typeface="Century Gothic" pitchFamily="34" charset="0"/>
-                <a:ea typeface="Century Gothic" pitchFamily="34" charset="-122"/>
-                <a:cs typeface="Century Gothic" pitchFamily="34" charset="-120"/>
+                <a:latin typeface="Corbel" pitchFamily="34" charset="0"/>
+                <a:ea typeface="Corbel" pitchFamily="34" charset="-122"/>
+                <a:cs typeface="Corbel" pitchFamily="34" charset="-120"/>
               </a:rPr>
               <a:t>Daily sales, footfall, stock, attendance</a:t>
             </a:r>
@@ -17390,9 +17535,9 @@
                 <a:solidFill>
                   <a:srgbClr val="8C7F72"/>
                 </a:solidFill>
-                <a:latin typeface="Century Gothic" pitchFamily="34" charset="0"/>
-                <a:ea typeface="Century Gothic" pitchFamily="34" charset="-122"/>
-                <a:cs typeface="Century Gothic" pitchFamily="34" charset="-120"/>
+                <a:latin typeface="Corbel" pitchFamily="34" charset="0"/>
+                <a:ea typeface="Corbel" pitchFamily="34" charset="-122"/>
+                <a:cs typeface="Corbel" pitchFamily="34" charset="-120"/>
               </a:rPr>
               <a:t>ProMarcom  ×  Doft Candles</a:t>
             </a:r>
@@ -17500,9 +17645,9 @@
                 <a:solidFill>
                   <a:srgbClr val="B8924A"/>
                 </a:solidFill>
-                <a:latin typeface="Century Gothic" pitchFamily="34" charset="0"/>
-                <a:ea typeface="Century Gothic" pitchFamily="34" charset="-122"/>
-                <a:cs typeface="Century Gothic" pitchFamily="34" charset="-120"/>
+                <a:latin typeface="Corbel" pitchFamily="34" charset="0"/>
+                <a:ea typeface="Corbel" pitchFamily="34" charset="-122"/>
+                <a:cs typeface="Corbel" pitchFamily="34" charset="-120"/>
               </a:rPr>
               <a:t>STAFFING</a:t>
             </a:r>
@@ -17557,18 +17702,30 @@
         </p:nvSpPr>
         <p:spPr>
           <a:xfrm>
-            <a:off x="10204704" y="457200"/>
-            <a:ext cx="1417320" cy="384048"/>
+            <a:off x="10140696" y="420624"/>
+            <a:ext cx="1481328" cy="457200"/>
           </a:xfrm>
           <a:prstGeom prst="roundRect">
             <a:avLst>
-              <a:gd name="adj" fmla="val 11905"/>
+              <a:gd name="adj" fmla="val 10000"/>
             </a:avLst>
           </a:prstGeom>
           <a:solidFill>
-            <a:srgbClr val="1C1518"/>
+            <a:srgbClr val="FFFFFF"/>
           </a:solidFill>
-          <a:ln/>
+          <a:ln w="12700">
+            <a:solidFill>
+              <a:srgbClr val="E3D8C7"/>
+            </a:solidFill>
+            <a:prstDash val="solid"/>
+          </a:ln>
+          <a:effectLst>
+            <a:outerShdw sx="100000" sy="100000" kx="0" ky="0" algn="bl" rotWithShape="0" blurRad="50800" dist="12700" dir="5400000">
+              <a:srgbClr val="B8A894">
+                <a:alpha val="35000"/>
+              </a:srgbClr>
+            </a:outerShdw>
+          </a:effectLst>
         </p:spPr>
       </p:sp>
       <p:pic>
@@ -17587,8 +17744,8 @@
         </p:blipFill>
         <p:spPr>
           <a:xfrm>
-            <a:off x="10332720" y="516796"/>
-            <a:ext cx="1161288" cy="264855"/>
+            <a:off x="10259568" y="507412"/>
+            <a:ext cx="1243584" cy="283624"/>
           </a:xfrm>
           <a:prstGeom prst="rect">
             <a:avLst/>
@@ -17761,9 +17918,9 @@
                 <a:solidFill>
                   <a:srgbClr val="35302B"/>
                 </a:solidFill>
-                <a:latin typeface="Century Gothic" pitchFamily="34" charset="0"/>
-                <a:ea typeface="Century Gothic" pitchFamily="34" charset="-122"/>
-                <a:cs typeface="Century Gothic" pitchFamily="34" charset="-120"/>
+                <a:latin typeface="Corbel" pitchFamily="34" charset="0"/>
+                <a:ea typeface="Corbel" pitchFamily="34" charset="-122"/>
+                <a:cs typeface="Corbel" pitchFamily="34" charset="-120"/>
               </a:rPr>
               <a:t>Female, 22–25, fluent English, retail experience</a:t>
             </a:r>
@@ -17937,9 +18094,9 @@
                 <a:solidFill>
                   <a:srgbClr val="35302B"/>
                 </a:solidFill>
-                <a:latin typeface="Century Gothic" pitchFamily="34" charset="0"/>
-                <a:ea typeface="Century Gothic" pitchFamily="34" charset="-122"/>
-                <a:cs typeface="Century Gothic" pitchFamily="34" charset="-120"/>
+                <a:latin typeface="Corbel" pitchFamily="34" charset="0"/>
+                <a:ea typeface="Corbel" pitchFamily="34" charset="-122"/>
+                <a:cs typeface="Corbel" pitchFamily="34" charset="-120"/>
               </a:rPr>
               <a:t>Merchandising, stock, queue management</a:t>
             </a:r>
@@ -18113,9 +18270,9 @@
                 <a:solidFill>
                   <a:srgbClr val="35302B"/>
                 </a:solidFill>
-                <a:latin typeface="Century Gothic" pitchFamily="34" charset="0"/>
-                <a:ea typeface="Century Gothic" pitchFamily="34" charset="-122"/>
-                <a:cs typeface="Century Gothic" pitchFamily="34" charset="-120"/>
+                <a:latin typeface="Corbel" pitchFamily="34" charset="0"/>
+                <a:ea typeface="Corbel" pitchFamily="34" charset="-122"/>
+                <a:cs typeface="Corbel" pitchFamily="34" charset="-120"/>
               </a:rPr>
               <a:t>Housekeeping &amp; material handling</a:t>
             </a:r>
@@ -18289,9 +18446,9 @@
                 <a:solidFill>
                   <a:srgbClr val="35302B"/>
                 </a:solidFill>
-                <a:latin typeface="Century Gothic" pitchFamily="34" charset="0"/>
-                <a:ea typeface="Century Gothic" pitchFamily="34" charset="-122"/>
-                <a:cs typeface="Century Gothic" pitchFamily="34" charset="-120"/>
+                <a:latin typeface="Corbel" pitchFamily="34" charset="0"/>
+                <a:ea typeface="Corbel" pitchFamily="34" charset="-122"/>
+                <a:cs typeface="Corbel" pitchFamily="34" charset="-120"/>
               </a:rPr>
               <a:t>Experienced on POS / EDC machines</a:t>
             </a:r>
@@ -18465,9 +18622,9 @@
                 <a:solidFill>
                   <a:srgbClr val="35302B"/>
                 </a:solidFill>
-                <a:latin typeface="Century Gothic" pitchFamily="34" charset="0"/>
-                <a:ea typeface="Century Gothic" pitchFamily="34" charset="-122"/>
-                <a:cs typeface="Century Gothic" pitchFamily="34" charset="-120"/>
+                <a:latin typeface="Corbel" pitchFamily="34" charset="0"/>
+                <a:ea typeface="Corbel" pitchFamily="34" charset="-122"/>
+                <a:cs typeface="Corbel" pitchFamily="34" charset="-120"/>
               </a:rPr>
               <a:t>Stock transport &amp; replenishment runs</a:t>
             </a:r>
@@ -18641,9 +18798,9 @@
                 <a:solidFill>
                   <a:srgbClr val="35302B"/>
                 </a:solidFill>
-                <a:latin typeface="Century Gothic" pitchFamily="34" charset="0"/>
-                <a:ea typeface="Century Gothic" pitchFamily="34" charset="-122"/>
-                <a:cs typeface="Century Gothic" pitchFamily="34" charset="-120"/>
+                <a:latin typeface="Corbel" pitchFamily="34" charset="0"/>
+                <a:ea typeface="Corbel" pitchFamily="34" charset="-122"/>
+                <a:cs typeface="Corbel" pitchFamily="34" charset="-120"/>
               </a:rPr>
               <a:t>Permanent ProMarcom employee — ops owner</a:t>
             </a:r>
@@ -18702,9 +18859,9 @@
                 <a:solidFill>
                   <a:srgbClr val="D9B86B"/>
                 </a:solidFill>
-                <a:latin typeface="Century Gothic" pitchFamily="34" charset="0"/>
-                <a:ea typeface="Century Gothic" pitchFamily="34" charset="-122"/>
-                <a:cs typeface="Century Gothic" pitchFamily="34" charset="-120"/>
+                <a:latin typeface="Corbel" pitchFamily="34" charset="0"/>
+                <a:ea typeface="Corbel" pitchFamily="34" charset="-122"/>
+                <a:cs typeface="Corbel" pitchFamily="34" charset="-120"/>
               </a:rPr>
               <a:t>12 per kiosk</a:t>
             </a:r>
@@ -18716,9 +18873,9 @@
                 <a:solidFill>
                   <a:srgbClr val="F3ECE0"/>
                 </a:solidFill>
-                <a:latin typeface="Century Gothic" pitchFamily="34" charset="0"/>
-                <a:ea typeface="Century Gothic" pitchFamily="34" charset="-122"/>
-                <a:cs typeface="Century Gothic" pitchFamily="34" charset="-120"/>
+                <a:latin typeface="Corbel" pitchFamily="34" charset="0"/>
+                <a:ea typeface="Corbel" pitchFamily="34" charset="-122"/>
+                <a:cs typeface="Corbel" pitchFamily="34" charset="-120"/>
               </a:rPr>
               <a:t>   ×   pop-ups   =   your deployed field force.   Illustrative 9-kiosk rollout  =  </a:t>
             </a:r>
@@ -18730,9 +18887,9 @@
                 <a:solidFill>
                   <a:srgbClr val="D9B86B"/>
                 </a:solidFill>
-                <a:latin typeface="Century Gothic" pitchFamily="34" charset="0"/>
-                <a:ea typeface="Century Gothic" pitchFamily="34" charset="-122"/>
-                <a:cs typeface="Century Gothic" pitchFamily="34" charset="-120"/>
+                <a:latin typeface="Corbel" pitchFamily="34" charset="0"/>
+                <a:ea typeface="Corbel" pitchFamily="34" charset="-122"/>
+                <a:cs typeface="Corbel" pitchFamily="34" charset="-120"/>
               </a:rPr>
               <a:t>108 trained staff</a:t>
             </a:r>
@@ -18769,9 +18926,9 @@
                 <a:solidFill>
                   <a:srgbClr val="8C7F72"/>
                 </a:solidFill>
-                <a:latin typeface="Century Gothic" pitchFamily="34" charset="0"/>
-                <a:ea typeface="Century Gothic" pitchFamily="34" charset="-122"/>
-                <a:cs typeface="Century Gothic" pitchFamily="34" charset="-120"/>
+                <a:latin typeface="Corbel" pitchFamily="34" charset="0"/>
+                <a:ea typeface="Corbel" pitchFamily="34" charset="-122"/>
+                <a:cs typeface="Corbel" pitchFamily="34" charset="-120"/>
               </a:rPr>
               <a:t>ProMarcom  ×  Doft Candles</a:t>
             </a:r>
@@ -18879,9 +19036,9 @@
                 <a:solidFill>
                   <a:srgbClr val="B8924A"/>
                 </a:solidFill>
-                <a:latin typeface="Century Gothic" pitchFamily="34" charset="0"/>
-                <a:ea typeface="Century Gothic" pitchFamily="34" charset="-122"/>
-                <a:cs typeface="Century Gothic" pitchFamily="34" charset="-120"/>
+                <a:latin typeface="Corbel" pitchFamily="34" charset="0"/>
+                <a:ea typeface="Corbel" pitchFamily="34" charset="-122"/>
+                <a:cs typeface="Corbel" pitchFamily="34" charset="-120"/>
               </a:rPr>
               <a:t>PEOPLE</a:t>
             </a:r>
@@ -18936,18 +19093,30 @@
         </p:nvSpPr>
         <p:spPr>
           <a:xfrm>
-            <a:off x="10204704" y="457200"/>
-            <a:ext cx="1417320" cy="384048"/>
+            <a:off x="10140696" y="420624"/>
+            <a:ext cx="1481328" cy="457200"/>
           </a:xfrm>
           <a:prstGeom prst="roundRect">
             <a:avLst>
-              <a:gd name="adj" fmla="val 11905"/>
+              <a:gd name="adj" fmla="val 10000"/>
             </a:avLst>
           </a:prstGeom>
           <a:solidFill>
-            <a:srgbClr val="1C1518"/>
+            <a:srgbClr val="FFFFFF"/>
           </a:solidFill>
-          <a:ln/>
+          <a:ln w="12700">
+            <a:solidFill>
+              <a:srgbClr val="E3D8C7"/>
+            </a:solidFill>
+            <a:prstDash val="solid"/>
+          </a:ln>
+          <a:effectLst>
+            <a:outerShdw sx="100000" sy="100000" kx="0" ky="0" algn="bl" rotWithShape="0" blurRad="50800" dist="12700" dir="5400000">
+              <a:srgbClr val="B8A894">
+                <a:alpha val="35000"/>
+              </a:srgbClr>
+            </a:outerShdw>
+          </a:effectLst>
         </p:spPr>
       </p:sp>
       <p:pic>
@@ -18966,8 +19135,8 @@
         </p:blipFill>
         <p:spPr>
           <a:xfrm>
-            <a:off x="10332720" y="516796"/>
-            <a:ext cx="1161288" cy="264855"/>
+            <a:off x="10259568" y="507412"/>
+            <a:ext cx="1243584" cy="283624"/>
           </a:xfrm>
           <a:prstGeom prst="rect">
             <a:avLst/>
@@ -19139,9 +19308,9 @@
                 <a:solidFill>
                   <a:srgbClr val="35302B"/>
                 </a:solidFill>
-                <a:latin typeface="Century Gothic" pitchFamily="34" charset="0"/>
-                <a:ea typeface="Century Gothic" pitchFamily="34" charset="-122"/>
-                <a:cs typeface="Century Gothic" pitchFamily="34" charset="-120"/>
+                <a:latin typeface="Corbel" pitchFamily="34" charset="0"/>
+                <a:ea typeface="Corbel" pitchFamily="34" charset="-122"/>
+                <a:cs typeface="Corbel" pitchFamily="34" charset="-120"/>
               </a:rPr>
               <a:t>City-level sourcing &amp; referrals</a:t>
             </a:r>
@@ -19160,9 +19329,9 @@
                 <a:solidFill>
                   <a:srgbClr val="35302B"/>
                 </a:solidFill>
-                <a:latin typeface="Century Gothic" pitchFamily="34" charset="0"/>
-                <a:ea typeface="Century Gothic" pitchFamily="34" charset="-122"/>
-                <a:cs typeface="Century Gothic" pitchFamily="34" charset="-120"/>
+                <a:latin typeface="Corbel" pitchFamily="34" charset="0"/>
+                <a:ea typeface="Corbel" pitchFamily="34" charset="-122"/>
+                <a:cs typeface="Corbel" pitchFamily="34" charset="-120"/>
               </a:rPr>
               <a:t>Prioritise proven prior-season staff</a:t>
             </a:r>
@@ -19181,9 +19350,9 @@
                 <a:solidFill>
                   <a:srgbClr val="35302B"/>
                 </a:solidFill>
-                <a:latin typeface="Century Gothic" pitchFamily="34" charset="0"/>
-                <a:ea typeface="Century Gothic" pitchFamily="34" charset="-122"/>
-                <a:cs typeface="Century Gothic" pitchFamily="34" charset="-120"/>
+                <a:latin typeface="Corbel" pitchFamily="34" charset="0"/>
+                <a:ea typeface="Corbel" pitchFamily="34" charset="-122"/>
+                <a:cs typeface="Corbel" pitchFamily="34" charset="-120"/>
               </a:rPr>
               <a:t>Background verification before deploy</a:t>
             </a:r>
@@ -19202,9 +19371,9 @@
                 <a:solidFill>
                   <a:srgbClr val="35302B"/>
                 </a:solidFill>
-                <a:latin typeface="Century Gothic" pitchFamily="34" charset="0"/>
-                <a:ea typeface="Century Gothic" pitchFamily="34" charset="-122"/>
-                <a:cs typeface="Century Gothic" pitchFamily="34" charset="-120"/>
+                <a:latin typeface="Corbel" pitchFamily="34" charset="0"/>
+                <a:ea typeface="Corbel" pitchFamily="34" charset="-122"/>
+                <a:cs typeface="Corbel" pitchFamily="34" charset="-120"/>
               </a:rPr>
               <a:t>Onboard to payroll, full compliance</a:t>
             </a:r>
@@ -19377,9 +19546,9 @@
                 <a:solidFill>
                   <a:srgbClr val="35302B"/>
                 </a:solidFill>
-                <a:latin typeface="Century Gothic" pitchFamily="34" charset="0"/>
-                <a:ea typeface="Century Gothic" pitchFamily="34" charset="-122"/>
-                <a:cs typeface="Century Gothic" pitchFamily="34" charset="-120"/>
+                <a:latin typeface="Corbel" pitchFamily="34" charset="0"/>
+                <a:ea typeface="Corbel" pitchFamily="34" charset="-122"/>
+                <a:cs typeface="Corbel" pitchFamily="34" charset="-120"/>
               </a:rPr>
               <a:t>100% attendance at Doft's 1-day training</a:t>
             </a:r>
@@ -19398,9 +19567,9 @@
                 <a:solidFill>
                   <a:srgbClr val="35302B"/>
                 </a:solidFill>
-                <a:latin typeface="Century Gothic" pitchFamily="34" charset="0"/>
-                <a:ea typeface="Century Gothic" pitchFamily="34" charset="-122"/>
-                <a:cs typeface="Century Gothic" pitchFamily="34" charset="-120"/>
+                <a:latin typeface="Corbel" pitchFamily="34" charset="0"/>
+                <a:ea typeface="Corbel" pitchFamily="34" charset="-122"/>
+                <a:cs typeface="Corbel" pitchFamily="34" charset="-120"/>
               </a:rPr>
               <a:t>Scheduled 10–21 days before go-live</a:t>
             </a:r>
@@ -19419,9 +19588,9 @@
                 <a:solidFill>
                   <a:srgbClr val="35302B"/>
                 </a:solidFill>
-                <a:latin typeface="Century Gothic" pitchFamily="34" charset="0"/>
-                <a:ea typeface="Century Gothic" pitchFamily="34" charset="-122"/>
-                <a:cs typeface="Century Gothic" pitchFamily="34" charset="-120"/>
+                <a:latin typeface="Corbel" pitchFamily="34" charset="0"/>
+                <a:ea typeface="Corbel" pitchFamily="34" charset="-122"/>
+                <a:cs typeface="Corbel" pitchFamily="34" charset="-120"/>
               </a:rPr>
               <a:t>Completion tracked per candidate</a:t>
             </a:r>
@@ -19440,9 +19609,9 @@
                 <a:solidFill>
                   <a:srgbClr val="35302B"/>
                 </a:solidFill>
-                <a:latin typeface="Century Gothic" pitchFamily="34" charset="0"/>
-                <a:ea typeface="Century Gothic" pitchFamily="34" charset="-122"/>
-                <a:cs typeface="Century Gothic" pitchFamily="34" charset="-120"/>
+                <a:latin typeface="Corbel" pitchFamily="34" charset="0"/>
+                <a:ea typeface="Corbel" pitchFamily="34" charset="-122"/>
+                <a:cs typeface="Corbel" pitchFamily="34" charset="-120"/>
               </a:rPr>
               <a:t>Replacements trained too — always equal</a:t>
             </a:r>
@@ -19615,9 +19784,9 @@
                 <a:solidFill>
                   <a:srgbClr val="35302B"/>
                 </a:solidFill>
-                <a:latin typeface="Century Gothic" pitchFamily="34" charset="0"/>
-                <a:ea typeface="Century Gothic" pitchFamily="34" charset="-122"/>
-                <a:cs typeface="Century Gothic" pitchFamily="34" charset="-120"/>
+                <a:latin typeface="Corbel" pitchFamily="34" charset="0"/>
+                <a:ea typeface="Corbel" pitchFamily="34" charset="-122"/>
+                <a:cs typeface="Corbel" pitchFamily="34" charset="-120"/>
               </a:rPr>
               <a:t>~15% trained bench held per city</a:t>
             </a:r>
@@ -19636,9 +19805,9 @@
                 <a:solidFill>
                   <a:srgbClr val="35302B"/>
                 </a:solidFill>
-                <a:latin typeface="Century Gothic" pitchFamily="34" charset="0"/>
-                <a:ea typeface="Century Gothic" pitchFamily="34" charset="-122"/>
-                <a:cs typeface="Century Gothic" pitchFamily="34" charset="-120"/>
+                <a:latin typeface="Corbel" pitchFamily="34" charset="0"/>
+                <a:ea typeface="Corbel" pitchFamily="34" charset="-122"/>
+                <a:cs typeface="Corbel" pitchFamily="34" charset="-120"/>
               </a:rPr>
               <a:t>Immediate same-day replacement</a:t>
             </a:r>
@@ -19657,9 +19826,9 @@
                 <a:solidFill>
                   <a:srgbClr val="35302B"/>
                 </a:solidFill>
-                <a:latin typeface="Century Gothic" pitchFamily="34" charset="0"/>
-                <a:ea typeface="Century Gothic" pitchFamily="34" charset="-122"/>
-                <a:cs typeface="Century Gothic" pitchFamily="34" charset="-120"/>
+                <a:latin typeface="Corbel" pitchFamily="34" charset="0"/>
+                <a:ea typeface="Corbel" pitchFamily="34" charset="-122"/>
+                <a:cs typeface="Corbel" pitchFamily="34" charset="-120"/>
               </a:rPr>
               <a:t>Attrition covered at no extra cost</a:t>
             </a:r>
@@ -19678,9 +19847,9 @@
                 <a:solidFill>
                   <a:srgbClr val="35302B"/>
                 </a:solidFill>
-                <a:latin typeface="Century Gothic" pitchFamily="34" charset="0"/>
-                <a:ea typeface="Century Gothic" pitchFamily="34" charset="-122"/>
-                <a:cs typeface="Century Gothic" pitchFamily="34" charset="-120"/>
+                <a:latin typeface="Corbel" pitchFamily="34" charset="0"/>
+                <a:ea typeface="Corbel" pitchFamily="34" charset="-122"/>
+                <a:cs typeface="Corbel" pitchFamily="34" charset="-120"/>
               </a:rPr>
               <a:t>Trading never stops for a vacancy</a:t>
             </a:r>
@@ -19739,9 +19908,9 @@
                 <a:solidFill>
                   <a:srgbClr val="FFFFFF"/>
                 </a:solidFill>
-                <a:latin typeface="Century Gothic" pitchFamily="34" charset="0"/>
-                <a:ea typeface="Century Gothic" pitchFamily="34" charset="-122"/>
-                <a:cs typeface="Century Gothic" pitchFamily="34" charset="-120"/>
+                <a:latin typeface="Corbel" pitchFamily="34" charset="0"/>
+                <a:ea typeface="Corbel" pitchFamily="34" charset="-122"/>
+                <a:cs typeface="Corbel" pitchFamily="34" charset="-120"/>
               </a:rPr>
               <a:t>Contractual commitment:  any attrition after training or during operations is replaced immediately with equally-trained staff — at no additional cost to Doft.</a:t>
             </a:r>
@@ -19778,9 +19947,9 @@
                 <a:solidFill>
                   <a:srgbClr val="8C7F72"/>
                 </a:solidFill>
-                <a:latin typeface="Century Gothic" pitchFamily="34" charset="0"/>
-                <a:ea typeface="Century Gothic" pitchFamily="34" charset="-122"/>
-                <a:cs typeface="Century Gothic" pitchFamily="34" charset="-120"/>
+                <a:latin typeface="Corbel" pitchFamily="34" charset="0"/>
+                <a:ea typeface="Corbel" pitchFamily="34" charset="-122"/>
+                <a:cs typeface="Corbel" pitchFamily="34" charset="-120"/>
               </a:rPr>
               <a:t>ProMarcom  ×  Doft Candles</a:t>
             </a:r>
@@ -19888,9 +20057,9 @@
                 <a:solidFill>
                   <a:srgbClr val="B8924A"/>
                 </a:solidFill>
-                <a:latin typeface="Century Gothic" pitchFamily="34" charset="0"/>
-                <a:ea typeface="Century Gothic" pitchFamily="34" charset="-122"/>
-                <a:cs typeface="Century Gothic" pitchFamily="34" charset="-120"/>
+                <a:latin typeface="Corbel" pitchFamily="34" charset="0"/>
+                <a:ea typeface="Corbel" pitchFamily="34" charset="-122"/>
+                <a:cs typeface="Corbel" pitchFamily="34" charset="-120"/>
               </a:rPr>
               <a:t>SETUP</a:t>
             </a:r>
@@ -19945,18 +20114,30 @@
         </p:nvSpPr>
         <p:spPr>
           <a:xfrm>
-            <a:off x="10204704" y="457200"/>
-            <a:ext cx="1417320" cy="384048"/>
+            <a:off x="10140696" y="420624"/>
+            <a:ext cx="1481328" cy="457200"/>
           </a:xfrm>
           <a:prstGeom prst="roundRect">
             <a:avLst>
-              <a:gd name="adj" fmla="val 11905"/>
+              <a:gd name="adj" fmla="val 10000"/>
             </a:avLst>
           </a:prstGeom>
           <a:solidFill>
-            <a:srgbClr val="1C1518"/>
+            <a:srgbClr val="FFFFFF"/>
           </a:solidFill>
-          <a:ln/>
+          <a:ln w="12700">
+            <a:solidFill>
+              <a:srgbClr val="E3D8C7"/>
+            </a:solidFill>
+            <a:prstDash val="solid"/>
+          </a:ln>
+          <a:effectLst>
+            <a:outerShdw sx="100000" sy="100000" kx="0" ky="0" algn="bl" rotWithShape="0" blurRad="50800" dist="12700" dir="5400000">
+              <a:srgbClr val="B8A894">
+                <a:alpha val="35000"/>
+              </a:srgbClr>
+            </a:outerShdw>
+          </a:effectLst>
         </p:spPr>
       </p:sp>
       <p:pic>
@@ -19975,8 +20156,8 @@
         </p:blipFill>
         <p:spPr>
           <a:xfrm>
-            <a:off x="10332720" y="516796"/>
-            <a:ext cx="1161288" cy="264855"/>
+            <a:off x="10259568" y="507412"/>
+            <a:ext cx="1243584" cy="283624"/>
           </a:xfrm>
           <a:prstGeom prst="rect">
             <a:avLst/>
@@ -20137,9 +20318,9 @@
                 <a:solidFill>
                   <a:srgbClr val="35302B"/>
                 </a:solidFill>
-                <a:latin typeface="Century Gothic" pitchFamily="34" charset="0"/>
-                <a:ea typeface="Century Gothic" pitchFamily="34" charset="-122"/>
-                <a:cs typeface="Century Gothic" pitchFamily="34" charset="-120"/>
+                <a:latin typeface="Corbel" pitchFamily="34" charset="0"/>
+                <a:ea typeface="Corbel" pitchFamily="34" charset="-122"/>
+                <a:cs typeface="Corbel" pitchFamily="34" charset="-120"/>
               </a:rPr>
               <a:t>On-site fabrication to Doft-approved design; transport, install, maintain, dismantle &amp; return fixtures — with a 3-day buffer before go-live.</a:t>
             </a:r>
@@ -20301,9 +20482,9 @@
                 <a:solidFill>
                   <a:srgbClr val="35302B"/>
                 </a:solidFill>
-                <a:latin typeface="Century Gothic" pitchFamily="34" charset="0"/>
-                <a:ea typeface="Century Gothic" pitchFamily="34" charset="-122"/>
-                <a:cs typeface="Century Gothic" pitchFamily="34" charset="-120"/>
+                <a:latin typeface="Corbel" pitchFamily="34" charset="0"/>
+                <a:ea typeface="Corbel" pitchFamily="34" charset="-122"/>
+                <a:cs typeface="Corbel" pitchFamily="34" charset="-120"/>
               </a:rPr>
               <a:t>Liaison with mall management; electricity, access passes, loading/unloading and operational approvals.</a:t>
             </a:r>
@@ -20465,9 +20646,9 @@
                 <a:solidFill>
                   <a:srgbClr val="35302B"/>
                 </a:solidFill>
-                <a:latin typeface="Century Gothic" pitchFamily="34" charset="0"/>
-                <a:ea typeface="Century Gothic" pitchFamily="34" charset="-122"/>
-                <a:cs typeface="Century Gothic" pitchFamily="34" charset="-120"/>
+                <a:latin typeface="Corbel" pitchFamily="34" charset="0"/>
+                <a:ea typeface="Corbel" pitchFamily="34" charset="-122"/>
+                <a:cs typeface="Corbel" pitchFamily="34" charset="-120"/>
               </a:rPr>
               <a:t>All permissions, licences and documentation — started at T-7 weeks to de-risk go-live.</a:t>
             </a:r>
@@ -20629,9 +20810,9 @@
                 <a:solidFill>
                   <a:srgbClr val="35302B"/>
                 </a:solidFill>
-                <a:latin typeface="Century Gothic" pitchFamily="34" charset="0"/>
-                <a:ea typeface="Century Gothic" pitchFamily="34" charset="-122"/>
-                <a:cs typeface="Century Gothic" pitchFamily="34" charset="-120"/>
+                <a:latin typeface="Corbel" pitchFamily="34" charset="0"/>
+                <a:ea typeface="Corbel" pitchFamily="34" charset="-122"/>
+                <a:cs typeface="Corbel" pitchFamily="34" charset="-120"/>
               </a:rPr>
               <a:t>Shops &amp; Establishment, GST/e-invoicing, PF/ESIC, insurance, fire &amp; electrical, staff BGV — signed before opening.</a:t>
             </a:r>
@@ -20668,9 +20849,9 @@
                 <a:solidFill>
                   <a:srgbClr val="8C7F72"/>
                 </a:solidFill>
-                <a:latin typeface="Century Gothic" pitchFamily="34" charset="0"/>
-                <a:ea typeface="Century Gothic" pitchFamily="34" charset="-122"/>
-                <a:cs typeface="Century Gothic" pitchFamily="34" charset="-120"/>
+                <a:latin typeface="Corbel" pitchFamily="34" charset="0"/>
+                <a:ea typeface="Corbel" pitchFamily="34" charset="-122"/>
+                <a:cs typeface="Corbel" pitchFamily="34" charset="-120"/>
               </a:rPr>
               <a:t>ProMarcom  ×  Doft Candles</a:t>
             </a:r>

</xml_diff>

<commit_message>
Use original ProMarcom logo (black background) across all deliverables
- Switch logo from transparent to the initial black-background version in the
  PDF deck, PowerPoint deck and Word doc header
- Re-render PDF (verified) and rebuild PPTX + docx

Co-Authored-By: Claude Opus 4.8 <noreply@anthropic.com>
Claude-Session: https://claude.ai/code/session_01SPjFYHW1nTDVr5tUuToRXR
</commit_message>
<xml_diff>
--- a/doft_diwali_popup/Doft_Diwali_PopUp_ProMarcom_Pitch.pptx
+++ b/doft_diwali_popup/Doft_Diwali_PopUp_ProMarcom_Pitch.pptx
@@ -3108,7 +3108,7 @@
       </p:sp>
       <p:pic>
         <p:nvPicPr>
-          <p:cNvPr id="14" name="Image 1" descr="assets/final/promarcom_logo_t.png">    </p:cNvPr>
+          <p:cNvPr id="14" name="Image 1" descr="assets/final/promarcom_logo.png">    </p:cNvPr>
           <p:cNvPicPr>
             <a:picLocks noChangeAspect="1"/>
           </p:cNvPicPr>
@@ -3128,13 +3128,6 @@
           <a:prstGeom prst="rect">
             <a:avLst/>
           </a:prstGeom>
-          <a:effectLst>
-            <a:outerShdw sx="100000" sy="100000" kx="0" ky="0" algn="bl" rotWithShape="0" blurRad="38100" dist="12700" dir="5400000">
-              <a:srgbClr val="8A7A68">
-                <a:alpha val="35000"/>
-              </a:srgbClr>
-            </a:outerShdw>
-          </a:effectLst>
         </p:spPr>
       </p:pic>
     </p:spTree>
@@ -3249,7 +3242,7 @@
       </p:sp>
       <p:pic>
         <p:nvPicPr>
-          <p:cNvPr id="4" name="Image 0" descr="assets/final/promarcom_logo_t.png">    </p:cNvPr>
+          <p:cNvPr id="4" name="Image 0" descr="assets/final/promarcom_logo.png">    </p:cNvPr>
           <p:cNvPicPr>
             <a:picLocks noChangeAspect="1"/>
           </p:cNvPicPr>
@@ -3269,13 +3262,6 @@
           <a:prstGeom prst="rect">
             <a:avLst/>
           </a:prstGeom>
-          <a:effectLst>
-            <a:outerShdw sx="100000" sy="100000" kx="0" ky="0" algn="bl" rotWithShape="0" blurRad="38100" dist="12700" dir="5400000">
-              <a:srgbClr val="8A7A68">
-                <a:alpha val="35000"/>
-              </a:srgbClr>
-            </a:outerShdw>
-          </a:effectLst>
         </p:spPr>
       </p:pic>
       <p:sp>
@@ -4330,7 +4316,7 @@
       </p:sp>
       <p:pic>
         <p:nvPicPr>
-          <p:cNvPr id="4" name="Image 0" descr="assets/final/promarcom_logo_t.png">    </p:cNvPr>
+          <p:cNvPr id="4" name="Image 0" descr="assets/final/promarcom_logo.png">    </p:cNvPr>
           <p:cNvPicPr>
             <a:picLocks noChangeAspect="1"/>
           </p:cNvPicPr>
@@ -4350,13 +4336,6 @@
           <a:prstGeom prst="rect">
             <a:avLst/>
           </a:prstGeom>
-          <a:effectLst>
-            <a:outerShdw sx="100000" sy="100000" kx="0" ky="0" algn="bl" rotWithShape="0" blurRad="38100" dist="12700" dir="5400000">
-              <a:srgbClr val="8A7A68">
-                <a:alpha val="35000"/>
-              </a:srgbClr>
-            </a:outerShdw>
-          </a:effectLst>
         </p:spPr>
       </p:pic>
       <p:sp>
@@ -5530,7 +5509,7 @@
       </p:sp>
       <p:pic>
         <p:nvPicPr>
-          <p:cNvPr id="4" name="Image 0" descr="assets/final/promarcom_logo_t.png">    </p:cNvPr>
+          <p:cNvPr id="4" name="Image 0" descr="assets/final/promarcom_logo.png">    </p:cNvPr>
           <p:cNvPicPr>
             <a:picLocks noChangeAspect="1"/>
           </p:cNvPicPr>
@@ -5550,13 +5529,6 @@
           <a:prstGeom prst="rect">
             <a:avLst/>
           </a:prstGeom>
-          <a:effectLst>
-            <a:outerShdw sx="100000" sy="100000" kx="0" ky="0" algn="bl" rotWithShape="0" blurRad="38100" dist="12700" dir="5400000">
-              <a:srgbClr val="8A7A68">
-                <a:alpha val="35000"/>
-              </a:srgbClr>
-            </a:outerShdw>
-          </a:effectLst>
         </p:spPr>
       </p:pic>
       <p:sp>
@@ -7764,7 +7736,7 @@
       </p:sp>
       <p:pic>
         <p:nvPicPr>
-          <p:cNvPr id="4" name="Image 0" descr="assets/final/promarcom_logo_t.png">    </p:cNvPr>
+          <p:cNvPr id="4" name="Image 0" descr="assets/final/promarcom_logo.png">    </p:cNvPr>
           <p:cNvPicPr>
             <a:picLocks noChangeAspect="1"/>
           </p:cNvPicPr>
@@ -7784,13 +7756,6 @@
           <a:prstGeom prst="rect">
             <a:avLst/>
           </a:prstGeom>
-          <a:effectLst>
-            <a:outerShdw sx="100000" sy="100000" kx="0" ky="0" algn="bl" rotWithShape="0" blurRad="38100" dist="12700" dir="5400000">
-              <a:srgbClr val="8A7A68">
-                <a:alpha val="35000"/>
-              </a:srgbClr>
-            </a:outerShdw>
-          </a:effectLst>
         </p:spPr>
       </p:pic>
       <p:sp>
@@ -8707,7 +8672,7 @@
       </p:sp>
       <p:pic>
         <p:nvPicPr>
-          <p:cNvPr id="4" name="Image 0" descr="assets/final/promarcom_logo_t.png">    </p:cNvPr>
+          <p:cNvPr id="4" name="Image 0" descr="assets/final/promarcom_logo.png">    </p:cNvPr>
           <p:cNvPicPr>
             <a:picLocks noChangeAspect="1"/>
           </p:cNvPicPr>
@@ -8727,13 +8692,6 @@
           <a:prstGeom prst="rect">
             <a:avLst/>
           </a:prstGeom>
-          <a:effectLst>
-            <a:outerShdw sx="100000" sy="100000" kx="0" ky="0" algn="bl" rotWithShape="0" blurRad="38100" dist="12700" dir="5400000">
-              <a:srgbClr val="8A7A68">
-                <a:alpha val="35000"/>
-              </a:srgbClr>
-            </a:outerShdw>
-          </a:effectLst>
         </p:spPr>
       </p:pic>
       <p:sp>
@@ -9559,7 +9517,7 @@
       </p:sp>
       <p:pic>
         <p:nvPicPr>
-          <p:cNvPr id="4" name="Image 0" descr="assets/final/promarcom_logo_t.png">    </p:cNvPr>
+          <p:cNvPr id="4" name="Image 0" descr="assets/final/promarcom_logo.png">    </p:cNvPr>
           <p:cNvPicPr>
             <a:picLocks noChangeAspect="1"/>
           </p:cNvPicPr>
@@ -9579,13 +9537,6 @@
           <a:prstGeom prst="rect">
             <a:avLst/>
           </a:prstGeom>
-          <a:effectLst>
-            <a:outerShdw sx="100000" sy="100000" kx="0" ky="0" algn="bl" rotWithShape="0" blurRad="38100" dist="12700" dir="5400000">
-              <a:srgbClr val="8A7A68">
-                <a:alpha val="35000"/>
-              </a:srgbClr>
-            </a:outerShdw>
-          </a:effectLst>
         </p:spPr>
       </p:pic>
       <p:sp>
@@ -11289,7 +11240,7 @@
       </p:sp>
       <p:pic>
         <p:nvPicPr>
-          <p:cNvPr id="8" name="Image 1" descr="assets/final/promarcom_logo_t.png">    </p:cNvPr>
+          <p:cNvPr id="8" name="Image 1" descr="assets/final/promarcom_logo.png">    </p:cNvPr>
           <p:cNvPicPr>
             <a:picLocks noChangeAspect="1"/>
           </p:cNvPicPr>
@@ -11803,7 +11754,7 @@
       </p:sp>
       <p:pic>
         <p:nvPicPr>
-          <p:cNvPr id="4" name="Image 0" descr="assets/final/promarcom_logo_t.png">    </p:cNvPr>
+          <p:cNvPr id="4" name="Image 0" descr="assets/final/promarcom_logo.png">    </p:cNvPr>
           <p:cNvPicPr>
             <a:picLocks noChangeAspect="1"/>
           </p:cNvPicPr>
@@ -11823,13 +11774,6 @@
           <a:prstGeom prst="rect">
             <a:avLst/>
           </a:prstGeom>
-          <a:effectLst>
-            <a:outerShdw sx="100000" sy="100000" kx="0" ky="0" algn="bl" rotWithShape="0" blurRad="38100" dist="12700" dir="5400000">
-              <a:srgbClr val="8A7A68">
-                <a:alpha val="35000"/>
-              </a:srgbClr>
-            </a:outerShdw>
-          </a:effectLst>
         </p:spPr>
       </p:pic>
       <p:sp>
@@ -13756,7 +13700,7 @@
       </p:sp>
       <p:pic>
         <p:nvPicPr>
-          <p:cNvPr id="4" name="Image 0" descr="assets/final/promarcom_logo_t.png">    </p:cNvPr>
+          <p:cNvPr id="4" name="Image 0" descr="assets/final/promarcom_logo.png">    </p:cNvPr>
           <p:cNvPicPr>
             <a:picLocks noChangeAspect="1"/>
           </p:cNvPicPr>
@@ -13776,13 +13720,6 @@
           <a:prstGeom prst="rect">
             <a:avLst/>
           </a:prstGeom>
-          <a:effectLst>
-            <a:outerShdw sx="100000" sy="100000" kx="0" ky="0" algn="bl" rotWithShape="0" blurRad="38100" dist="12700" dir="5400000">
-              <a:srgbClr val="8A7A68">
-                <a:alpha val="35000"/>
-              </a:srgbClr>
-            </a:outerShdw>
-          </a:effectLst>
         </p:spPr>
       </p:pic>
       <p:sp>
@@ -15293,7 +15230,7 @@
       </p:sp>
       <p:pic>
         <p:nvPicPr>
-          <p:cNvPr id="4" name="Image 0" descr="assets/final/promarcom_logo_t.png">    </p:cNvPr>
+          <p:cNvPr id="4" name="Image 0" descr="assets/final/promarcom_logo.png">    </p:cNvPr>
           <p:cNvPicPr>
             <a:picLocks noChangeAspect="1"/>
           </p:cNvPicPr>
@@ -15313,13 +15250,6 @@
           <a:prstGeom prst="rect">
             <a:avLst/>
           </a:prstGeom>
-          <a:effectLst>
-            <a:outerShdw sx="100000" sy="100000" kx="0" ky="0" algn="bl" rotWithShape="0" blurRad="38100" dist="12700" dir="5400000">
-              <a:srgbClr val="8A7A68">
-                <a:alpha val="35000"/>
-              </a:srgbClr>
-            </a:outerShdw>
-          </a:effectLst>
         </p:spPr>
       </p:pic>
       <p:sp>
@@ -16100,7 +16030,7 @@
       </p:sp>
       <p:pic>
         <p:nvPicPr>
-          <p:cNvPr id="4" name="Image 0" descr="assets/final/promarcom_logo_t.png">    </p:cNvPr>
+          <p:cNvPr id="4" name="Image 0" descr="assets/final/promarcom_logo.png">    </p:cNvPr>
           <p:cNvPicPr>
             <a:picLocks noChangeAspect="1"/>
           </p:cNvPicPr>
@@ -16120,13 +16050,6 @@
           <a:prstGeom prst="rect">
             <a:avLst/>
           </a:prstGeom>
-          <a:effectLst>
-            <a:outerShdw sx="100000" sy="100000" kx="0" ky="0" algn="bl" rotWithShape="0" blurRad="38100" dist="12700" dir="5400000">
-              <a:srgbClr val="8A7A68">
-                <a:alpha val="35000"/>
-              </a:srgbClr>
-            </a:outerShdw>
-          </a:effectLst>
         </p:spPr>
       </p:pic>
       <p:sp>
@@ -17415,7 +17338,7 @@
       </p:sp>
       <p:pic>
         <p:nvPicPr>
-          <p:cNvPr id="4" name="Image 0" descr="assets/final/promarcom_logo_t.png">    </p:cNvPr>
+          <p:cNvPr id="4" name="Image 0" descr="assets/final/promarcom_logo.png">    </p:cNvPr>
           <p:cNvPicPr>
             <a:picLocks noChangeAspect="1"/>
           </p:cNvPicPr>
@@ -17435,13 +17358,6 @@
           <a:prstGeom prst="rect">
             <a:avLst/>
           </a:prstGeom>
-          <a:effectLst>
-            <a:outerShdw sx="100000" sy="100000" kx="0" ky="0" algn="bl" rotWithShape="0" blurRad="38100" dist="12700" dir="5400000">
-              <a:srgbClr val="8A7A68">
-                <a:alpha val="35000"/>
-              </a:srgbClr>
-            </a:outerShdw>
-          </a:effectLst>
         </p:spPr>
       </p:pic>
       <p:sp>
@@ -18779,7 +18695,7 @@
       </p:sp>
       <p:pic>
         <p:nvPicPr>
-          <p:cNvPr id="4" name="Image 0" descr="assets/final/promarcom_logo_t.png">    </p:cNvPr>
+          <p:cNvPr id="4" name="Image 0" descr="assets/final/promarcom_logo.png">    </p:cNvPr>
           <p:cNvPicPr>
             <a:picLocks noChangeAspect="1"/>
           </p:cNvPicPr>
@@ -18799,13 +18715,6 @@
           <a:prstGeom prst="rect">
             <a:avLst/>
           </a:prstGeom>
-          <a:effectLst>
-            <a:outerShdw sx="100000" sy="100000" kx="0" ky="0" algn="bl" rotWithShape="0" blurRad="38100" dist="12700" dir="5400000">
-              <a:srgbClr val="8A7A68">
-                <a:alpha val="35000"/>
-              </a:srgbClr>
-            </a:outerShdw>
-          </a:effectLst>
         </p:spPr>
       </p:pic>
       <p:sp>
@@ -19773,7 +19682,7 @@
       </p:sp>
       <p:pic>
         <p:nvPicPr>
-          <p:cNvPr id="4" name="Image 0" descr="assets/final/promarcom_logo_t.png">    </p:cNvPr>
+          <p:cNvPr id="4" name="Image 0" descr="assets/final/promarcom_logo.png">    </p:cNvPr>
           <p:cNvPicPr>
             <a:picLocks noChangeAspect="1"/>
           </p:cNvPicPr>
@@ -19793,13 +19702,6 @@
           <a:prstGeom prst="rect">
             <a:avLst/>
           </a:prstGeom>
-          <a:effectLst>
-            <a:outerShdw sx="100000" sy="100000" kx="0" ky="0" algn="bl" rotWithShape="0" blurRad="38100" dist="12700" dir="5400000">
-              <a:srgbClr val="8A7A68">
-                <a:alpha val="35000"/>
-              </a:srgbClr>
-            </a:outerShdw>
-          </a:effectLst>
         </p:spPr>
       </p:pic>
       <p:sp>

</xml_diff>